<commit_message>
Align SuperCheap pitch deck with product brand
</commit_message>
<xml_diff>
--- a/pitch/supercheap.market.pptx
+++ b/pitch/supercheap.market.pptx
@@ -2,24 +2,24 @@
 <file path=ppt/presentation.xml><?xml version="1.0" encoding="utf-8"?>
 <p:presentation xmlns:p="http://schemas.openxmlformats.org/presentationml/2006/main">
   <p:sldMasterIdLst>
-    <p:sldMasterId xmlns:r="http://schemas.openxmlformats.org/officeDocument/2006/relationships" id="2147483648" r:id="R35d6fe1b07944ce3"/>
+    <p:sldMasterId xmlns:r="http://schemas.openxmlformats.org/officeDocument/2006/relationships" id="2147483648" r:id="Re52a6f5b920a49f8"/>
   </p:sldMasterIdLst>
   <p:notesMasterIdLst>
-    <p:notesMasterId xmlns:r="http://schemas.openxmlformats.org/officeDocument/2006/relationships" r:id="R2fded07cd5bc4888"/>
+    <p:notesMasterId xmlns:r="http://schemas.openxmlformats.org/officeDocument/2006/relationships" r:id="R0422dae34d5d41fd"/>
   </p:notesMasterIdLst>
   <p:sldIdLst>
-    <p:sldId xmlns:r="http://schemas.openxmlformats.org/officeDocument/2006/relationships" id="256" r:id="R09f531d533c342cb"/>
-    <p:sldId xmlns:r="http://schemas.openxmlformats.org/officeDocument/2006/relationships" id="257" r:id="Radeb8baf32aa4e3a"/>
-    <p:sldId xmlns:r="http://schemas.openxmlformats.org/officeDocument/2006/relationships" id="258" r:id="Rdea2c2135f3b4ada"/>
-    <p:sldId xmlns:r="http://schemas.openxmlformats.org/officeDocument/2006/relationships" id="259" r:id="Rdc6c2cca52cb4caa"/>
-    <p:sldId xmlns:r="http://schemas.openxmlformats.org/officeDocument/2006/relationships" id="260" r:id="Rbdc2b96818dc46b6"/>
-    <p:sldId xmlns:r="http://schemas.openxmlformats.org/officeDocument/2006/relationships" id="261" r:id="Rac3a9819eb564275"/>
-    <p:sldId xmlns:r="http://schemas.openxmlformats.org/officeDocument/2006/relationships" id="262" r:id="Rf2a5551770034a10"/>
-    <p:sldId xmlns:r="http://schemas.openxmlformats.org/officeDocument/2006/relationships" id="263" r:id="R7050c194e9204d7c"/>
-    <p:sldId xmlns:r="http://schemas.openxmlformats.org/officeDocument/2006/relationships" id="264" r:id="R4cc5588b827640f7"/>
-    <p:sldId xmlns:r="http://schemas.openxmlformats.org/officeDocument/2006/relationships" id="265" r:id="R171a75eb4d3e4bf5"/>
-    <p:sldId xmlns:r="http://schemas.openxmlformats.org/officeDocument/2006/relationships" id="266" r:id="R491652df18a84a87"/>
-    <p:sldId xmlns:r="http://schemas.openxmlformats.org/officeDocument/2006/relationships" id="267" r:id="R0e62b1e671314aa9"/>
+    <p:sldId xmlns:r="http://schemas.openxmlformats.org/officeDocument/2006/relationships" id="256" r:id="Rd206ee0c2935424f"/>
+    <p:sldId xmlns:r="http://schemas.openxmlformats.org/officeDocument/2006/relationships" id="257" r:id="R1e09785dce364ef3"/>
+    <p:sldId xmlns:r="http://schemas.openxmlformats.org/officeDocument/2006/relationships" id="258" r:id="Rc43b97442d994e0b"/>
+    <p:sldId xmlns:r="http://schemas.openxmlformats.org/officeDocument/2006/relationships" id="259" r:id="R5035a46671c74a2f"/>
+    <p:sldId xmlns:r="http://schemas.openxmlformats.org/officeDocument/2006/relationships" id="260" r:id="Re31b17a5117a4b70"/>
+    <p:sldId xmlns:r="http://schemas.openxmlformats.org/officeDocument/2006/relationships" id="261" r:id="Re737e4dfa5a946f8"/>
+    <p:sldId xmlns:r="http://schemas.openxmlformats.org/officeDocument/2006/relationships" id="262" r:id="Ra5695431bcda4aef"/>
+    <p:sldId xmlns:r="http://schemas.openxmlformats.org/officeDocument/2006/relationships" id="263" r:id="R62f31a6504f24367"/>
+    <p:sldId xmlns:r="http://schemas.openxmlformats.org/officeDocument/2006/relationships" id="264" r:id="Rc2586edb37664b22"/>
+    <p:sldId xmlns:r="http://schemas.openxmlformats.org/officeDocument/2006/relationships" id="265" r:id="R1fd5cd6d3a0b4510"/>
+    <p:sldId xmlns:r="http://schemas.openxmlformats.org/officeDocument/2006/relationships" id="266" r:id="R828e66dff9284bef"/>
+    <p:sldId xmlns:r="http://schemas.openxmlformats.org/officeDocument/2006/relationships" id="267" r:id="Rf04dd785c1284633"/>
   </p:sldIdLst>
   <p:sldSz cx="12192000" cy="6858000"/>
   <p:notesSz cx="6858000" cy="9144000"/>
@@ -1343,7 +1343,7 @@
   </p:cSld>
   <p:clrMap bg1="lt1" tx1="dk1" bg2="lt2" tx2="dk2" accent1="accent1" accent2="accent2" accent3="accent3" accent4="accent4" accent5="accent5" accent6="accent6" hlink="hlink" folHlink="folHlink"/>
   <p:sldLayoutIdLst>
-    <p:sldLayoutId xmlns:r="http://schemas.openxmlformats.org/officeDocument/2006/relationships" id="2147483649" r:id="Rf62fa9c733c84146"/>
+    <p:sldLayoutId xmlns:r="http://schemas.openxmlformats.org/officeDocument/2006/relationships" id="2147483649" r:id="R872b9e6e6e6d43c6"/>
   </p:sldLayoutIdLst>
   <p:hf sldNum="0" hdr="0" ftr="0" dt="0"/>
   <p:txStyles>
@@ -1896,7 +1896,7 @@
     <p:bg>
       <p:bgPr>
         <a:solidFill xmlns:a="http://schemas.openxmlformats.org/drawingml/2006/main">
-          <a:srgbClr val="141B34"/>
+          <a:srgbClr val="FFFFFF"/>
         </a:solidFill>
       </p:bgPr>
     </p:bg>
@@ -1932,7 +1932,7 @@
             <a:avLst/>
           </a:prstGeom>
           <a:solidFill xmlns:a="http://schemas.openxmlformats.org/drawingml/2006/main">
-            <a:srgbClr val="1E2747"/>
+            <a:srgbClr val="EDFFD4"/>
           </a:solidFill>
         </p:spPr>
       </p:sp>
@@ -1952,62 +1952,35 @@
         </p:nvSpPr>
         <p:spPr>
           <a:xfrm xmlns:a="http://schemas.openxmlformats.org/drawingml/2006/main">
-            <a:off x="10881360" y="4297680"/>
+            <a:off x="10881360" y="4714875"/>
             <a:ext cx="2926080" cy="2926080"/>
           </a:xfrm>
           <a:prstGeom xmlns:a="http://schemas.openxmlformats.org/drawingml/2006/main" prst="ellipse">
             <a:avLst/>
           </a:prstGeom>
           <a:solidFill xmlns:a="http://schemas.openxmlformats.org/drawingml/2006/main">
-            <a:srgbClr val="1E2747"/>
+            <a:srgbClr val="EDFFD4"/>
           </a:solidFill>
         </p:spPr>
       </p:sp>
       <p:sp>
         <p:nvSpPr>
-          <p:cNvPr id="4" name="Shape 2">
-            <a:extLst xmlns:a="http://schemas.openxmlformats.org/drawingml/2006/main">
-              <a:ext uri="{FF2B5EF4-FFF2-40B4-BE49-F238E27FC236}">
-                <a16:creationId xmlns:a16="http://schemas.microsoft.com/office/drawing/2014/main" id="{6DC17E61-9B61-49B9-B98E-C5910A5AA0EF}"/>
-              </a:ext>
-            </a:extLst>
-          </p:cNvPr>
-          <p:cNvSpPr>
-            <a:spLocks xmlns:a="http://schemas.openxmlformats.org/drawingml/2006/main" noGrp="1"/>
-          </p:cNvSpPr>
-          <p:nvPr/>
-        </p:nvSpPr>
-        <p:spPr>
-          <a:xfrm xmlns:a="http://schemas.openxmlformats.org/drawingml/2006/main">
-            <a:off x="640080" y="1051560"/>
-            <a:ext cx="310896" cy="310896"/>
-          </a:xfrm>
-          <a:prstGeom xmlns:a="http://schemas.openxmlformats.org/drawingml/2006/main" prst="ellipse">
-            <a:avLst/>
-          </a:prstGeom>
-          <a:solidFill xmlns:a="http://schemas.openxmlformats.org/drawingml/2006/main">
-            <a:srgbClr val="FF5A6E"/>
-          </a:solidFill>
-        </p:spPr>
-      </p:sp>
-      <p:sp>
-        <p:nvSpPr>
-          <p:cNvPr id="5" name="Text 3">
-            <a:extLst xmlns:a="http://schemas.openxmlformats.org/drawingml/2006/main">
-              <a:ext uri="{FF2B5EF4-FFF2-40B4-BE49-F238E27FC236}">
-                <a16:creationId xmlns:a16="http://schemas.microsoft.com/office/drawing/2014/main" id="{17B8EE30-0557-4BF7-9E25-B22BA964CB17}"/>
-              </a:ext>
-            </a:extLst>
-          </p:cNvPr>
-          <p:cNvSpPr>
-            <a:spLocks xmlns:a="http://schemas.openxmlformats.org/drawingml/2006/main" noGrp="1"/>
-          </p:cNvSpPr>
-          <p:nvPr/>
-        </p:nvSpPr>
-        <p:spPr>
-          <a:xfrm xmlns:a="http://schemas.openxmlformats.org/drawingml/2006/main">
-            <a:off x="640080" y="1371600"/>
-            <a:ext cx="7315200" cy="1280160"/>
+          <p:cNvPr id="6" name="Text 4">
+            <a:extLst xmlns:a="http://schemas.openxmlformats.org/drawingml/2006/main">
+              <a:ext uri="{FF2B5EF4-FFF2-40B4-BE49-F238E27FC236}">
+                <a16:creationId xmlns:a16="http://schemas.microsoft.com/office/drawing/2014/main" id="{7177148D-E838-433B-B9D4-11DBD5ED5F45}"/>
+              </a:ext>
+            </a:extLst>
+          </p:cNvPr>
+          <p:cNvSpPr>
+            <a:spLocks xmlns:a="http://schemas.openxmlformats.org/drawingml/2006/main" noGrp="1"/>
+          </p:cNvSpPr>
+          <p:nvPr/>
+        </p:nvSpPr>
+        <p:spPr>
+          <a:xfrm xmlns:a="http://schemas.openxmlformats.org/drawingml/2006/main">
+            <a:off x="658368" y="3028950"/>
+            <a:ext cx="3657600" cy="320040"/>
           </a:xfrm>
           <a:prstGeom xmlns:a="http://schemas.openxmlformats.org/drawingml/2006/main" prst="rect">
             <a:avLst/>
@@ -2022,55 +1995,9 @@
               <a:buNone/>
             </a:pPr>
             <a:r>
-              <a:rPr sz="7600" b="1">
-                <a:solidFill>
-                  <a:srgbClr val="FFFFFF"/>
-                </a:solidFill>
-                <a:latin typeface="Cambria"/>
-                <a:ea typeface="Cambria"/>
-                <a:cs typeface="Cambria"/>
-              </a:rPr>
-              <a:t>SuperCheap</a:t>
-            </a:r>
-            <a:endParaRPr sz="7600"/>
-          </a:p>
-        </p:txBody>
-      </p:sp>
-      <p:sp>
-        <p:nvSpPr>
-          <p:cNvPr id="6" name="Text 4">
-            <a:extLst xmlns:a="http://schemas.openxmlformats.org/drawingml/2006/main">
-              <a:ext uri="{FF2B5EF4-FFF2-40B4-BE49-F238E27FC236}">
-                <a16:creationId xmlns:a16="http://schemas.microsoft.com/office/drawing/2014/main" id="{7177148D-E838-433B-B9D4-11DBD5ED5F45}"/>
-              </a:ext>
-            </a:extLst>
-          </p:cNvPr>
-          <p:cNvSpPr>
-            <a:spLocks xmlns:a="http://schemas.openxmlformats.org/drawingml/2006/main" noGrp="1"/>
-          </p:cNvSpPr>
-          <p:nvPr/>
-        </p:nvSpPr>
-        <p:spPr>
-          <a:xfrm xmlns:a="http://schemas.openxmlformats.org/drawingml/2006/main">
-            <a:off x="658368" y="2606040"/>
-            <a:ext cx="3657600" cy="320040"/>
-          </a:xfrm>
-          <a:prstGeom xmlns:a="http://schemas.openxmlformats.org/drawingml/2006/main" prst="rect">
-            <a:avLst/>
-          </a:prstGeom>
-          <a:noFill xmlns:a="http://schemas.openxmlformats.org/drawingml/2006/main"/>
-        </p:spPr>
-        <p:txBody>
-          <a:bodyPr xmlns:a="http://schemas.openxmlformats.org/drawingml/2006/main" wrap="square" lIns="0" tIns="0" rIns="0" bIns="0" anchor="ctr"/>
-          <a:lstStyle xmlns:a="http://schemas.openxmlformats.org/drawingml/2006/main"/>
-          <a:p xmlns:a="http://schemas.openxmlformats.org/drawingml/2006/main">
-            <a:pPr marL="0" indent="0">
-              <a:buNone/>
-            </a:pPr>
-            <a:r>
               <a:rPr sz="1300" i="1">
                 <a:solidFill>
-                  <a:srgbClr val="FF8494"/>
+                  <a:srgbClr val="356B15"/>
                 </a:solidFill>
                 <a:latin typeface="Arial"/>
                 <a:ea typeface="Arial"/>
@@ -2098,7 +2025,7 @@
         </p:nvSpPr>
         <p:spPr>
           <a:xfrm xmlns:a="http://schemas.openxmlformats.org/drawingml/2006/main">
-            <a:off x="640080" y="3154680"/>
+            <a:off x="640080" y="3476625"/>
             <a:ext cx="7955280" cy="914400"/>
           </a:xfrm>
           <a:prstGeom xmlns:a="http://schemas.openxmlformats.org/drawingml/2006/main" prst="rect">
@@ -2119,11 +2046,11 @@
             <a:r>
               <a:rPr sz="2300">
                 <a:solidFill>
-                  <a:srgbClr val="CBD5F0"/>
-                </a:solidFill>
-                <a:latin typeface="Cambria"/>
-                <a:ea typeface="Cambria"/>
-                <a:cs typeface="Cambria"/>
+                  <a:srgbClr val="626262"/>
+                </a:solidFill>
+                <a:latin typeface="Arial"/>
+                <a:ea typeface="Arial"/>
+                <a:cs typeface="Arial"/>
               </a:rPr>
               <a:t>The affordable, stylish, factory-direct shopping app for young women who shop from the feed.</a:t>
             </a:r>
@@ -2147,7 +2074,7 @@
         </p:nvSpPr>
         <p:spPr>
           <a:xfrm xmlns:a="http://schemas.openxmlformats.org/drawingml/2006/main">
-            <a:off x="640080" y="4343400"/>
+            <a:off x="640080" y="4714875"/>
             <a:ext cx="1993392" cy="402336"/>
           </a:xfrm>
           <a:prstGeom xmlns:a="http://schemas.openxmlformats.org/drawingml/2006/main" prst="roundRect">
@@ -2156,7 +2083,7 @@
             </a:avLst>
           </a:prstGeom>
           <a:solidFill xmlns:a="http://schemas.openxmlformats.org/drawingml/2006/main">
-            <a:srgbClr val="1E2747"/>
+            <a:srgbClr val="EDFFD4"/>
           </a:solidFill>
           <a:ln xmlns:a="http://schemas.openxmlformats.org/drawingml/2006/main" w="12700">
             <a:solidFill>
@@ -2182,7 +2109,7 @@
         </p:nvSpPr>
         <p:spPr>
           <a:xfrm xmlns:a="http://schemas.openxmlformats.org/drawingml/2006/main">
-            <a:off x="640080" y="4343400"/>
+            <a:off x="640080" y="4714875"/>
             <a:ext cx="1993392" cy="402336"/>
           </a:xfrm>
           <a:prstGeom xmlns:a="http://schemas.openxmlformats.org/drawingml/2006/main" prst="rect">
@@ -2200,7 +2127,7 @@
             <a:r>
               <a:rPr sz="1150">
                 <a:solidFill>
-                  <a:srgbClr val="CBD5F0"/>
+                  <a:srgbClr val="626262"/>
                 </a:solidFill>
                 <a:latin typeface="Arial"/>
                 <a:ea typeface="Arial"/>
@@ -2228,7 +2155,7 @@
         </p:nvSpPr>
         <p:spPr>
           <a:xfrm xmlns:a="http://schemas.openxmlformats.org/drawingml/2006/main">
-            <a:off x="2862072" y="4343400"/>
+            <a:off x="2862072" y="4714875"/>
             <a:ext cx="2414016" cy="402336"/>
           </a:xfrm>
           <a:prstGeom xmlns:a="http://schemas.openxmlformats.org/drawingml/2006/main" prst="roundRect">
@@ -2237,7 +2164,7 @@
             </a:avLst>
           </a:prstGeom>
           <a:solidFill xmlns:a="http://schemas.openxmlformats.org/drawingml/2006/main">
-            <a:srgbClr val="1E2747"/>
+            <a:srgbClr val="EDFFD4"/>
           </a:solidFill>
           <a:ln xmlns:a="http://schemas.openxmlformats.org/drawingml/2006/main" w="12700">
             <a:solidFill>
@@ -2263,7 +2190,7 @@
         </p:nvSpPr>
         <p:spPr>
           <a:xfrm xmlns:a="http://schemas.openxmlformats.org/drawingml/2006/main">
-            <a:off x="2862072" y="4343400"/>
+            <a:off x="2862072" y="4714875"/>
             <a:ext cx="2414016" cy="402336"/>
           </a:xfrm>
           <a:prstGeom xmlns:a="http://schemas.openxmlformats.org/drawingml/2006/main" prst="rect">
@@ -2281,7 +2208,7 @@
             <a:r>
               <a:rPr sz="1150">
                 <a:solidFill>
-                  <a:srgbClr val="CBD5F0"/>
+                  <a:srgbClr val="626262"/>
                 </a:solidFill>
                 <a:latin typeface="Arial"/>
                 <a:ea typeface="Arial"/>
@@ -2309,7 +2236,7 @@
         </p:nvSpPr>
         <p:spPr>
           <a:xfrm xmlns:a="http://schemas.openxmlformats.org/drawingml/2006/main">
-            <a:off x="5504688" y="4343400"/>
+            <a:off x="5504688" y="4714875"/>
             <a:ext cx="2834640" cy="402336"/>
           </a:xfrm>
           <a:prstGeom xmlns:a="http://schemas.openxmlformats.org/drawingml/2006/main" prst="roundRect">
@@ -2318,7 +2245,7 @@
             </a:avLst>
           </a:prstGeom>
           <a:solidFill xmlns:a="http://schemas.openxmlformats.org/drawingml/2006/main">
-            <a:srgbClr val="1E2747"/>
+            <a:srgbClr val="EDFFD4"/>
           </a:solidFill>
           <a:ln xmlns:a="http://schemas.openxmlformats.org/drawingml/2006/main" w="12700">
             <a:solidFill>
@@ -2344,7 +2271,7 @@
         </p:nvSpPr>
         <p:spPr>
           <a:xfrm xmlns:a="http://schemas.openxmlformats.org/drawingml/2006/main">
-            <a:off x="5504688" y="4343400"/>
+            <a:off x="5504688" y="4714875"/>
             <a:ext cx="2834640" cy="402336"/>
           </a:xfrm>
           <a:prstGeom xmlns:a="http://schemas.openxmlformats.org/drawingml/2006/main" prst="rect">
@@ -2362,7 +2289,7 @@
             <a:r>
               <a:rPr sz="1150">
                 <a:solidFill>
-                  <a:srgbClr val="CBD5F0"/>
+                  <a:srgbClr val="626262"/>
                 </a:solidFill>
                 <a:latin typeface="Arial"/>
                 <a:ea typeface="Arial"/>
@@ -2408,7 +2335,7 @@
             <a:r>
               <a:rPr sz="1300" b="1">
                 <a:solidFill>
-                  <a:srgbClr val="FFFFFF"/>
+                  <a:srgbClr val="171717"/>
                 </a:solidFill>
                 <a:latin typeface="Arial"/>
                 <a:ea typeface="Arial"/>
@@ -2419,7 +2346,7 @@
             <a:r>
               <a:rPr sz="1300">
                 <a:solidFill>
-                  <a:srgbClr val="9AA3B2"/>
+                  <a:srgbClr val="171717"/>
                 </a:solidFill>
                 <a:latin typeface="Arial"/>
                 <a:ea typeface="Arial"/>
@@ -2431,6 +2358,56 @@
           </a:p>
         </p:txBody>
       </p:sp>
+      <p:pic>
+        <p:nvPicPr>
+          <p:cNvPr id="28" name=""/>
+          <p:cNvPicPr>
+            <a:picLocks xmlns:a="http://schemas.openxmlformats.org/drawingml/2006/main" noChangeAspect="1"/>
+          </p:cNvPicPr>
+          <p:nvPr/>
+        </p:nvPicPr>
+        <p:blipFill>
+          <a:blip xmlns:r="http://schemas.openxmlformats.org/officeDocument/2006/relationships" xmlns:a="http://schemas.openxmlformats.org/drawingml/2006/main" r:embed="Rcdc4df2fa0c849c0"/>
+          <a:stretch xmlns:a="http://schemas.openxmlformats.org/drawingml/2006/main"/>
+        </p:blipFill>
+        <p:spPr>
+          <a:xfrm xmlns:a="http://schemas.openxmlformats.org/drawingml/2006/main">
+            <a:off x="640080" y="1333500"/>
+            <a:ext cx="4572000" cy="1524000"/>
+          </a:xfrm>
+          <a:prstGeom xmlns:a="http://schemas.openxmlformats.org/drawingml/2006/main" prst="rect">
+            <a:avLst/>
+          </a:prstGeom>
+        </p:spPr>
+      </p:pic>
+      <p:pic>
+        <p:nvPicPr>
+          <p:cNvPr id="29" name=""/>
+          <p:cNvPicPr>
+            <a:picLocks xmlns:a="http://schemas.openxmlformats.org/drawingml/2006/main" noChangeAspect="1"/>
+          </p:cNvPicPr>
+          <p:nvPr/>
+        </p:nvPicPr>
+        <p:blipFill>
+          <a:blip xmlns:r="http://schemas.openxmlformats.org/officeDocument/2006/relationships" xmlns:a="http://schemas.openxmlformats.org/drawingml/2006/main" r:embed="R0c24cbda5e77485d">
+            <a:extLst>
+              <a:ext uri="{96DAC541-7B7A-43D3-8B79-37D633B846F1}">
+                <asvg:svgBlip xmlns:asvg="http://schemas.microsoft.com/office/drawing/2016/SVG/main" r:embed="R48b3d6fa390545fe"/>
+              </a:ext>
+            </a:extLst>
+          </a:blip>
+          <a:stretch xmlns:a="http://schemas.openxmlformats.org/drawingml/2006/main"/>
+        </p:blipFill>
+        <p:spPr>
+          <a:xfrm xmlns:a="http://schemas.openxmlformats.org/drawingml/2006/main">
+            <a:off x="640080" y="1051560"/>
+            <a:ext cx="310896" cy="310896"/>
+          </a:xfrm>
+          <a:prstGeom xmlns:a="http://schemas.openxmlformats.org/drawingml/2006/main" prst="rect">
+            <a:avLst/>
+          </a:prstGeom>
+        </p:spPr>
+      </p:pic>
     </p:spTree>
     <p:extLst>
       <p:ext uri="{BB962C8B-B14F-4D97-AF65-F5344CB8AC3E}">
@@ -2447,7 +2424,7 @@
     <p:bg>
       <p:bgPr>
         <a:solidFill xmlns:a="http://schemas.openxmlformats.org/drawingml/2006/main">
-          <a:srgbClr val="F7F5F2"/>
+          <a:srgbClr val="FFFFFF"/>
         </a:solidFill>
       </p:bgPr>
     </p:bg>
@@ -2494,7 +2471,7 @@
             <a:r>
               <a:rPr sz="1200" b="1" spc="300">
                 <a:solidFill>
-                  <a:srgbClr val="FF5A6E"/>
+                  <a:srgbClr val="356B15"/>
                 </a:solidFill>
                 <a:latin typeface="Arial"/>
                 <a:ea typeface="Arial"/>
@@ -2543,11 +2520,11 @@
             <a:r>
               <a:rPr sz="3200" b="1">
                 <a:solidFill>
-                  <a:srgbClr val="1A2138"/>
-                </a:solidFill>
-                <a:latin typeface="Cambria"/>
-                <a:ea typeface="Cambria"/>
-                <a:cs typeface="Cambria"/>
+                  <a:srgbClr val="171717"/>
+                </a:solidFill>
+                <a:latin typeface="Arial"/>
+                <a:ea typeface="Arial"/>
+                <a:cs typeface="Arial"/>
               </a:rPr>
               <a:t>Margin now, platform revenue later</a:t>
             </a:r>
@@ -2580,7 +2557,7 @@
             </a:avLst>
           </a:prstGeom>
           <a:solidFill xmlns:a="http://schemas.openxmlformats.org/drawingml/2006/main">
-            <a:srgbClr val="141B34"/>
+            <a:srgbClr val="171717"/>
           </a:solidFill>
         </p:spPr>
       </p:sp>
@@ -2618,7 +2595,7 @@
             <a:r>
               <a:rPr sz="1200" b="1" spc="200">
                 <a:solidFill>
-                  <a:srgbClr val="FF8494"/>
+                  <a:srgbClr val="FFFFFF"/>
                 </a:solidFill>
                 <a:latin typeface="Arial"/>
                 <a:ea typeface="Arial"/>
@@ -2666,9 +2643,9 @@
                 <a:solidFill>
                   <a:srgbClr val="FFFFFF"/>
                 </a:solidFill>
-                <a:latin typeface="Cambria"/>
-                <a:ea typeface="Cambria"/>
-                <a:cs typeface="Cambria"/>
+                <a:latin typeface="Arial"/>
+                <a:ea typeface="Arial"/>
+                <a:cs typeface="Arial"/>
               </a:rPr>
               <a:t>Margin on every order</a:t>
             </a:r>
@@ -2713,7 +2690,7 @@
             <a:r>
               <a:rPr sz="1350">
                 <a:solidFill>
-                  <a:srgbClr val="CBD5F0"/>
+                  <a:srgbClr val="FFFFFF"/>
                 </a:solidFill>
                 <a:latin typeface="Arial"/>
                 <a:ea typeface="Arial"/>
@@ -2750,7 +2727,7 @@
             </a:avLst>
           </a:prstGeom>
           <a:solidFill xmlns:a="http://schemas.openxmlformats.org/drawingml/2006/main">
-            <a:srgbClr val="23305A"/>
+            <a:srgbClr val="14210A"/>
           </a:solidFill>
         </p:spPr>
       </p:sp>
@@ -2788,7 +2765,7 @@
             <a:r>
               <a:rPr sz="1150" b="1">
                 <a:solidFill>
-                  <a:srgbClr val="37D3A8"/>
+                  <a:srgbClr val="FFFFFF"/>
                 </a:solidFill>
                 <a:latin typeface="Arial"/>
                 <a:ea typeface="Arial"/>
@@ -2834,7 +2811,7 @@
             <a:r>
               <a:rPr sz="1200" b="1" spc="150">
                 <a:solidFill>
-                  <a:srgbClr val="6B7280"/>
+                  <a:srgbClr val="626262"/>
                 </a:solidFill>
                 <a:latin typeface="Arial"/>
                 <a:ea typeface="Arial"/>
@@ -2905,20 +2882,20 @@
             <a:avLst/>
           </a:prstGeom>
           <a:solidFill xmlns:a="http://schemas.openxmlformats.org/drawingml/2006/main">
-            <a:srgbClr val="FF5A6E"/>
+            <a:srgbClr val="B8FF58"/>
           </a:solidFill>
         </p:spPr>
       </p:sp>
       <p:pic>
         <p:nvPicPr>
-          <p:cNvPr id="48" name="Image 0"/>
+          <p:cNvPr id="49" name="Image 0"/>
           <p:cNvPicPr>
             <a:picLocks xmlns:a="http://schemas.openxmlformats.org/drawingml/2006/main" noChangeAspect="1"/>
           </p:cNvPicPr>
           <p:nvPr/>
         </p:nvPicPr>
         <p:blipFill>
-          <a:blip xmlns:r="http://schemas.openxmlformats.org/officeDocument/2006/relationships" xmlns:a="http://schemas.openxmlformats.org/drawingml/2006/main" r:embed="R7a834e85644f4511"/>
+          <a:blip xmlns:r="http://schemas.openxmlformats.org/officeDocument/2006/relationships" xmlns:a="http://schemas.openxmlformats.org/drawingml/2006/main" r:embed="R06b0f9d15cb14717"/>
           <a:stretch xmlns:a="http://schemas.openxmlformats.org/drawingml/2006/main">
             <a:fillRect l="0" t="0" r="0" b="0"/>
           </a:stretch>
@@ -2967,7 +2944,7 @@
             <a:r>
               <a:rPr sz="1300" b="1">
                 <a:solidFill>
-                  <a:srgbClr val="1A2138"/>
+                  <a:srgbClr val="171717"/>
                 </a:solidFill>
                 <a:latin typeface="Arial"/>
                 <a:ea typeface="Arial"/>
@@ -3013,7 +2990,7 @@
             <a:r>
               <a:rPr sz="1050">
                 <a:solidFill>
-                  <a:srgbClr val="6B7280"/>
+                  <a:srgbClr val="626262"/>
                 </a:solidFill>
                 <a:latin typeface="Arial"/>
                 <a:ea typeface="Arial"/>
@@ -3084,20 +3061,20 @@
             <a:avLst/>
           </a:prstGeom>
           <a:solidFill xmlns:a="http://schemas.openxmlformats.org/drawingml/2006/main">
-            <a:srgbClr val="FF5A6E"/>
+            <a:srgbClr val="B8FF58"/>
           </a:solidFill>
         </p:spPr>
       </p:sp>
       <p:pic>
         <p:nvPicPr>
-          <p:cNvPr id="53" name="Image 1"/>
+          <p:cNvPr id="54" name="Image 1"/>
           <p:cNvPicPr>
             <a:picLocks xmlns:a="http://schemas.openxmlformats.org/drawingml/2006/main" noChangeAspect="1"/>
           </p:cNvPicPr>
           <p:nvPr/>
         </p:nvPicPr>
         <p:blipFill>
-          <a:blip xmlns:r="http://schemas.openxmlformats.org/officeDocument/2006/relationships" xmlns:a="http://schemas.openxmlformats.org/drawingml/2006/main" r:embed="Rce6ee82b694547b2"/>
+          <a:blip xmlns:r="http://schemas.openxmlformats.org/officeDocument/2006/relationships" xmlns:a="http://schemas.openxmlformats.org/drawingml/2006/main" r:embed="Rdd0a3c4a4d214ca2"/>
           <a:stretch xmlns:a="http://schemas.openxmlformats.org/drawingml/2006/main">
             <a:fillRect l="0" t="0" r="0" b="0"/>
           </a:stretch>
@@ -3146,7 +3123,7 @@
             <a:r>
               <a:rPr sz="1300" b="1">
                 <a:solidFill>
-                  <a:srgbClr val="1A2138"/>
+                  <a:srgbClr val="171717"/>
                 </a:solidFill>
                 <a:latin typeface="Arial"/>
                 <a:ea typeface="Arial"/>
@@ -3192,7 +3169,7 @@
             <a:r>
               <a:rPr sz="1050">
                 <a:solidFill>
-                  <a:srgbClr val="6B7280"/>
+                  <a:srgbClr val="626262"/>
                 </a:solidFill>
                 <a:latin typeface="Arial"/>
                 <a:ea typeface="Arial"/>
@@ -3263,20 +3240,20 @@
             <a:avLst/>
           </a:prstGeom>
           <a:solidFill xmlns:a="http://schemas.openxmlformats.org/drawingml/2006/main">
-            <a:srgbClr val="FF5A6E"/>
+            <a:srgbClr val="B8FF58"/>
           </a:solidFill>
         </p:spPr>
       </p:sp>
       <p:pic>
         <p:nvPicPr>
-          <p:cNvPr id="58" name="Image 2"/>
+          <p:cNvPr id="59" name="Image 2"/>
           <p:cNvPicPr>
             <a:picLocks xmlns:a="http://schemas.openxmlformats.org/drawingml/2006/main" noChangeAspect="1"/>
           </p:cNvPicPr>
           <p:nvPr/>
         </p:nvPicPr>
         <p:blipFill>
-          <a:blip xmlns:r="http://schemas.openxmlformats.org/officeDocument/2006/relationships" xmlns:a="http://schemas.openxmlformats.org/drawingml/2006/main" r:embed="Rbf5560e993484f42"/>
+          <a:blip xmlns:r="http://schemas.openxmlformats.org/officeDocument/2006/relationships" xmlns:a="http://schemas.openxmlformats.org/drawingml/2006/main" r:embed="R6a367b88ade14907"/>
           <a:stretch xmlns:a="http://schemas.openxmlformats.org/drawingml/2006/main">
             <a:fillRect l="0" t="0" r="0" b="0"/>
           </a:stretch>
@@ -3325,7 +3302,7 @@
             <a:r>
               <a:rPr sz="1300" b="1">
                 <a:solidFill>
-                  <a:srgbClr val="1A2138"/>
+                  <a:srgbClr val="171717"/>
                 </a:solidFill>
                 <a:latin typeface="Arial"/>
                 <a:ea typeface="Arial"/>
@@ -3371,7 +3348,7 @@
             <a:r>
               <a:rPr sz="1050">
                 <a:solidFill>
-                  <a:srgbClr val="6B7280"/>
+                  <a:srgbClr val="626262"/>
                 </a:solidFill>
                 <a:latin typeface="Arial"/>
                 <a:ea typeface="Arial"/>
@@ -3442,20 +3419,20 @@
             <a:avLst/>
           </a:prstGeom>
           <a:solidFill xmlns:a="http://schemas.openxmlformats.org/drawingml/2006/main">
-            <a:srgbClr val="FF5A6E"/>
+            <a:srgbClr val="B8FF58"/>
           </a:solidFill>
         </p:spPr>
       </p:sp>
       <p:pic>
         <p:nvPicPr>
-          <p:cNvPr id="63" name="Image 3"/>
+          <p:cNvPr id="64" name="Image 3"/>
           <p:cNvPicPr>
             <a:picLocks xmlns:a="http://schemas.openxmlformats.org/drawingml/2006/main" noChangeAspect="1"/>
           </p:cNvPicPr>
           <p:nvPr/>
         </p:nvPicPr>
         <p:blipFill>
-          <a:blip xmlns:r="http://schemas.openxmlformats.org/officeDocument/2006/relationships" xmlns:a="http://schemas.openxmlformats.org/drawingml/2006/main" r:embed="R3c6bd9e1d6d34a22"/>
+          <a:blip xmlns:r="http://schemas.openxmlformats.org/officeDocument/2006/relationships" xmlns:a="http://schemas.openxmlformats.org/drawingml/2006/main" r:embed="R44c4d5a93f8641aa"/>
           <a:stretch xmlns:a="http://schemas.openxmlformats.org/drawingml/2006/main">
             <a:fillRect l="0" t="0" r="0" b="0"/>
           </a:stretch>
@@ -3504,7 +3481,7 @@
             <a:r>
               <a:rPr sz="1300" b="1">
                 <a:solidFill>
-                  <a:srgbClr val="1A2138"/>
+                  <a:srgbClr val="171717"/>
                 </a:solidFill>
                 <a:latin typeface="Arial"/>
                 <a:ea typeface="Arial"/>
@@ -3550,7 +3527,7 @@
             <a:r>
               <a:rPr sz="1050">
                 <a:solidFill>
-                  <a:srgbClr val="6B7280"/>
+                  <a:srgbClr val="626262"/>
                 </a:solidFill>
                 <a:latin typeface="Arial"/>
                 <a:ea typeface="Arial"/>
@@ -3596,7 +3573,7 @@
             <a:r>
               <a:rPr sz="900">
                 <a:solidFill>
-                  <a:srgbClr val="6B7280"/>
+                  <a:srgbClr val="626262"/>
                 </a:solidFill>
                 <a:latin typeface="Arial"/>
                 <a:ea typeface="Arial"/>
@@ -3642,7 +3619,7 @@
             <a:r>
               <a:rPr sz="900">
                 <a:solidFill>
-                  <a:srgbClr val="6B7280"/>
+                  <a:srgbClr val="626262"/>
                 </a:solidFill>
                 <a:latin typeface="Arial"/>
                 <a:ea typeface="Arial"/>
@@ -3654,6 +3631,34 @@
           </a:p>
         </p:txBody>
       </p:sp>
+      <p:pic>
+        <p:nvPicPr>
+          <p:cNvPr id="69" name=""/>
+          <p:cNvPicPr>
+            <a:picLocks xmlns:a="http://schemas.openxmlformats.org/drawingml/2006/main" noChangeAspect="1"/>
+          </p:cNvPicPr>
+          <p:nvPr/>
+        </p:nvPicPr>
+        <p:blipFill>
+          <a:blip xmlns:r="http://schemas.openxmlformats.org/officeDocument/2006/relationships" xmlns:a="http://schemas.openxmlformats.org/drawingml/2006/main" r:embed="R1d47d27fb7ac4ec4">
+            <a:extLst>
+              <a:ext uri="{96DAC541-7B7A-43D3-8B79-37D633B846F1}">
+                <asvg:svgBlip xmlns:asvg="http://schemas.microsoft.com/office/drawing/2016/SVG/main" r:embed="Rab55b48b441b490d"/>
+              </a:ext>
+            </a:extLst>
+          </a:blip>
+          <a:stretch xmlns:a="http://schemas.openxmlformats.org/drawingml/2006/main"/>
+        </p:blipFill>
+        <p:spPr>
+          <a:xfrm xmlns:a="http://schemas.openxmlformats.org/drawingml/2006/main">
+            <a:off x="228600" y="228600"/>
+            <a:ext cx="266700" cy="266700"/>
+          </a:xfrm>
+          <a:prstGeom xmlns:a="http://schemas.openxmlformats.org/drawingml/2006/main" prst="rect">
+            <a:avLst/>
+          </a:prstGeom>
+        </p:spPr>
+      </p:pic>
     </p:spTree>
     <p:extLst>
       <p:ext uri="{BB962C8B-B14F-4D97-AF65-F5344CB8AC3E}">
@@ -3670,7 +3675,7 @@
     <p:bg>
       <p:bgPr>
         <a:solidFill xmlns:a="http://schemas.openxmlformats.org/drawingml/2006/main">
-          <a:srgbClr val="141B34"/>
+          <a:srgbClr val="FFFFFF"/>
         </a:solidFill>
       </p:bgPr>
     </p:bg>
@@ -3717,7 +3722,7 @@
             <a:r>
               <a:rPr sz="1200" b="1" spc="300">
                 <a:solidFill>
-                  <a:srgbClr val="FF5A6E"/>
+                  <a:srgbClr val="356B15"/>
                 </a:solidFill>
                 <a:latin typeface="Arial"/>
                 <a:ea typeface="Arial"/>
@@ -3766,11 +3771,11 @@
             <a:r>
               <a:rPr sz="3200" b="1">
                 <a:solidFill>
-                  <a:srgbClr val="FFFFFF"/>
-                </a:solidFill>
-                <a:latin typeface="Cambria"/>
-                <a:ea typeface="Cambria"/>
-                <a:cs typeface="Cambria"/>
+                  <a:srgbClr val="171717"/>
+                </a:solidFill>
+                <a:latin typeface="Arial"/>
+                <a:ea typeface="Arial"/>
+                <a:cs typeface="Arial"/>
               </a:rPr>
               <a:t>Solo founder who has built and sold this kind of company</a:t>
             </a:r>
@@ -3801,20 +3806,20 @@
             <a:avLst/>
           </a:prstGeom>
           <a:solidFill xmlns:a="http://schemas.openxmlformats.org/drawingml/2006/main">
-            <a:srgbClr val="FF5A6E"/>
+            <a:srgbClr val="B8FF58"/>
           </a:solidFill>
         </p:spPr>
       </p:sp>
       <p:pic>
         <p:nvPicPr>
-          <p:cNvPr id="39" name="Image 0"/>
+          <p:cNvPr id="40" name="Image 0"/>
           <p:cNvPicPr>
             <a:picLocks xmlns:a="http://schemas.openxmlformats.org/drawingml/2006/main" noChangeAspect="1"/>
           </p:cNvPicPr>
           <p:nvPr/>
         </p:nvPicPr>
         <p:blipFill>
-          <a:blip xmlns:r="http://schemas.openxmlformats.org/officeDocument/2006/relationships" xmlns:a="http://schemas.openxmlformats.org/drawingml/2006/main" r:embed="Rdc27a2785843420f"/>
+          <a:blip xmlns:r="http://schemas.openxmlformats.org/officeDocument/2006/relationships" xmlns:a="http://schemas.openxmlformats.org/drawingml/2006/main" r:embed="R0727b8f23ac14098"/>
           <a:stretch xmlns:a="http://schemas.openxmlformats.org/drawingml/2006/main">
             <a:fillRect l="0" t="0" r="0" b="0"/>
           </a:stretch>
@@ -3863,11 +3868,11 @@
             <a:r>
               <a:rPr sz="2400" b="1">
                 <a:solidFill>
-                  <a:srgbClr val="FFFFFF"/>
-                </a:solidFill>
-                <a:latin typeface="Cambria"/>
-                <a:ea typeface="Cambria"/>
-                <a:cs typeface="Cambria"/>
+                  <a:srgbClr val="171717"/>
+                </a:solidFill>
+                <a:latin typeface="Arial"/>
+                <a:ea typeface="Arial"/>
+                <a:cs typeface="Arial"/>
               </a:rPr>
               <a:t>Aleksei Balchunas</a:t>
             </a:r>
@@ -3909,7 +3914,7 @@
             <a:r>
               <a:rPr sz="1400">
                 <a:solidFill>
-                  <a:srgbClr val="FF8494"/>
+                  <a:srgbClr val="356B15"/>
                 </a:solidFill>
                 <a:latin typeface="Arial"/>
                 <a:ea typeface="Arial"/>
@@ -3958,7 +3963,7 @@
             <a:r>
               <a:rPr sz="1300">
                 <a:solidFill>
-                  <a:srgbClr val="CBD5F0"/>
+                  <a:srgbClr val="626262"/>
                 </a:solidFill>
                 <a:latin typeface="Arial"/>
                 <a:ea typeface="Arial"/>
@@ -3995,7 +4000,7 @@
             </a:avLst>
           </a:prstGeom>
           <a:solidFill xmlns:a="http://schemas.openxmlformats.org/drawingml/2006/main">
-            <a:srgbClr val="1E2747"/>
+            <a:srgbClr val="EDFFD4"/>
           </a:solidFill>
           <a:ln xmlns:a="http://schemas.openxmlformats.org/drawingml/2006/main" w="12700">
             <a:solidFill>
@@ -4028,20 +4033,20 @@
             <a:avLst/>
           </a:prstGeom>
           <a:solidFill xmlns:a="http://schemas.openxmlformats.org/drawingml/2006/main">
-            <a:srgbClr val="FF5A6E"/>
+            <a:srgbClr val="B8FF58"/>
           </a:solidFill>
         </p:spPr>
       </p:sp>
       <p:pic>
         <p:nvPicPr>
-          <p:cNvPr id="45" name="Image 1"/>
+          <p:cNvPr id="46" name="Image 1"/>
           <p:cNvPicPr>
             <a:picLocks xmlns:a="http://schemas.openxmlformats.org/drawingml/2006/main" noChangeAspect="1"/>
           </p:cNvPicPr>
           <p:nvPr/>
         </p:nvPicPr>
         <p:blipFill>
-          <a:blip xmlns:r="http://schemas.openxmlformats.org/officeDocument/2006/relationships" xmlns:a="http://schemas.openxmlformats.org/drawingml/2006/main" r:embed="R12cebdb7043c4ef2"/>
+          <a:blip xmlns:r="http://schemas.openxmlformats.org/officeDocument/2006/relationships" xmlns:a="http://schemas.openxmlformats.org/drawingml/2006/main" r:embed="R782b520997654d15"/>
           <a:stretch xmlns:a="http://schemas.openxmlformats.org/drawingml/2006/main">
             <a:fillRect l="0" t="0" r="0" b="0"/>
           </a:stretch>
@@ -4090,7 +4095,7 @@
             <a:r>
               <a:rPr sz="1400" b="1">
                 <a:solidFill>
-                  <a:srgbClr val="FFFFFF"/>
+                  <a:srgbClr val="171717"/>
                 </a:solidFill>
                 <a:latin typeface="Arial"/>
                 <a:ea typeface="Arial"/>
@@ -4139,7 +4144,7 @@
             <a:r>
               <a:rPr sz="1100">
                 <a:solidFill>
-                  <a:srgbClr val="CBD5F0"/>
+                  <a:srgbClr val="626262"/>
                 </a:solidFill>
                 <a:latin typeface="Arial"/>
                 <a:ea typeface="Arial"/>
@@ -4176,7 +4181,7 @@
             </a:avLst>
           </a:prstGeom>
           <a:solidFill xmlns:a="http://schemas.openxmlformats.org/drawingml/2006/main">
-            <a:srgbClr val="1E2747"/>
+            <a:srgbClr val="EDFFD4"/>
           </a:solidFill>
           <a:ln xmlns:a="http://schemas.openxmlformats.org/drawingml/2006/main" w="12700">
             <a:solidFill>
@@ -4209,20 +4214,20 @@
             <a:avLst/>
           </a:prstGeom>
           <a:solidFill xmlns:a="http://schemas.openxmlformats.org/drawingml/2006/main">
-            <a:srgbClr val="FF5A6E"/>
+            <a:srgbClr val="B8FF58"/>
           </a:solidFill>
         </p:spPr>
       </p:sp>
       <p:pic>
         <p:nvPicPr>
-          <p:cNvPr id="50" name="Image 2"/>
+          <p:cNvPr id="51" name="Image 2"/>
           <p:cNvPicPr>
             <a:picLocks xmlns:a="http://schemas.openxmlformats.org/drawingml/2006/main" noChangeAspect="1"/>
           </p:cNvPicPr>
           <p:nvPr/>
         </p:nvPicPr>
         <p:blipFill>
-          <a:blip xmlns:r="http://schemas.openxmlformats.org/officeDocument/2006/relationships" xmlns:a="http://schemas.openxmlformats.org/drawingml/2006/main" r:embed="R441d1ce1267649ab"/>
+          <a:blip xmlns:r="http://schemas.openxmlformats.org/officeDocument/2006/relationships" xmlns:a="http://schemas.openxmlformats.org/drawingml/2006/main" r:embed="R9c3c5621af0a43db"/>
           <a:stretch xmlns:a="http://schemas.openxmlformats.org/drawingml/2006/main">
             <a:fillRect l="0" t="0" r="0" b="0"/>
           </a:stretch>
@@ -4271,7 +4276,7 @@
             <a:r>
               <a:rPr sz="1400" b="1">
                 <a:solidFill>
-                  <a:srgbClr val="FFFFFF"/>
+                  <a:srgbClr val="171717"/>
                 </a:solidFill>
                 <a:latin typeface="Arial"/>
                 <a:ea typeface="Arial"/>
@@ -4320,7 +4325,7 @@
             <a:r>
               <a:rPr sz="1100">
                 <a:solidFill>
-                  <a:srgbClr val="CBD5F0"/>
+                  <a:srgbClr val="626262"/>
                 </a:solidFill>
                 <a:latin typeface="Arial"/>
                 <a:ea typeface="Arial"/>
@@ -4357,7 +4362,7 @@
             </a:avLst>
           </a:prstGeom>
           <a:solidFill xmlns:a="http://schemas.openxmlformats.org/drawingml/2006/main">
-            <a:srgbClr val="1E2747"/>
+            <a:srgbClr val="EDFFD4"/>
           </a:solidFill>
           <a:ln xmlns:a="http://schemas.openxmlformats.org/drawingml/2006/main" w="12700">
             <a:solidFill>
@@ -4390,20 +4395,20 @@
             <a:avLst/>
           </a:prstGeom>
           <a:solidFill xmlns:a="http://schemas.openxmlformats.org/drawingml/2006/main">
-            <a:srgbClr val="FF5A6E"/>
+            <a:srgbClr val="B8FF58"/>
           </a:solidFill>
         </p:spPr>
       </p:sp>
       <p:pic>
         <p:nvPicPr>
-          <p:cNvPr id="55" name="Image 3"/>
+          <p:cNvPr id="56" name="Image 3"/>
           <p:cNvPicPr>
             <a:picLocks xmlns:a="http://schemas.openxmlformats.org/drawingml/2006/main" noChangeAspect="1"/>
           </p:cNvPicPr>
           <p:nvPr/>
         </p:nvPicPr>
         <p:blipFill>
-          <a:blip xmlns:r="http://schemas.openxmlformats.org/officeDocument/2006/relationships" xmlns:a="http://schemas.openxmlformats.org/drawingml/2006/main" r:embed="R15d5867b49034d07"/>
+          <a:blip xmlns:r="http://schemas.openxmlformats.org/officeDocument/2006/relationships" xmlns:a="http://schemas.openxmlformats.org/drawingml/2006/main" r:embed="Ra8489c1b2f014737"/>
           <a:stretch xmlns:a="http://schemas.openxmlformats.org/drawingml/2006/main">
             <a:fillRect l="0" t="0" r="0" b="0"/>
           </a:stretch>
@@ -4452,7 +4457,7 @@
             <a:r>
               <a:rPr sz="1400" b="1">
                 <a:solidFill>
-                  <a:srgbClr val="FFFFFF"/>
+                  <a:srgbClr val="171717"/>
                 </a:solidFill>
                 <a:latin typeface="Arial"/>
                 <a:ea typeface="Arial"/>
@@ -4501,7 +4506,7 @@
             <a:r>
               <a:rPr sz="1100">
                 <a:solidFill>
-                  <a:srgbClr val="CBD5F0"/>
+                  <a:srgbClr val="626262"/>
                 </a:solidFill>
                 <a:latin typeface="Arial"/>
                 <a:ea typeface="Arial"/>
@@ -4538,7 +4543,7 @@
             </a:avLst>
           </a:prstGeom>
           <a:solidFill xmlns:a="http://schemas.openxmlformats.org/drawingml/2006/main">
-            <a:srgbClr val="1E2747"/>
+            <a:srgbClr val="EDFFD4"/>
           </a:solidFill>
           <a:ln xmlns:a="http://schemas.openxmlformats.org/drawingml/2006/main" w="12700">
             <a:solidFill>
@@ -4571,20 +4576,20 @@
             <a:avLst/>
           </a:prstGeom>
           <a:solidFill xmlns:a="http://schemas.openxmlformats.org/drawingml/2006/main">
-            <a:srgbClr val="FF5A6E"/>
+            <a:srgbClr val="B8FF58"/>
           </a:solidFill>
         </p:spPr>
       </p:sp>
       <p:pic>
         <p:nvPicPr>
-          <p:cNvPr id="60" name="Image 4"/>
+          <p:cNvPr id="61" name="Image 4"/>
           <p:cNvPicPr>
             <a:picLocks xmlns:a="http://schemas.openxmlformats.org/drawingml/2006/main" noChangeAspect="1"/>
           </p:cNvPicPr>
           <p:nvPr/>
         </p:nvPicPr>
         <p:blipFill>
-          <a:blip xmlns:r="http://schemas.openxmlformats.org/officeDocument/2006/relationships" xmlns:a="http://schemas.openxmlformats.org/drawingml/2006/main" r:embed="R8d93d05c2fec450d"/>
+          <a:blip xmlns:r="http://schemas.openxmlformats.org/officeDocument/2006/relationships" xmlns:a="http://schemas.openxmlformats.org/drawingml/2006/main" r:embed="R79d7372ae4b4411e"/>
           <a:stretch xmlns:a="http://schemas.openxmlformats.org/drawingml/2006/main">
             <a:fillRect l="0" t="0" r="0" b="0"/>
           </a:stretch>
@@ -4633,7 +4638,7 @@
             <a:r>
               <a:rPr sz="1400" b="1">
                 <a:solidFill>
-                  <a:srgbClr val="FFFFFF"/>
+                  <a:srgbClr val="171717"/>
                 </a:solidFill>
                 <a:latin typeface="Arial"/>
                 <a:ea typeface="Arial"/>
@@ -4682,7 +4687,7 @@
             <a:r>
               <a:rPr sz="1100">
                 <a:solidFill>
-                  <a:srgbClr val="CBD5F0"/>
+                  <a:srgbClr val="626262"/>
                 </a:solidFill>
                 <a:latin typeface="Arial"/>
                 <a:ea typeface="Arial"/>
@@ -4728,7 +4733,7 @@
             <a:r>
               <a:rPr sz="900">
                 <a:solidFill>
-                  <a:srgbClr val="9AA3B2"/>
+                  <a:srgbClr val="626262"/>
                 </a:solidFill>
                 <a:latin typeface="Arial"/>
                 <a:ea typeface="Arial"/>
@@ -4774,7 +4779,7 @@
             <a:r>
               <a:rPr sz="900">
                 <a:solidFill>
-                  <a:srgbClr val="9AA3B2"/>
+                  <a:srgbClr val="626262"/>
                 </a:solidFill>
                 <a:latin typeface="Arial"/>
                 <a:ea typeface="Arial"/>
@@ -4786,6 +4791,34 @@
           </a:p>
         </p:txBody>
       </p:sp>
+      <p:pic>
+        <p:nvPicPr>
+          <p:cNvPr id="66" name=""/>
+          <p:cNvPicPr>
+            <a:picLocks xmlns:a="http://schemas.openxmlformats.org/drawingml/2006/main" noChangeAspect="1"/>
+          </p:cNvPicPr>
+          <p:nvPr/>
+        </p:nvPicPr>
+        <p:blipFill>
+          <a:blip xmlns:r="http://schemas.openxmlformats.org/officeDocument/2006/relationships" xmlns:a="http://schemas.openxmlformats.org/drawingml/2006/main" r:embed="Rd107b91a326842b0">
+            <a:extLst>
+              <a:ext uri="{96DAC541-7B7A-43D3-8B79-37D633B846F1}">
+                <asvg:svgBlip xmlns:asvg="http://schemas.microsoft.com/office/drawing/2016/SVG/main" r:embed="R89edc59f12394a79"/>
+              </a:ext>
+            </a:extLst>
+          </a:blip>
+          <a:stretch xmlns:a="http://schemas.openxmlformats.org/drawingml/2006/main"/>
+        </p:blipFill>
+        <p:spPr>
+          <a:xfrm xmlns:a="http://schemas.openxmlformats.org/drawingml/2006/main">
+            <a:off x="228600" y="228600"/>
+            <a:ext cx="266700" cy="266700"/>
+          </a:xfrm>
+          <a:prstGeom xmlns:a="http://schemas.openxmlformats.org/drawingml/2006/main" prst="rect">
+            <a:avLst/>
+          </a:prstGeom>
+        </p:spPr>
+      </p:pic>
     </p:spTree>
     <p:extLst>
       <p:ext uri="{BB962C8B-B14F-4D97-AF65-F5344CB8AC3E}">
@@ -4802,7 +4835,7 @@
     <p:bg>
       <p:bgPr>
         <a:solidFill xmlns:a="http://schemas.openxmlformats.org/drawingml/2006/main">
-          <a:srgbClr val="141B34"/>
+          <a:srgbClr val="FFFFFF"/>
         </a:solidFill>
       </p:bgPr>
     </p:bg>
@@ -4838,7 +4871,7 @@
             <a:avLst/>
           </a:prstGeom>
           <a:solidFill xmlns:a="http://schemas.openxmlformats.org/drawingml/2006/main">
-            <a:srgbClr val="1E2747"/>
+            <a:srgbClr val="EDFFD4"/>
           </a:solidFill>
         </p:spPr>
       </p:sp>
@@ -4876,7 +4909,7 @@
             <a:r>
               <a:rPr sz="1200" b="1" spc="300">
                 <a:solidFill>
-                  <a:srgbClr val="FF5A6E"/>
+                  <a:srgbClr val="356B15"/>
                 </a:solidFill>
                 <a:latin typeface="Arial"/>
                 <a:ea typeface="Arial"/>
@@ -4925,11 +4958,11 @@
             <a:r>
               <a:rPr sz="3000" b="1">
                 <a:solidFill>
-                  <a:srgbClr val="FFFFFF"/>
-                </a:solidFill>
-                <a:latin typeface="Cambria"/>
-                <a:ea typeface="Cambria"/>
-                <a:cs typeface="Cambria"/>
+                  <a:srgbClr val="171717"/>
+                </a:solidFill>
+                <a:latin typeface="Arial"/>
+                <a:ea typeface="Arial"/>
+                <a:cs typeface="Arial"/>
               </a:rPr>
               <a:t>Fuel to take the category while the window is open</a:t>
             </a:r>
@@ -4971,7 +5004,7 @@
             <a:r>
               <a:rPr sz="1500" b="1">
                 <a:solidFill>
-                  <a:srgbClr val="FFFFFF"/>
+                  <a:srgbClr val="171717"/>
                 </a:solidFill>
                 <a:latin typeface="Arial"/>
                 <a:ea typeface="Arial"/>
@@ -4982,7 +5015,7 @@
             <a:r>
               <a:rPr sz="1500">
                 <a:solidFill>
-                  <a:srgbClr val="9AA3B2"/>
+                  <a:srgbClr val="171717"/>
                 </a:solidFill>
                 <a:latin typeface="Arial"/>
                 <a:ea typeface="Arial"/>
@@ -5028,7 +5061,7 @@
             <a:r>
               <a:rPr sz="1200" b="1" spc="200">
                 <a:solidFill>
-                  <a:srgbClr val="FF8494"/>
+                  <a:srgbClr val="356B15"/>
                 </a:solidFill>
                 <a:latin typeface="Arial"/>
                 <a:ea typeface="Arial"/>
@@ -5063,20 +5096,20 @@
             <a:avLst/>
           </a:prstGeom>
           <a:solidFill xmlns:a="http://schemas.openxmlformats.org/drawingml/2006/main">
-            <a:srgbClr val="FF5A6E"/>
+            <a:srgbClr val="B8FF58"/>
           </a:solidFill>
         </p:spPr>
       </p:sp>
       <p:pic>
         <p:nvPicPr>
-          <p:cNvPr id="34" name="Image 0"/>
+          <p:cNvPr id="35" name="Image 0"/>
           <p:cNvPicPr>
             <a:picLocks xmlns:a="http://schemas.openxmlformats.org/drawingml/2006/main" noChangeAspect="1"/>
           </p:cNvPicPr>
           <p:nvPr/>
         </p:nvPicPr>
         <p:blipFill>
-          <a:blip xmlns:r="http://schemas.openxmlformats.org/officeDocument/2006/relationships" xmlns:a="http://schemas.openxmlformats.org/drawingml/2006/main" r:embed="R64b2d9204d734995"/>
+          <a:blip xmlns:r="http://schemas.openxmlformats.org/officeDocument/2006/relationships" xmlns:a="http://schemas.openxmlformats.org/drawingml/2006/main" r:embed="Re2a81b733a554240"/>
           <a:stretch xmlns:a="http://schemas.openxmlformats.org/drawingml/2006/main">
             <a:fillRect l="0" t="0" r="0" b="0"/>
           </a:stretch>
@@ -5125,7 +5158,7 @@
             <a:r>
               <a:rPr sz="1350">
                 <a:solidFill>
-                  <a:srgbClr val="CBD5F0"/>
+                  <a:srgbClr val="626262"/>
                 </a:solidFill>
                 <a:latin typeface="Arial"/>
                 <a:ea typeface="Arial"/>
@@ -5160,20 +5193,20 @@
             <a:avLst/>
           </a:prstGeom>
           <a:solidFill xmlns:a="http://schemas.openxmlformats.org/drawingml/2006/main">
-            <a:srgbClr val="FF5A6E"/>
+            <a:srgbClr val="B8FF58"/>
           </a:solidFill>
         </p:spPr>
       </p:sp>
       <p:pic>
         <p:nvPicPr>
-          <p:cNvPr id="37" name="Image 1"/>
+          <p:cNvPr id="38" name="Image 1"/>
           <p:cNvPicPr>
             <a:picLocks xmlns:a="http://schemas.openxmlformats.org/drawingml/2006/main" noChangeAspect="1"/>
           </p:cNvPicPr>
           <p:nvPr/>
         </p:nvPicPr>
         <p:blipFill>
-          <a:blip xmlns:r="http://schemas.openxmlformats.org/officeDocument/2006/relationships" xmlns:a="http://schemas.openxmlformats.org/drawingml/2006/main" r:embed="R5d9e99048c6a4ed4"/>
+          <a:blip xmlns:r="http://schemas.openxmlformats.org/officeDocument/2006/relationships" xmlns:a="http://schemas.openxmlformats.org/drawingml/2006/main" r:embed="Rb6ab1a05228046db"/>
           <a:stretch xmlns:a="http://schemas.openxmlformats.org/drawingml/2006/main">
             <a:fillRect l="0" t="0" r="0" b="0"/>
           </a:stretch>
@@ -5222,7 +5255,7 @@
             <a:r>
               <a:rPr sz="1350">
                 <a:solidFill>
-                  <a:srgbClr val="CBD5F0"/>
+                  <a:srgbClr val="626262"/>
                 </a:solidFill>
                 <a:latin typeface="Arial"/>
                 <a:ea typeface="Arial"/>
@@ -5257,20 +5290,20 @@
             <a:avLst/>
           </a:prstGeom>
           <a:solidFill xmlns:a="http://schemas.openxmlformats.org/drawingml/2006/main">
-            <a:srgbClr val="FF5A6E"/>
+            <a:srgbClr val="B8FF58"/>
           </a:solidFill>
         </p:spPr>
       </p:sp>
       <p:pic>
         <p:nvPicPr>
-          <p:cNvPr id="40" name="Image 2"/>
+          <p:cNvPr id="41" name="Image 2"/>
           <p:cNvPicPr>
             <a:picLocks xmlns:a="http://schemas.openxmlformats.org/drawingml/2006/main" noChangeAspect="1"/>
           </p:cNvPicPr>
           <p:nvPr/>
         </p:nvPicPr>
         <p:blipFill>
-          <a:blip xmlns:r="http://schemas.openxmlformats.org/officeDocument/2006/relationships" xmlns:a="http://schemas.openxmlformats.org/drawingml/2006/main" r:embed="Rf6b607c4d96c4746"/>
+          <a:blip xmlns:r="http://schemas.openxmlformats.org/officeDocument/2006/relationships" xmlns:a="http://schemas.openxmlformats.org/drawingml/2006/main" r:embed="R719f0a7bbca04495"/>
           <a:stretch xmlns:a="http://schemas.openxmlformats.org/drawingml/2006/main">
             <a:fillRect l="0" t="0" r="0" b="0"/>
           </a:stretch>
@@ -5319,7 +5352,7 @@
             <a:r>
               <a:rPr sz="1350">
                 <a:solidFill>
-                  <a:srgbClr val="CBD5F0"/>
+                  <a:srgbClr val="626262"/>
                 </a:solidFill>
                 <a:latin typeface="Arial"/>
                 <a:ea typeface="Arial"/>
@@ -5354,20 +5387,20 @@
             <a:avLst/>
           </a:prstGeom>
           <a:solidFill xmlns:a="http://schemas.openxmlformats.org/drawingml/2006/main">
-            <a:srgbClr val="FF5A6E"/>
+            <a:srgbClr val="B8FF58"/>
           </a:solidFill>
         </p:spPr>
       </p:sp>
       <p:pic>
         <p:nvPicPr>
-          <p:cNvPr id="43" name="Image 3"/>
+          <p:cNvPr id="44" name="Image 3"/>
           <p:cNvPicPr>
             <a:picLocks xmlns:a="http://schemas.openxmlformats.org/drawingml/2006/main" noChangeAspect="1"/>
           </p:cNvPicPr>
           <p:nvPr/>
         </p:nvPicPr>
         <p:blipFill>
-          <a:blip xmlns:r="http://schemas.openxmlformats.org/officeDocument/2006/relationships" xmlns:a="http://schemas.openxmlformats.org/drawingml/2006/main" r:embed="R80aa3e538ac04553"/>
+          <a:blip xmlns:r="http://schemas.openxmlformats.org/officeDocument/2006/relationships" xmlns:a="http://schemas.openxmlformats.org/drawingml/2006/main" r:embed="Rc7357d5525d34b9a"/>
           <a:stretch xmlns:a="http://schemas.openxmlformats.org/drawingml/2006/main">
             <a:fillRect l="0" t="0" r="0" b="0"/>
           </a:stretch>
@@ -5416,7 +5449,7 @@
             <a:r>
               <a:rPr sz="1350">
                 <a:solidFill>
-                  <a:srgbClr val="CBD5F0"/>
+                  <a:srgbClr val="626262"/>
                 </a:solidFill>
                 <a:latin typeface="Arial"/>
                 <a:ea typeface="Arial"/>
@@ -5453,7 +5486,7 @@
             </a:avLst>
           </a:prstGeom>
           <a:solidFill xmlns:a="http://schemas.openxmlformats.org/drawingml/2006/main">
-            <a:srgbClr val="FF5A6E"/>
+            <a:srgbClr val="B8FF58"/>
           </a:solidFill>
         </p:spPr>
       </p:sp>
@@ -5491,7 +5524,7 @@
             <a:r>
               <a:rPr sz="1200" b="1" spc="200">
                 <a:solidFill>
-                  <a:srgbClr val="FFFFFF"/>
+                  <a:srgbClr val="171717"/>
                 </a:solidFill>
                 <a:latin typeface="Arial"/>
                 <a:ea typeface="Arial"/>
@@ -5540,11 +5573,11 @@
             <a:r>
               <a:rPr sz="2200" b="1">
                 <a:solidFill>
-                  <a:srgbClr val="FFFFFF"/>
-                </a:solidFill>
-                <a:latin typeface="Cambria"/>
-                <a:ea typeface="Cambria"/>
-                <a:cs typeface="Cambria"/>
+                  <a:srgbClr val="171717"/>
+                </a:solidFill>
+                <a:latin typeface="Arial"/>
+                <a:ea typeface="Arial"/>
+                <a:cs typeface="Arial"/>
               </a:rPr>
               <a:t>Native shopping for the feed generation</a:t>
             </a:r>
@@ -5589,7 +5622,7 @@
             <a:r>
               <a:rPr sz="1250">
                 <a:solidFill>
-                  <a:srgbClr val="FFECEF"/>
+                  <a:srgbClr val="356B15"/>
                 </a:solidFill>
                 <a:latin typeface="Arial"/>
                 <a:ea typeface="Arial"/>
@@ -5618,7 +5651,7 @@
             <a:r>
               <a:rPr sz="1250">
                 <a:solidFill>
-                  <a:srgbClr val="FFECEF"/>
+                  <a:srgbClr val="356B15"/>
                 </a:solidFill>
                 <a:latin typeface="Arial"/>
                 <a:ea typeface="Arial"/>
@@ -5664,7 +5697,7 @@
             <a:r>
               <a:rPr sz="1200" b="1">
                 <a:solidFill>
-                  <a:srgbClr val="FFFFFF"/>
+                  <a:srgbClr val="171717"/>
                 </a:solidFill>
                 <a:latin typeface="Arial"/>
                 <a:ea typeface="Arial"/>
@@ -5676,6 +5709,34 @@
           </a:p>
         </p:txBody>
       </p:sp>
+      <p:pic>
+        <p:nvPicPr>
+          <p:cNvPr id="51" name=""/>
+          <p:cNvPicPr>
+            <a:picLocks xmlns:a="http://schemas.openxmlformats.org/drawingml/2006/main" noChangeAspect="1"/>
+          </p:cNvPicPr>
+          <p:nvPr/>
+        </p:nvPicPr>
+        <p:blipFill>
+          <a:blip xmlns:r="http://schemas.openxmlformats.org/officeDocument/2006/relationships" xmlns:a="http://schemas.openxmlformats.org/drawingml/2006/main" r:embed="R731ab5d22a7e487a">
+            <a:extLst>
+              <a:ext uri="{96DAC541-7B7A-43D3-8B79-37D633B846F1}">
+                <asvg:svgBlip xmlns:asvg="http://schemas.microsoft.com/office/drawing/2016/SVG/main" r:embed="R8b195ebb5a8a4b64"/>
+              </a:ext>
+            </a:extLst>
+          </a:blip>
+          <a:stretch xmlns:a="http://schemas.openxmlformats.org/drawingml/2006/main"/>
+        </p:blipFill>
+        <p:spPr>
+          <a:xfrm xmlns:a="http://schemas.openxmlformats.org/drawingml/2006/main">
+            <a:off x="228600" y="228600"/>
+            <a:ext cx="266700" cy="266700"/>
+          </a:xfrm>
+          <a:prstGeom xmlns:a="http://schemas.openxmlformats.org/drawingml/2006/main" prst="rect">
+            <a:avLst/>
+          </a:prstGeom>
+        </p:spPr>
+      </p:pic>
     </p:spTree>
     <p:extLst>
       <p:ext uri="{BB962C8B-B14F-4D97-AF65-F5344CB8AC3E}">
@@ -5692,7 +5753,7 @@
     <p:bg>
       <p:bgPr>
         <a:solidFill xmlns:a="http://schemas.openxmlformats.org/drawingml/2006/main">
-          <a:srgbClr val="F7F5F2"/>
+          <a:srgbClr val="FFFFFF"/>
         </a:solidFill>
       </p:bgPr>
     </p:bg>
@@ -5739,7 +5800,7 @@
             <a:r>
               <a:rPr sz="1200" b="1" spc="300">
                 <a:solidFill>
-                  <a:srgbClr val="FF5A6E"/>
+                  <a:srgbClr val="356B15"/>
                 </a:solidFill>
                 <a:latin typeface="Arial"/>
                 <a:ea typeface="Arial"/>
@@ -5788,11 +5849,11 @@
             <a:r>
               <a:rPr sz="3200" b="1">
                 <a:solidFill>
-                  <a:srgbClr val="1A2138"/>
-                </a:solidFill>
-                <a:latin typeface="Cambria"/>
-                <a:ea typeface="Cambria"/>
-                <a:cs typeface="Cambria"/>
+                  <a:srgbClr val="171717"/>
+                </a:solidFill>
+                <a:latin typeface="Arial"/>
+                <a:ea typeface="Arial"/>
+                <a:cs typeface="Arial"/>
               </a:rPr>
               <a:t>Huge purchase intent, nowhere good to spend it</a:t>
             </a:r>
@@ -5837,7 +5898,7 @@
             <a:r>
               <a:rPr sz="1500">
                 <a:solidFill>
-                  <a:srgbClr val="6B7280"/>
+                  <a:srgbClr val="626262"/>
                 </a:solidFill>
                 <a:latin typeface="Arial"/>
                 <a:ea typeface="Arial"/>
@@ -5908,20 +5969,20 @@
             <a:avLst/>
           </a:prstGeom>
           <a:solidFill xmlns:a="http://schemas.openxmlformats.org/drawingml/2006/main">
-            <a:srgbClr val="FF5A6E"/>
+            <a:srgbClr val="B8FF58"/>
           </a:solidFill>
         </p:spPr>
       </p:sp>
       <p:pic>
         <p:nvPicPr>
-          <p:cNvPr id="36" name="Image 0"/>
+          <p:cNvPr id="37" name="Image 0"/>
           <p:cNvPicPr>
             <a:picLocks xmlns:a="http://schemas.openxmlformats.org/drawingml/2006/main" noChangeAspect="1"/>
           </p:cNvPicPr>
           <p:nvPr/>
         </p:nvPicPr>
         <p:blipFill>
-          <a:blip xmlns:r="http://schemas.openxmlformats.org/officeDocument/2006/relationships" xmlns:a="http://schemas.openxmlformats.org/drawingml/2006/main" r:embed="R8aefe4425c074766"/>
+          <a:blip xmlns:r="http://schemas.openxmlformats.org/officeDocument/2006/relationships" xmlns:a="http://schemas.openxmlformats.org/drawingml/2006/main" r:embed="Ra76d5b2dd15a41cc"/>
           <a:stretch xmlns:a="http://schemas.openxmlformats.org/drawingml/2006/main">
             <a:fillRect l="0" t="0" r="0" b="0"/>
           </a:stretch>
@@ -5970,7 +6031,7 @@
             <a:r>
               <a:rPr sz="1500" b="1">
                 <a:solidFill>
-                  <a:srgbClr val="1A2138"/>
+                  <a:srgbClr val="171717"/>
                 </a:solidFill>
                 <a:latin typeface="Arial"/>
                 <a:ea typeface="Arial"/>
@@ -6019,7 +6080,7 @@
             <a:r>
               <a:rPr sz="1250">
                 <a:solidFill>
-                  <a:srgbClr val="6B7280"/>
+                  <a:srgbClr val="626262"/>
                 </a:solidFill>
                 <a:latin typeface="Arial"/>
                 <a:ea typeface="Arial"/>
@@ -6090,20 +6151,20 @@
             <a:avLst/>
           </a:prstGeom>
           <a:solidFill xmlns:a="http://schemas.openxmlformats.org/drawingml/2006/main">
-            <a:srgbClr val="FF5A6E"/>
+            <a:srgbClr val="B8FF58"/>
           </a:solidFill>
         </p:spPr>
       </p:sp>
       <p:pic>
         <p:nvPicPr>
-          <p:cNvPr id="41" name="Image 1"/>
+          <p:cNvPr id="42" name="Image 1"/>
           <p:cNvPicPr>
             <a:picLocks xmlns:a="http://schemas.openxmlformats.org/drawingml/2006/main" noChangeAspect="1"/>
           </p:cNvPicPr>
           <p:nvPr/>
         </p:nvPicPr>
         <p:blipFill>
-          <a:blip xmlns:r="http://schemas.openxmlformats.org/officeDocument/2006/relationships" xmlns:a="http://schemas.openxmlformats.org/drawingml/2006/main" r:embed="Ra55639c7da224991"/>
+          <a:blip xmlns:r="http://schemas.openxmlformats.org/officeDocument/2006/relationships" xmlns:a="http://schemas.openxmlformats.org/drawingml/2006/main" r:embed="R85ef5ca6c79b4ba0"/>
           <a:stretch xmlns:a="http://schemas.openxmlformats.org/drawingml/2006/main">
             <a:fillRect l="0" t="0" r="0" b="0"/>
           </a:stretch>
@@ -6152,7 +6213,7 @@
             <a:r>
               <a:rPr sz="1500" b="1">
                 <a:solidFill>
-                  <a:srgbClr val="1A2138"/>
+                  <a:srgbClr val="171717"/>
                 </a:solidFill>
                 <a:latin typeface="Arial"/>
                 <a:ea typeface="Arial"/>
@@ -6201,7 +6262,7 @@
             <a:r>
               <a:rPr sz="1250">
                 <a:solidFill>
-                  <a:srgbClr val="6B7280"/>
+                  <a:srgbClr val="626262"/>
                 </a:solidFill>
                 <a:latin typeface="Arial"/>
                 <a:ea typeface="Arial"/>
@@ -6272,20 +6333,20 @@
             <a:avLst/>
           </a:prstGeom>
           <a:solidFill xmlns:a="http://schemas.openxmlformats.org/drawingml/2006/main">
-            <a:srgbClr val="FF5A6E"/>
+            <a:srgbClr val="B8FF58"/>
           </a:solidFill>
         </p:spPr>
       </p:sp>
       <p:pic>
         <p:nvPicPr>
-          <p:cNvPr id="46" name="Image 2"/>
+          <p:cNvPr id="47" name="Image 2"/>
           <p:cNvPicPr>
             <a:picLocks xmlns:a="http://schemas.openxmlformats.org/drawingml/2006/main" noChangeAspect="1"/>
           </p:cNvPicPr>
           <p:nvPr/>
         </p:nvPicPr>
         <p:blipFill>
-          <a:blip xmlns:r="http://schemas.openxmlformats.org/officeDocument/2006/relationships" xmlns:a="http://schemas.openxmlformats.org/drawingml/2006/main" r:embed="Rd3906f69e58f4139"/>
+          <a:blip xmlns:r="http://schemas.openxmlformats.org/officeDocument/2006/relationships" xmlns:a="http://schemas.openxmlformats.org/drawingml/2006/main" r:embed="Rd995a7f7b17a4d9f"/>
           <a:stretch xmlns:a="http://schemas.openxmlformats.org/drawingml/2006/main">
             <a:fillRect l="0" t="0" r="0" b="0"/>
           </a:stretch>
@@ -6334,7 +6395,7 @@
             <a:r>
               <a:rPr sz="1500" b="1">
                 <a:solidFill>
-                  <a:srgbClr val="1A2138"/>
+                  <a:srgbClr val="171717"/>
                 </a:solidFill>
                 <a:latin typeface="Arial"/>
                 <a:ea typeface="Arial"/>
@@ -6383,7 +6444,7 @@
             <a:r>
               <a:rPr sz="1250">
                 <a:solidFill>
-                  <a:srgbClr val="6B7280"/>
+                  <a:srgbClr val="626262"/>
                 </a:solidFill>
                 <a:latin typeface="Arial"/>
                 <a:ea typeface="Arial"/>
@@ -6454,20 +6515,20 @@
             <a:avLst/>
           </a:prstGeom>
           <a:solidFill xmlns:a="http://schemas.openxmlformats.org/drawingml/2006/main">
-            <a:srgbClr val="FF5A6E"/>
+            <a:srgbClr val="B8FF58"/>
           </a:solidFill>
         </p:spPr>
       </p:sp>
       <p:pic>
         <p:nvPicPr>
-          <p:cNvPr id="51" name="Image 3"/>
+          <p:cNvPr id="52" name="Image 3"/>
           <p:cNvPicPr>
             <a:picLocks xmlns:a="http://schemas.openxmlformats.org/drawingml/2006/main" noChangeAspect="1"/>
           </p:cNvPicPr>
           <p:nvPr/>
         </p:nvPicPr>
         <p:blipFill>
-          <a:blip xmlns:r="http://schemas.openxmlformats.org/officeDocument/2006/relationships" xmlns:a="http://schemas.openxmlformats.org/drawingml/2006/main" r:embed="R4c3acc4bd4f546d1"/>
+          <a:blip xmlns:r="http://schemas.openxmlformats.org/officeDocument/2006/relationships" xmlns:a="http://schemas.openxmlformats.org/drawingml/2006/main" r:embed="R1e8d9c94c7c04520"/>
           <a:stretch xmlns:a="http://schemas.openxmlformats.org/drawingml/2006/main">
             <a:fillRect l="0" t="0" r="0" b="0"/>
           </a:stretch>
@@ -6516,7 +6577,7 @@
             <a:r>
               <a:rPr sz="1500" b="1">
                 <a:solidFill>
-                  <a:srgbClr val="1A2138"/>
+                  <a:srgbClr val="171717"/>
                 </a:solidFill>
                 <a:latin typeface="Arial"/>
                 <a:ea typeface="Arial"/>
@@ -6565,7 +6626,7 @@
             <a:r>
               <a:rPr sz="1250">
                 <a:solidFill>
-                  <a:srgbClr val="6B7280"/>
+                  <a:srgbClr val="626262"/>
                 </a:solidFill>
                 <a:latin typeface="Arial"/>
                 <a:ea typeface="Arial"/>
@@ -6611,7 +6672,7 @@
             <a:r>
               <a:rPr sz="900">
                 <a:solidFill>
-                  <a:srgbClr val="6B7280"/>
+                  <a:srgbClr val="626262"/>
                 </a:solidFill>
                 <a:latin typeface="Arial"/>
                 <a:ea typeface="Arial"/>
@@ -6657,7 +6718,7 @@
             <a:r>
               <a:rPr sz="900">
                 <a:solidFill>
-                  <a:srgbClr val="6B7280"/>
+                  <a:srgbClr val="626262"/>
                 </a:solidFill>
                 <a:latin typeface="Arial"/>
                 <a:ea typeface="Arial"/>
@@ -6669,6 +6730,34 @@
           </a:p>
         </p:txBody>
       </p:sp>
+      <p:pic>
+        <p:nvPicPr>
+          <p:cNvPr id="57" name=""/>
+          <p:cNvPicPr>
+            <a:picLocks xmlns:a="http://schemas.openxmlformats.org/drawingml/2006/main" noChangeAspect="1"/>
+          </p:cNvPicPr>
+          <p:nvPr/>
+        </p:nvPicPr>
+        <p:blipFill>
+          <a:blip xmlns:r="http://schemas.openxmlformats.org/officeDocument/2006/relationships" xmlns:a="http://schemas.openxmlformats.org/drawingml/2006/main" r:embed="Rb453a7ec93544071">
+            <a:extLst>
+              <a:ext uri="{96DAC541-7B7A-43D3-8B79-37D633B846F1}">
+                <asvg:svgBlip xmlns:asvg="http://schemas.microsoft.com/office/drawing/2016/SVG/main" r:embed="Rf8f06cd2b7de43a1"/>
+              </a:ext>
+            </a:extLst>
+          </a:blip>
+          <a:stretch xmlns:a="http://schemas.openxmlformats.org/drawingml/2006/main"/>
+        </p:blipFill>
+        <p:spPr>
+          <a:xfrm xmlns:a="http://schemas.openxmlformats.org/drawingml/2006/main">
+            <a:off x="228600" y="228600"/>
+            <a:ext cx="266700" cy="266700"/>
+          </a:xfrm>
+          <a:prstGeom xmlns:a="http://schemas.openxmlformats.org/drawingml/2006/main" prst="rect">
+            <a:avLst/>
+          </a:prstGeom>
+        </p:spPr>
+      </p:pic>
     </p:spTree>
     <p:extLst>
       <p:ext uri="{BB962C8B-B14F-4D97-AF65-F5344CB8AC3E}">
@@ -6685,7 +6774,7 @@
     <p:bg>
       <p:bgPr>
         <a:solidFill xmlns:a="http://schemas.openxmlformats.org/drawingml/2006/main">
-          <a:srgbClr val="F7F5F2"/>
+          <a:srgbClr val="FFFFFF"/>
         </a:solidFill>
       </p:bgPr>
     </p:bg>
@@ -6732,7 +6821,7 @@
             <a:r>
               <a:rPr sz="1200" b="1" spc="300">
                 <a:solidFill>
-                  <a:srgbClr val="FF5A6E"/>
+                  <a:srgbClr val="356B15"/>
                 </a:solidFill>
                 <a:latin typeface="Arial"/>
                 <a:ea typeface="Arial"/>
@@ -6781,11 +6870,11 @@
             <a:r>
               <a:rPr sz="3200" b="1">
                 <a:solidFill>
-                  <a:srgbClr val="1A2138"/>
-                </a:solidFill>
-                <a:latin typeface="Cambria"/>
-                <a:ea typeface="Cambria"/>
-                <a:cs typeface="Cambria"/>
+                  <a:srgbClr val="171717"/>
+                </a:solidFill>
+                <a:latin typeface="Arial"/>
+                <a:ea typeface="Arial"/>
+                <a:cs typeface="Arial"/>
               </a:rPr>
               <a:t>Four bad options, and she bounces between them</a:t>
             </a:r>
@@ -6852,20 +6941,20 @@
             <a:avLst/>
           </a:prstGeom>
           <a:solidFill xmlns:a="http://schemas.openxmlformats.org/drawingml/2006/main">
-            <a:srgbClr val="FF5A6E"/>
+            <a:srgbClr val="B8FF58"/>
           </a:solidFill>
         </p:spPr>
       </p:sp>
       <p:pic>
         <p:nvPicPr>
-          <p:cNvPr id="40" name="Image 0"/>
+          <p:cNvPr id="41" name="Image 0"/>
           <p:cNvPicPr>
             <a:picLocks xmlns:a="http://schemas.openxmlformats.org/drawingml/2006/main" noChangeAspect="1"/>
           </p:cNvPicPr>
           <p:nvPr/>
         </p:nvPicPr>
         <p:blipFill>
-          <a:blip xmlns:r="http://schemas.openxmlformats.org/officeDocument/2006/relationships" xmlns:a="http://schemas.openxmlformats.org/drawingml/2006/main" r:embed="R9401aa4613d84739"/>
+          <a:blip xmlns:r="http://schemas.openxmlformats.org/officeDocument/2006/relationships" xmlns:a="http://schemas.openxmlformats.org/drawingml/2006/main" r:embed="R1dbb4d713c304b15"/>
           <a:stretch xmlns:a="http://schemas.openxmlformats.org/drawingml/2006/main">
             <a:fillRect l="0" t="0" r="0" b="0"/>
           </a:stretch>
@@ -6914,7 +7003,7 @@
             <a:r>
               <a:rPr sz="1450" b="1">
                 <a:solidFill>
-                  <a:srgbClr val="1A2138"/>
+                  <a:srgbClr val="171717"/>
                 </a:solidFill>
                 <a:latin typeface="Arial"/>
                 <a:ea typeface="Arial"/>
@@ -6963,7 +7052,7 @@
             <a:r>
               <a:rPr sz="1180">
                 <a:solidFill>
-                  <a:srgbClr val="6B7280"/>
+                  <a:srgbClr val="626262"/>
                 </a:solidFill>
                 <a:latin typeface="Arial"/>
                 <a:ea typeface="Arial"/>
@@ -7012,7 +7101,7 @@
             <a:r>
               <a:rPr sz="1100" b="1" i="1">
                 <a:solidFill>
-                  <a:srgbClr val="FF5A6E"/>
+                  <a:srgbClr val="356B15"/>
                 </a:solidFill>
                 <a:latin typeface="Arial"/>
                 <a:ea typeface="Arial"/>
@@ -7083,20 +7172,20 @@
             <a:avLst/>
           </a:prstGeom>
           <a:solidFill xmlns:a="http://schemas.openxmlformats.org/drawingml/2006/main">
-            <a:srgbClr val="FF5A6E"/>
+            <a:srgbClr val="B8FF58"/>
           </a:solidFill>
         </p:spPr>
       </p:sp>
       <p:pic>
         <p:nvPicPr>
-          <p:cNvPr id="46" name="Image 1"/>
+          <p:cNvPr id="47" name="Image 1"/>
           <p:cNvPicPr>
             <a:picLocks xmlns:a="http://schemas.openxmlformats.org/drawingml/2006/main" noChangeAspect="1"/>
           </p:cNvPicPr>
           <p:nvPr/>
         </p:nvPicPr>
         <p:blipFill>
-          <a:blip xmlns:r="http://schemas.openxmlformats.org/officeDocument/2006/relationships" xmlns:a="http://schemas.openxmlformats.org/drawingml/2006/main" r:embed="R14d950a6bf5d4c73"/>
+          <a:blip xmlns:r="http://schemas.openxmlformats.org/officeDocument/2006/relationships" xmlns:a="http://schemas.openxmlformats.org/drawingml/2006/main" r:embed="Rf3b1a041613e47c4"/>
           <a:stretch xmlns:a="http://schemas.openxmlformats.org/drawingml/2006/main">
             <a:fillRect l="0" t="0" r="0" b="0"/>
           </a:stretch>
@@ -7145,7 +7234,7 @@
             <a:r>
               <a:rPr sz="1450" b="1">
                 <a:solidFill>
-                  <a:srgbClr val="1A2138"/>
+                  <a:srgbClr val="171717"/>
                 </a:solidFill>
                 <a:latin typeface="Arial"/>
                 <a:ea typeface="Arial"/>
@@ -7194,7 +7283,7 @@
             <a:r>
               <a:rPr sz="1180">
                 <a:solidFill>
-                  <a:srgbClr val="6B7280"/>
+                  <a:srgbClr val="626262"/>
                 </a:solidFill>
                 <a:latin typeface="Arial"/>
                 <a:ea typeface="Arial"/>
@@ -7243,7 +7332,7 @@
             <a:r>
               <a:rPr sz="1100" b="1" i="1">
                 <a:solidFill>
-                  <a:srgbClr val="FF5A6E"/>
+                  <a:srgbClr val="356B15"/>
                 </a:solidFill>
                 <a:latin typeface="Arial"/>
                 <a:ea typeface="Arial"/>
@@ -7314,20 +7403,20 @@
             <a:avLst/>
           </a:prstGeom>
           <a:solidFill xmlns:a="http://schemas.openxmlformats.org/drawingml/2006/main">
-            <a:srgbClr val="FF5A6E"/>
+            <a:srgbClr val="B8FF58"/>
           </a:solidFill>
         </p:spPr>
       </p:sp>
       <p:pic>
         <p:nvPicPr>
-          <p:cNvPr id="52" name="Image 2"/>
+          <p:cNvPr id="53" name="Image 2"/>
           <p:cNvPicPr>
             <a:picLocks xmlns:a="http://schemas.openxmlformats.org/drawingml/2006/main" noChangeAspect="1"/>
           </p:cNvPicPr>
           <p:nvPr/>
         </p:nvPicPr>
         <p:blipFill>
-          <a:blip xmlns:r="http://schemas.openxmlformats.org/officeDocument/2006/relationships" xmlns:a="http://schemas.openxmlformats.org/drawingml/2006/main" r:embed="Rc9cbf943417649ca"/>
+          <a:blip xmlns:r="http://schemas.openxmlformats.org/officeDocument/2006/relationships" xmlns:a="http://schemas.openxmlformats.org/drawingml/2006/main" r:embed="Rb5d00ecd63d2407d"/>
           <a:stretch xmlns:a="http://schemas.openxmlformats.org/drawingml/2006/main">
             <a:fillRect l="0" t="0" r="0" b="0"/>
           </a:stretch>
@@ -7376,7 +7465,7 @@
             <a:r>
               <a:rPr sz="1450" b="1">
                 <a:solidFill>
-                  <a:srgbClr val="1A2138"/>
+                  <a:srgbClr val="171717"/>
                 </a:solidFill>
                 <a:latin typeface="Arial"/>
                 <a:ea typeface="Arial"/>
@@ -7425,7 +7514,7 @@
             <a:r>
               <a:rPr sz="1180">
                 <a:solidFill>
-                  <a:srgbClr val="6B7280"/>
+                  <a:srgbClr val="626262"/>
                 </a:solidFill>
                 <a:latin typeface="Arial"/>
                 <a:ea typeface="Arial"/>
@@ -7474,7 +7563,7 @@
             <a:r>
               <a:rPr sz="1100" b="1" i="1">
                 <a:solidFill>
-                  <a:srgbClr val="FF5A6E"/>
+                  <a:srgbClr val="356B15"/>
                 </a:solidFill>
                 <a:latin typeface="Arial"/>
                 <a:ea typeface="Arial"/>
@@ -7545,20 +7634,20 @@
             <a:avLst/>
           </a:prstGeom>
           <a:solidFill xmlns:a="http://schemas.openxmlformats.org/drawingml/2006/main">
-            <a:srgbClr val="FF5A6E"/>
+            <a:srgbClr val="B8FF58"/>
           </a:solidFill>
         </p:spPr>
       </p:sp>
       <p:pic>
         <p:nvPicPr>
-          <p:cNvPr id="58" name="Image 3"/>
+          <p:cNvPr id="59" name="Image 3"/>
           <p:cNvPicPr>
             <a:picLocks xmlns:a="http://schemas.openxmlformats.org/drawingml/2006/main" noChangeAspect="1"/>
           </p:cNvPicPr>
           <p:nvPr/>
         </p:nvPicPr>
         <p:blipFill>
-          <a:blip xmlns:r="http://schemas.openxmlformats.org/officeDocument/2006/relationships" xmlns:a="http://schemas.openxmlformats.org/drawingml/2006/main" r:embed="R0b989bf21e5f4edc"/>
+          <a:blip xmlns:r="http://schemas.openxmlformats.org/officeDocument/2006/relationships" xmlns:a="http://schemas.openxmlformats.org/drawingml/2006/main" r:embed="Rfac7c55b600b4685"/>
           <a:stretch xmlns:a="http://schemas.openxmlformats.org/drawingml/2006/main">
             <a:fillRect l="0" t="0" r="0" b="0"/>
           </a:stretch>
@@ -7607,7 +7696,7 @@
             <a:r>
               <a:rPr sz="1450" b="1">
                 <a:solidFill>
-                  <a:srgbClr val="1A2138"/>
+                  <a:srgbClr val="171717"/>
                 </a:solidFill>
                 <a:latin typeface="Arial"/>
                 <a:ea typeface="Arial"/>
@@ -7656,7 +7745,7 @@
             <a:r>
               <a:rPr sz="1180">
                 <a:solidFill>
-                  <a:srgbClr val="6B7280"/>
+                  <a:srgbClr val="626262"/>
                 </a:solidFill>
                 <a:latin typeface="Arial"/>
                 <a:ea typeface="Arial"/>
@@ -7705,7 +7794,7 @@
             <a:r>
               <a:rPr sz="1100" b="1" i="1">
                 <a:solidFill>
-                  <a:srgbClr val="FF5A6E"/>
+                  <a:srgbClr val="356B15"/>
                 </a:solidFill>
                 <a:latin typeface="Arial"/>
                 <a:ea typeface="Arial"/>
@@ -7751,7 +7840,7 @@
             <a:r>
               <a:rPr sz="1350" b="1">
                 <a:solidFill>
-                  <a:srgbClr val="1A2138"/>
+                  <a:srgbClr val="171717"/>
                 </a:solidFill>
                 <a:latin typeface="Arial"/>
                 <a:ea typeface="Arial"/>
@@ -7797,7 +7886,7 @@
             <a:r>
               <a:rPr sz="900">
                 <a:solidFill>
-                  <a:srgbClr val="6B7280"/>
+                  <a:srgbClr val="626262"/>
                 </a:solidFill>
                 <a:latin typeface="Arial"/>
                 <a:ea typeface="Arial"/>
@@ -7843,7 +7932,7 @@
             <a:r>
               <a:rPr sz="900">
                 <a:solidFill>
-                  <a:srgbClr val="6B7280"/>
+                  <a:srgbClr val="626262"/>
                 </a:solidFill>
                 <a:latin typeface="Arial"/>
                 <a:ea typeface="Arial"/>
@@ -7855,6 +7944,34 @@
           </a:p>
         </p:txBody>
       </p:sp>
+      <p:pic>
+        <p:nvPicPr>
+          <p:cNvPr id="66" name=""/>
+          <p:cNvPicPr>
+            <a:picLocks xmlns:a="http://schemas.openxmlformats.org/drawingml/2006/main" noChangeAspect="1"/>
+          </p:cNvPicPr>
+          <p:nvPr/>
+        </p:nvPicPr>
+        <p:blipFill>
+          <a:blip xmlns:r="http://schemas.openxmlformats.org/officeDocument/2006/relationships" xmlns:a="http://schemas.openxmlformats.org/drawingml/2006/main" r:embed="R6757c1a950954242">
+            <a:extLst>
+              <a:ext uri="{96DAC541-7B7A-43D3-8B79-37D633B846F1}">
+                <asvg:svgBlip xmlns:asvg="http://schemas.microsoft.com/office/drawing/2016/SVG/main" r:embed="R579c97feefc7486b"/>
+              </a:ext>
+            </a:extLst>
+          </a:blip>
+          <a:stretch xmlns:a="http://schemas.openxmlformats.org/drawingml/2006/main"/>
+        </p:blipFill>
+        <p:spPr>
+          <a:xfrm xmlns:a="http://schemas.openxmlformats.org/drawingml/2006/main">
+            <a:off x="228600" y="228600"/>
+            <a:ext cx="266700" cy="266700"/>
+          </a:xfrm>
+          <a:prstGeom xmlns:a="http://schemas.openxmlformats.org/drawingml/2006/main" prst="rect">
+            <a:avLst/>
+          </a:prstGeom>
+        </p:spPr>
+      </p:pic>
     </p:spTree>
     <p:extLst>
       <p:ext uri="{BB962C8B-B14F-4D97-AF65-F5344CB8AC3E}">
@@ -7871,7 +7988,7 @@
     <p:bg>
       <p:bgPr>
         <a:solidFill xmlns:a="http://schemas.openxmlformats.org/drawingml/2006/main">
-          <a:srgbClr val="141B34"/>
+          <a:srgbClr val="FFFFFF"/>
         </a:solidFill>
       </p:bgPr>
     </p:bg>
@@ -7918,7 +8035,7 @@
             <a:r>
               <a:rPr sz="1200" b="1" spc="300">
                 <a:solidFill>
-                  <a:srgbClr val="FF5A6E"/>
+                  <a:srgbClr val="356B15"/>
                 </a:solidFill>
                 <a:latin typeface="Arial"/>
                 <a:ea typeface="Arial"/>
@@ -7964,11 +8081,11 @@
             <a:r>
               <a:rPr sz="3300" b="1">
                 <a:solidFill>
-                  <a:srgbClr val="FFFFFF"/>
-                </a:solidFill>
-                <a:latin typeface="Cambria"/>
-                <a:ea typeface="Cambria"/>
-                <a:cs typeface="Cambria"/>
+                  <a:srgbClr val="171717"/>
+                </a:solidFill>
+                <a:latin typeface="Arial"/>
+                <a:ea typeface="Arial"/>
+                <a:cs typeface="Arial"/>
               </a:rPr>
               <a:t>Same factories, different buying model</a:t>
             </a:r>
@@ -8013,7 +8130,7 @@
             <a:r>
               <a:rPr sz="1500">
                 <a:solidFill>
-                  <a:srgbClr val="CBD5F0"/>
+                  <a:srgbClr val="626262"/>
                 </a:solidFill>
                 <a:latin typeface="Arial"/>
                 <a:ea typeface="Arial"/>
@@ -8050,7 +8167,7 @@
             </a:avLst>
           </a:prstGeom>
           <a:solidFill xmlns:a="http://schemas.openxmlformats.org/drawingml/2006/main">
-            <a:srgbClr val="1E2747"/>
+            <a:srgbClr val="EDFFD4"/>
           </a:solidFill>
           <a:ln xmlns:a="http://schemas.openxmlformats.org/drawingml/2006/main" w="12700">
             <a:solidFill>
@@ -8083,20 +8200,20 @@
             <a:avLst/>
           </a:prstGeom>
           <a:solidFill xmlns:a="http://schemas.openxmlformats.org/drawingml/2006/main">
-            <a:srgbClr val="FF5A6E"/>
+            <a:srgbClr val="B8FF58"/>
           </a:solidFill>
         </p:spPr>
       </p:sp>
       <p:pic>
         <p:nvPicPr>
-          <p:cNvPr id="31" name="Image 0"/>
+          <p:cNvPr id="32" name="Image 0"/>
           <p:cNvPicPr>
             <a:picLocks xmlns:a="http://schemas.openxmlformats.org/drawingml/2006/main" noChangeAspect="1"/>
           </p:cNvPicPr>
           <p:nvPr/>
         </p:nvPicPr>
         <p:blipFill>
-          <a:blip xmlns:r="http://schemas.openxmlformats.org/officeDocument/2006/relationships" xmlns:a="http://schemas.openxmlformats.org/drawingml/2006/main" r:embed="Rfae104d328eb47b9"/>
+          <a:blip xmlns:r="http://schemas.openxmlformats.org/officeDocument/2006/relationships" xmlns:a="http://schemas.openxmlformats.org/drawingml/2006/main" r:embed="R178bfee0a21243c1"/>
           <a:stretch xmlns:a="http://schemas.openxmlformats.org/drawingml/2006/main">
             <a:fillRect l="0" t="0" r="0" b="0"/>
           </a:stretch>
@@ -8148,7 +8265,7 @@
             <a:r>
               <a:rPr sz="1550" b="1">
                 <a:solidFill>
-                  <a:srgbClr val="FFFFFF"/>
+                  <a:srgbClr val="171717"/>
                 </a:solidFill>
                 <a:latin typeface="Arial"/>
                 <a:ea typeface="Arial"/>
@@ -8197,7 +8314,7 @@
             <a:r>
               <a:rPr sz="1200">
                 <a:solidFill>
-                  <a:srgbClr val="CBD5F0"/>
+                  <a:srgbClr val="626262"/>
                 </a:solidFill>
                 <a:latin typeface="Arial"/>
                 <a:ea typeface="Arial"/>
@@ -8234,7 +8351,7 @@
             </a:avLst>
           </a:prstGeom>
           <a:solidFill xmlns:a="http://schemas.openxmlformats.org/drawingml/2006/main">
-            <a:srgbClr val="1E2747"/>
+            <a:srgbClr val="EDFFD4"/>
           </a:solidFill>
           <a:ln xmlns:a="http://schemas.openxmlformats.org/drawingml/2006/main" w="12700">
             <a:solidFill>
@@ -8267,20 +8384,20 @@
             <a:avLst/>
           </a:prstGeom>
           <a:solidFill xmlns:a="http://schemas.openxmlformats.org/drawingml/2006/main">
-            <a:srgbClr val="FF5A6E"/>
+            <a:srgbClr val="B8FF58"/>
           </a:solidFill>
         </p:spPr>
       </p:sp>
       <p:pic>
         <p:nvPicPr>
-          <p:cNvPr id="36" name="Image 1"/>
+          <p:cNvPr id="37" name="Image 1"/>
           <p:cNvPicPr>
             <a:picLocks xmlns:a="http://schemas.openxmlformats.org/drawingml/2006/main" noChangeAspect="1"/>
           </p:cNvPicPr>
           <p:nvPr/>
         </p:nvPicPr>
         <p:blipFill>
-          <a:blip xmlns:r="http://schemas.openxmlformats.org/officeDocument/2006/relationships" xmlns:a="http://schemas.openxmlformats.org/drawingml/2006/main" r:embed="R8e5dacfc6ece4cac"/>
+          <a:blip xmlns:r="http://schemas.openxmlformats.org/officeDocument/2006/relationships" xmlns:a="http://schemas.openxmlformats.org/drawingml/2006/main" r:embed="R0ccb6df5884e4afe"/>
           <a:stretch xmlns:a="http://schemas.openxmlformats.org/drawingml/2006/main">
             <a:fillRect l="0" t="0" r="0" b="0"/>
           </a:stretch>
@@ -8332,7 +8449,7 @@
             <a:r>
               <a:rPr sz="1550" b="1">
                 <a:solidFill>
-                  <a:srgbClr val="FFFFFF"/>
+                  <a:srgbClr val="171717"/>
                 </a:solidFill>
                 <a:latin typeface="Arial"/>
                 <a:ea typeface="Arial"/>
@@ -8381,7 +8498,7 @@
             <a:r>
               <a:rPr sz="1200">
                 <a:solidFill>
-                  <a:srgbClr val="CBD5F0"/>
+                  <a:srgbClr val="626262"/>
                 </a:solidFill>
                 <a:latin typeface="Arial"/>
                 <a:ea typeface="Arial"/>
@@ -8418,7 +8535,7 @@
             </a:avLst>
           </a:prstGeom>
           <a:solidFill xmlns:a="http://schemas.openxmlformats.org/drawingml/2006/main">
-            <a:srgbClr val="1E2747"/>
+            <a:srgbClr val="EDFFD4"/>
           </a:solidFill>
           <a:ln xmlns:a="http://schemas.openxmlformats.org/drawingml/2006/main" w="12700">
             <a:solidFill>
@@ -8451,20 +8568,20 @@
             <a:avLst/>
           </a:prstGeom>
           <a:solidFill xmlns:a="http://schemas.openxmlformats.org/drawingml/2006/main">
-            <a:srgbClr val="FF5A6E"/>
+            <a:srgbClr val="B8FF58"/>
           </a:solidFill>
         </p:spPr>
       </p:sp>
       <p:pic>
         <p:nvPicPr>
-          <p:cNvPr id="41" name="Image 2"/>
+          <p:cNvPr id="42" name="Image 2"/>
           <p:cNvPicPr>
             <a:picLocks xmlns:a="http://schemas.openxmlformats.org/drawingml/2006/main" noChangeAspect="1"/>
           </p:cNvPicPr>
           <p:nvPr/>
         </p:nvPicPr>
         <p:blipFill>
-          <a:blip xmlns:r="http://schemas.openxmlformats.org/officeDocument/2006/relationships" xmlns:a="http://schemas.openxmlformats.org/drawingml/2006/main" r:embed="R3ce211f9cad0444a"/>
+          <a:blip xmlns:r="http://schemas.openxmlformats.org/officeDocument/2006/relationships" xmlns:a="http://schemas.openxmlformats.org/drawingml/2006/main" r:embed="Rdf66342b608c4caf"/>
           <a:stretch xmlns:a="http://schemas.openxmlformats.org/drawingml/2006/main">
             <a:fillRect l="0" t="0" r="0" b="0"/>
           </a:stretch>
@@ -8516,7 +8633,7 @@
             <a:r>
               <a:rPr sz="1550" b="1">
                 <a:solidFill>
-                  <a:srgbClr val="FFFFFF"/>
+                  <a:srgbClr val="171717"/>
                 </a:solidFill>
                 <a:latin typeface="Arial"/>
                 <a:ea typeface="Arial"/>
@@ -8565,7 +8682,7 @@
             <a:r>
               <a:rPr sz="1200">
                 <a:solidFill>
-                  <a:srgbClr val="CBD5F0"/>
+                  <a:srgbClr val="626262"/>
                 </a:solidFill>
                 <a:latin typeface="Arial"/>
                 <a:ea typeface="Arial"/>
@@ -8611,7 +8728,7 @@
             <a:r>
               <a:rPr sz="1350">
                 <a:solidFill>
-                  <a:srgbClr val="9AA3B2"/>
+                  <a:srgbClr val="626262"/>
                 </a:solidFill>
                 <a:latin typeface="Arial"/>
                 <a:ea typeface="Arial"/>
@@ -8657,7 +8774,7 @@
             <a:r>
               <a:rPr sz="900">
                 <a:solidFill>
-                  <a:srgbClr val="9AA3B2"/>
+                  <a:srgbClr val="626262"/>
                 </a:solidFill>
                 <a:latin typeface="Arial"/>
                 <a:ea typeface="Arial"/>
@@ -8703,7 +8820,7 @@
             <a:r>
               <a:rPr sz="900">
                 <a:solidFill>
-                  <a:srgbClr val="9AA3B2"/>
+                  <a:srgbClr val="626262"/>
                 </a:solidFill>
                 <a:latin typeface="Arial"/>
                 <a:ea typeface="Arial"/>
@@ -8715,6 +8832,34 @@
           </a:p>
         </p:txBody>
       </p:sp>
+      <p:pic>
+        <p:nvPicPr>
+          <p:cNvPr id="48" name=""/>
+          <p:cNvPicPr>
+            <a:picLocks xmlns:a="http://schemas.openxmlformats.org/drawingml/2006/main" noChangeAspect="1"/>
+          </p:cNvPicPr>
+          <p:nvPr/>
+        </p:nvPicPr>
+        <p:blipFill>
+          <a:blip xmlns:r="http://schemas.openxmlformats.org/officeDocument/2006/relationships" xmlns:a="http://schemas.openxmlformats.org/drawingml/2006/main" r:embed="R41c3534e92154568">
+            <a:extLst>
+              <a:ext uri="{96DAC541-7B7A-43D3-8B79-37D633B846F1}">
+                <asvg:svgBlip xmlns:asvg="http://schemas.microsoft.com/office/drawing/2016/SVG/main" r:embed="R04c809798c1a410a"/>
+              </a:ext>
+            </a:extLst>
+          </a:blip>
+          <a:stretch xmlns:a="http://schemas.openxmlformats.org/drawingml/2006/main"/>
+        </p:blipFill>
+        <p:spPr>
+          <a:xfrm xmlns:a="http://schemas.openxmlformats.org/drawingml/2006/main">
+            <a:off x="228600" y="228600"/>
+            <a:ext cx="266700" cy="266700"/>
+          </a:xfrm>
+          <a:prstGeom xmlns:a="http://schemas.openxmlformats.org/drawingml/2006/main" prst="rect">
+            <a:avLst/>
+          </a:prstGeom>
+        </p:spPr>
+      </p:pic>
     </p:spTree>
     <p:extLst>
       <p:ext uri="{BB962C8B-B14F-4D97-AF65-F5344CB8AC3E}">
@@ -8731,7 +8876,7 @@
     <p:bg>
       <p:bgPr>
         <a:solidFill xmlns:a="http://schemas.openxmlformats.org/drawingml/2006/main">
-          <a:srgbClr val="F7F5F2"/>
+          <a:srgbClr val="FFFFFF"/>
         </a:solidFill>
       </p:bgPr>
     </p:bg>
@@ -8778,7 +8923,7 @@
             <a:r>
               <a:rPr sz="1200" b="1" spc="300">
                 <a:solidFill>
-                  <a:srgbClr val="FF5A6E"/>
+                  <a:srgbClr val="356B15"/>
                 </a:solidFill>
                 <a:latin typeface="Arial"/>
                 <a:ea typeface="Arial"/>
@@ -8827,11 +8972,11 @@
             <a:r>
               <a:rPr sz="3200" b="1">
                 <a:solidFill>
-                  <a:srgbClr val="1A2138"/>
-                </a:solidFill>
-                <a:latin typeface="Cambria"/>
-                <a:ea typeface="Cambria"/>
-                <a:cs typeface="Cambria"/>
+                  <a:srgbClr val="171717"/>
+                </a:solidFill>
+                <a:latin typeface="Arial"/>
+                <a:ea typeface="Arial"/>
+                <a:cs typeface="Arial"/>
               </a:rPr>
               <a:t>A factory-direct feed with a trust layer no one else ships</a:t>
             </a:r>
@@ -8898,20 +9043,20 @@
             <a:avLst/>
           </a:prstGeom>
           <a:solidFill xmlns:a="http://schemas.openxmlformats.org/drawingml/2006/main">
-            <a:srgbClr val="FF5A6E"/>
+            <a:srgbClr val="B8FF58"/>
           </a:solidFill>
         </p:spPr>
       </p:sp>
       <p:pic>
         <p:nvPicPr>
-          <p:cNvPr id="47" name="Image 0"/>
+          <p:cNvPr id="48" name="Image 0"/>
           <p:cNvPicPr>
             <a:picLocks xmlns:a="http://schemas.openxmlformats.org/drawingml/2006/main" noChangeAspect="1"/>
           </p:cNvPicPr>
           <p:nvPr/>
         </p:nvPicPr>
         <p:blipFill>
-          <a:blip xmlns:r="http://schemas.openxmlformats.org/officeDocument/2006/relationships" xmlns:a="http://schemas.openxmlformats.org/drawingml/2006/main" r:embed="R013039814ffd4472"/>
+          <a:blip xmlns:r="http://schemas.openxmlformats.org/officeDocument/2006/relationships" xmlns:a="http://schemas.openxmlformats.org/drawingml/2006/main" r:embed="Rf2e2b980559346f0"/>
           <a:stretch xmlns:a="http://schemas.openxmlformats.org/drawingml/2006/main">
             <a:fillRect l="0" t="0" r="0" b="0"/>
           </a:stretch>
@@ -8963,7 +9108,7 @@
             <a:r>
               <a:rPr sz="1400" b="1">
                 <a:solidFill>
-                  <a:srgbClr val="1A2138"/>
+                  <a:srgbClr val="171717"/>
                 </a:solidFill>
                 <a:latin typeface="Arial"/>
                 <a:ea typeface="Arial"/>
@@ -9012,7 +9157,7 @@
             <a:r>
               <a:rPr sz="1130">
                 <a:solidFill>
-                  <a:srgbClr val="6B7280"/>
+                  <a:srgbClr val="626262"/>
                 </a:solidFill>
                 <a:latin typeface="Arial"/>
                 <a:ea typeface="Arial"/>
@@ -9083,20 +9228,20 @@
             <a:avLst/>
           </a:prstGeom>
           <a:solidFill xmlns:a="http://schemas.openxmlformats.org/drawingml/2006/main">
-            <a:srgbClr val="FF5A6E"/>
+            <a:srgbClr val="B8FF58"/>
           </a:solidFill>
         </p:spPr>
       </p:sp>
       <p:pic>
         <p:nvPicPr>
-          <p:cNvPr id="52" name="Image 1"/>
+          <p:cNvPr id="53" name="Image 1"/>
           <p:cNvPicPr>
             <a:picLocks xmlns:a="http://schemas.openxmlformats.org/drawingml/2006/main" noChangeAspect="1"/>
           </p:cNvPicPr>
           <p:nvPr/>
         </p:nvPicPr>
         <p:blipFill>
-          <a:blip xmlns:r="http://schemas.openxmlformats.org/officeDocument/2006/relationships" xmlns:a="http://schemas.openxmlformats.org/drawingml/2006/main" r:embed="R12f1a511b54d4dda"/>
+          <a:blip xmlns:r="http://schemas.openxmlformats.org/officeDocument/2006/relationships" xmlns:a="http://schemas.openxmlformats.org/drawingml/2006/main" r:embed="Rf8d17968eaca4850"/>
           <a:stretch xmlns:a="http://schemas.openxmlformats.org/drawingml/2006/main">
             <a:fillRect l="0" t="0" r="0" b="0"/>
           </a:stretch>
@@ -9148,7 +9293,7 @@
             <a:r>
               <a:rPr sz="1400" b="1">
                 <a:solidFill>
-                  <a:srgbClr val="1A2138"/>
+                  <a:srgbClr val="171717"/>
                 </a:solidFill>
                 <a:latin typeface="Arial"/>
                 <a:ea typeface="Arial"/>
@@ -9197,7 +9342,7 @@
             <a:r>
               <a:rPr sz="1130">
                 <a:solidFill>
-                  <a:srgbClr val="6B7280"/>
+                  <a:srgbClr val="626262"/>
                 </a:solidFill>
                 <a:latin typeface="Arial"/>
                 <a:ea typeface="Arial"/>
@@ -9268,20 +9413,20 @@
             <a:avLst/>
           </a:prstGeom>
           <a:solidFill xmlns:a="http://schemas.openxmlformats.org/drawingml/2006/main">
-            <a:srgbClr val="FF5A6E"/>
+            <a:srgbClr val="B8FF58"/>
           </a:solidFill>
         </p:spPr>
       </p:sp>
       <p:pic>
         <p:nvPicPr>
-          <p:cNvPr id="57" name="Image 2"/>
+          <p:cNvPr id="58" name="Image 2"/>
           <p:cNvPicPr>
             <a:picLocks xmlns:a="http://schemas.openxmlformats.org/drawingml/2006/main" noChangeAspect="1"/>
           </p:cNvPicPr>
           <p:nvPr/>
         </p:nvPicPr>
         <p:blipFill>
-          <a:blip xmlns:r="http://schemas.openxmlformats.org/officeDocument/2006/relationships" xmlns:a="http://schemas.openxmlformats.org/drawingml/2006/main" r:embed="R3c30edf30d784e74"/>
+          <a:blip xmlns:r="http://schemas.openxmlformats.org/officeDocument/2006/relationships" xmlns:a="http://schemas.openxmlformats.org/drawingml/2006/main" r:embed="R1a6c51682fba46d0"/>
           <a:stretch xmlns:a="http://schemas.openxmlformats.org/drawingml/2006/main">
             <a:fillRect l="0" t="0" r="0" b="0"/>
           </a:stretch>
@@ -9333,7 +9478,7 @@
             <a:r>
               <a:rPr sz="1400" b="1">
                 <a:solidFill>
-                  <a:srgbClr val="1A2138"/>
+                  <a:srgbClr val="171717"/>
                 </a:solidFill>
                 <a:latin typeface="Arial"/>
                 <a:ea typeface="Arial"/>
@@ -9382,7 +9527,7 @@
             <a:r>
               <a:rPr sz="1130">
                 <a:solidFill>
-                  <a:srgbClr val="6B7280"/>
+                  <a:srgbClr val="626262"/>
                 </a:solidFill>
                 <a:latin typeface="Arial"/>
                 <a:ea typeface="Arial"/>
@@ -9453,20 +9598,20 @@
             <a:avLst/>
           </a:prstGeom>
           <a:solidFill xmlns:a="http://schemas.openxmlformats.org/drawingml/2006/main">
-            <a:srgbClr val="FF5A6E"/>
+            <a:srgbClr val="B8FF58"/>
           </a:solidFill>
         </p:spPr>
       </p:sp>
       <p:pic>
         <p:nvPicPr>
-          <p:cNvPr id="62" name="Image 3"/>
+          <p:cNvPr id="63" name="Image 3"/>
           <p:cNvPicPr>
             <a:picLocks xmlns:a="http://schemas.openxmlformats.org/drawingml/2006/main" noChangeAspect="1"/>
           </p:cNvPicPr>
           <p:nvPr/>
         </p:nvPicPr>
         <p:blipFill>
-          <a:blip xmlns:r="http://schemas.openxmlformats.org/officeDocument/2006/relationships" xmlns:a="http://schemas.openxmlformats.org/drawingml/2006/main" r:embed="Rbbecebe78ec34e57"/>
+          <a:blip xmlns:r="http://schemas.openxmlformats.org/officeDocument/2006/relationships" xmlns:a="http://schemas.openxmlformats.org/drawingml/2006/main" r:embed="R6c170fc49fb4429b"/>
           <a:stretch xmlns:a="http://schemas.openxmlformats.org/drawingml/2006/main">
             <a:fillRect l="0" t="0" r="0" b="0"/>
           </a:stretch>
@@ -9518,7 +9663,7 @@
             <a:r>
               <a:rPr sz="1400" b="1">
                 <a:solidFill>
-                  <a:srgbClr val="1A2138"/>
+                  <a:srgbClr val="171717"/>
                 </a:solidFill>
                 <a:latin typeface="Arial"/>
                 <a:ea typeface="Arial"/>
@@ -9567,7 +9712,7 @@
             <a:r>
               <a:rPr sz="1130">
                 <a:solidFill>
-                  <a:srgbClr val="6B7280"/>
+                  <a:srgbClr val="626262"/>
                 </a:solidFill>
                 <a:latin typeface="Arial"/>
                 <a:ea typeface="Arial"/>
@@ -9638,20 +9783,20 @@
             <a:avLst/>
           </a:prstGeom>
           <a:solidFill xmlns:a="http://schemas.openxmlformats.org/drawingml/2006/main">
-            <a:srgbClr val="FF5A6E"/>
+            <a:srgbClr val="B8FF58"/>
           </a:solidFill>
         </p:spPr>
       </p:sp>
       <p:pic>
         <p:nvPicPr>
-          <p:cNvPr id="67" name="Image 4"/>
+          <p:cNvPr id="68" name="Image 4"/>
           <p:cNvPicPr>
             <a:picLocks xmlns:a="http://schemas.openxmlformats.org/drawingml/2006/main" noChangeAspect="1"/>
           </p:cNvPicPr>
           <p:nvPr/>
         </p:nvPicPr>
         <p:blipFill>
-          <a:blip xmlns:r="http://schemas.openxmlformats.org/officeDocument/2006/relationships" xmlns:a="http://schemas.openxmlformats.org/drawingml/2006/main" r:embed="Rec5931868bdd48bb"/>
+          <a:blip xmlns:r="http://schemas.openxmlformats.org/officeDocument/2006/relationships" xmlns:a="http://schemas.openxmlformats.org/drawingml/2006/main" r:embed="R897e7cc7adc14e4a"/>
           <a:stretch xmlns:a="http://schemas.openxmlformats.org/drawingml/2006/main">
             <a:fillRect l="0" t="0" r="0" b="0"/>
           </a:stretch>
@@ -9703,7 +9848,7 @@
             <a:r>
               <a:rPr sz="1400" b="1">
                 <a:solidFill>
-                  <a:srgbClr val="1A2138"/>
+                  <a:srgbClr val="171717"/>
                 </a:solidFill>
                 <a:latin typeface="Arial"/>
                 <a:ea typeface="Arial"/>
@@ -9752,7 +9897,7 @@
             <a:r>
               <a:rPr sz="1130">
                 <a:solidFill>
-                  <a:srgbClr val="6B7280"/>
+                  <a:srgbClr val="626262"/>
                 </a:solidFill>
                 <a:latin typeface="Arial"/>
                 <a:ea typeface="Arial"/>
@@ -9823,20 +9968,20 @@
             <a:avLst/>
           </a:prstGeom>
           <a:solidFill xmlns:a="http://schemas.openxmlformats.org/drawingml/2006/main">
-            <a:srgbClr val="FF5A6E"/>
+            <a:srgbClr val="B8FF58"/>
           </a:solidFill>
         </p:spPr>
       </p:sp>
       <p:pic>
         <p:nvPicPr>
-          <p:cNvPr id="72" name="Image 5"/>
+          <p:cNvPr id="73" name="Image 5"/>
           <p:cNvPicPr>
             <a:picLocks xmlns:a="http://schemas.openxmlformats.org/drawingml/2006/main" noChangeAspect="1"/>
           </p:cNvPicPr>
           <p:nvPr/>
         </p:nvPicPr>
         <p:blipFill>
-          <a:blip xmlns:r="http://schemas.openxmlformats.org/officeDocument/2006/relationships" xmlns:a="http://schemas.openxmlformats.org/drawingml/2006/main" r:embed="Rc16b6304f57b4dcb"/>
+          <a:blip xmlns:r="http://schemas.openxmlformats.org/officeDocument/2006/relationships" xmlns:a="http://schemas.openxmlformats.org/drawingml/2006/main" r:embed="R965d50074af24c4d"/>
           <a:stretch xmlns:a="http://schemas.openxmlformats.org/drawingml/2006/main">
             <a:fillRect l="0" t="0" r="0" b="0"/>
           </a:stretch>
@@ -9888,7 +10033,7 @@
             <a:r>
               <a:rPr sz="1400" b="1">
                 <a:solidFill>
-                  <a:srgbClr val="1A2138"/>
+                  <a:srgbClr val="171717"/>
                 </a:solidFill>
                 <a:latin typeface="Arial"/>
                 <a:ea typeface="Arial"/>
@@ -9937,7 +10082,7 @@
             <a:r>
               <a:rPr sz="1130">
                 <a:solidFill>
-                  <a:srgbClr val="6B7280"/>
+                  <a:srgbClr val="626262"/>
                 </a:solidFill>
                 <a:latin typeface="Arial"/>
                 <a:ea typeface="Arial"/>
@@ -9983,7 +10128,7 @@
             <a:r>
               <a:rPr sz="1300" b="1">
                 <a:solidFill>
-                  <a:srgbClr val="FF5A6E"/>
+                  <a:srgbClr val="356B15"/>
                 </a:solidFill>
                 <a:latin typeface="Arial"/>
                 <a:ea typeface="Arial"/>
@@ -10029,7 +10174,7 @@
             <a:r>
               <a:rPr sz="900">
                 <a:solidFill>
-                  <a:srgbClr val="6B7280"/>
+                  <a:srgbClr val="626262"/>
                 </a:solidFill>
                 <a:latin typeface="Arial"/>
                 <a:ea typeface="Arial"/>
@@ -10075,7 +10220,7 @@
             <a:r>
               <a:rPr sz="900">
                 <a:solidFill>
-                  <a:srgbClr val="6B7280"/>
+                  <a:srgbClr val="626262"/>
                 </a:solidFill>
                 <a:latin typeface="Arial"/>
                 <a:ea typeface="Arial"/>
@@ -10087,6 +10232,34 @@
           </a:p>
         </p:txBody>
       </p:sp>
+      <p:pic>
+        <p:nvPicPr>
+          <p:cNvPr id="79" name=""/>
+          <p:cNvPicPr>
+            <a:picLocks xmlns:a="http://schemas.openxmlformats.org/drawingml/2006/main" noChangeAspect="1"/>
+          </p:cNvPicPr>
+          <p:nvPr/>
+        </p:nvPicPr>
+        <p:blipFill>
+          <a:blip xmlns:r="http://schemas.openxmlformats.org/officeDocument/2006/relationships" xmlns:a="http://schemas.openxmlformats.org/drawingml/2006/main" r:embed="R3a8e7dc966e74492">
+            <a:extLst>
+              <a:ext uri="{96DAC541-7B7A-43D3-8B79-37D633B846F1}">
+                <asvg:svgBlip xmlns:asvg="http://schemas.microsoft.com/office/drawing/2016/SVG/main" r:embed="R98578ce354e34941"/>
+              </a:ext>
+            </a:extLst>
+          </a:blip>
+          <a:stretch xmlns:a="http://schemas.openxmlformats.org/drawingml/2006/main"/>
+        </p:blipFill>
+        <p:spPr>
+          <a:xfrm xmlns:a="http://schemas.openxmlformats.org/drawingml/2006/main">
+            <a:off x="228600" y="228600"/>
+            <a:ext cx="266700" cy="266700"/>
+          </a:xfrm>
+          <a:prstGeom xmlns:a="http://schemas.openxmlformats.org/drawingml/2006/main" prst="rect">
+            <a:avLst/>
+          </a:prstGeom>
+        </p:spPr>
+      </p:pic>
     </p:spTree>
     <p:extLst>
       <p:ext uri="{BB962C8B-B14F-4D97-AF65-F5344CB8AC3E}">
@@ -10103,7 +10276,7 @@
     <p:bg>
       <p:bgPr>
         <a:solidFill xmlns:a="http://schemas.openxmlformats.org/drawingml/2006/main">
-          <a:srgbClr val="F7F5F2"/>
+          <a:srgbClr val="FFFFFF"/>
         </a:solidFill>
       </p:bgPr>
     </p:bg>
@@ -10150,7 +10323,7 @@
             <a:r>
               <a:rPr sz="1200" b="1" spc="300">
                 <a:solidFill>
-                  <a:srgbClr val="FF5A6E"/>
+                  <a:srgbClr val="356B15"/>
                 </a:solidFill>
                 <a:latin typeface="Arial"/>
                 <a:ea typeface="Arial"/>
@@ -10199,11 +10372,11 @@
             <a:r>
               <a:rPr sz="3200" b="1">
                 <a:solidFill>
-                  <a:srgbClr val="1A2138"/>
-                </a:solidFill>
-                <a:latin typeface="Cambria"/>
-                <a:ea typeface="Cambria"/>
-                <a:cs typeface="Cambria"/>
+                  <a:srgbClr val="171717"/>
+                </a:solidFill>
+                <a:latin typeface="Arial"/>
+                <a:ea typeface="Arial"/>
+                <a:cs typeface="Arial"/>
               </a:rPr>
               <a:t>How it works, end to end</a:t>
             </a:r>
@@ -10281,11 +10454,11 @@
             <a:r>
               <a:rPr sz="2600" b="1">
                 <a:solidFill>
-                  <a:srgbClr val="FF8494"/>
-                </a:solidFill>
-                <a:latin typeface="Cambria"/>
-                <a:ea typeface="Cambria"/>
-                <a:cs typeface="Cambria"/>
+                  <a:srgbClr val="356B15"/>
+                </a:solidFill>
+                <a:latin typeface="Arial"/>
+                <a:ea typeface="Arial"/>
+                <a:cs typeface="Arial"/>
               </a:rPr>
               <a:t>1</a:t>
             </a:r>
@@ -10316,20 +10489,20 @@
             <a:avLst/>
           </a:prstGeom>
           <a:solidFill xmlns:a="http://schemas.openxmlformats.org/drawingml/2006/main">
-            <a:srgbClr val="FF5A6E"/>
+            <a:srgbClr val="B8FF58"/>
           </a:solidFill>
         </p:spPr>
       </p:sp>
       <p:pic>
         <p:nvPicPr>
-          <p:cNvPr id="55" name="Image 0"/>
+          <p:cNvPr id="56" name="Image 0"/>
           <p:cNvPicPr>
             <a:picLocks xmlns:a="http://schemas.openxmlformats.org/drawingml/2006/main" noChangeAspect="1"/>
           </p:cNvPicPr>
           <p:nvPr/>
         </p:nvPicPr>
         <p:blipFill>
-          <a:blip xmlns:r="http://schemas.openxmlformats.org/officeDocument/2006/relationships" xmlns:a="http://schemas.openxmlformats.org/drawingml/2006/main" r:embed="Ra9086548efa44988"/>
+          <a:blip xmlns:r="http://schemas.openxmlformats.org/officeDocument/2006/relationships" xmlns:a="http://schemas.openxmlformats.org/drawingml/2006/main" r:embed="R1728260ba9b147f6"/>
           <a:stretch xmlns:a="http://schemas.openxmlformats.org/drawingml/2006/main">
             <a:fillRect l="0" t="0" r="0" b="0"/>
           </a:stretch>
@@ -10378,7 +10551,7 @@
             <a:r>
               <a:rPr sz="1450" b="1">
                 <a:solidFill>
-                  <a:srgbClr val="1A2138"/>
+                  <a:srgbClr val="171717"/>
                 </a:solidFill>
                 <a:latin typeface="Arial"/>
                 <a:ea typeface="Arial"/>
@@ -10427,7 +10600,7 @@
             <a:r>
               <a:rPr sz="1130">
                 <a:solidFill>
-                  <a:srgbClr val="6B7280"/>
+                  <a:srgbClr val="626262"/>
                 </a:solidFill>
                 <a:latin typeface="Arial"/>
                 <a:ea typeface="Arial"/>
@@ -10441,14 +10614,14 @@
       </p:sp>
       <p:pic>
         <p:nvPicPr>
-          <p:cNvPr id="58" name="Image 1"/>
+          <p:cNvPr id="59" name="Image 1"/>
           <p:cNvPicPr>
             <a:picLocks xmlns:a="http://schemas.openxmlformats.org/drawingml/2006/main" noChangeAspect="1"/>
           </p:cNvPicPr>
           <p:nvPr/>
         </p:nvPicPr>
         <p:blipFill>
-          <a:blip xmlns:r="http://schemas.openxmlformats.org/officeDocument/2006/relationships" xmlns:a="http://schemas.openxmlformats.org/drawingml/2006/main" r:embed="Rb87f27bb04f94b9b"/>
+          <a:blip xmlns:r="http://schemas.openxmlformats.org/officeDocument/2006/relationships" xmlns:a="http://schemas.openxmlformats.org/drawingml/2006/main" r:embed="R7b446f7b64fc4251"/>
           <a:stretch xmlns:a="http://schemas.openxmlformats.org/drawingml/2006/main">
             <a:fillRect l="0" t="0" r="0" b="0"/>
           </a:stretch>
@@ -10533,11 +10706,11 @@
             <a:r>
               <a:rPr sz="2600" b="1">
                 <a:solidFill>
-                  <a:srgbClr val="FF8494"/>
-                </a:solidFill>
-                <a:latin typeface="Cambria"/>
-                <a:ea typeface="Cambria"/>
-                <a:cs typeface="Cambria"/>
+                  <a:srgbClr val="356B15"/>
+                </a:solidFill>
+                <a:latin typeface="Arial"/>
+                <a:ea typeface="Arial"/>
+                <a:cs typeface="Arial"/>
               </a:rPr>
               <a:t>2</a:t>
             </a:r>
@@ -10568,20 +10741,20 @@
             <a:avLst/>
           </a:prstGeom>
           <a:solidFill xmlns:a="http://schemas.openxmlformats.org/drawingml/2006/main">
-            <a:srgbClr val="FF5A6E"/>
+            <a:srgbClr val="B8FF58"/>
           </a:solidFill>
         </p:spPr>
       </p:sp>
       <p:pic>
         <p:nvPicPr>
-          <p:cNvPr id="62" name="Image 2"/>
+          <p:cNvPr id="63" name="Image 2"/>
           <p:cNvPicPr>
             <a:picLocks xmlns:a="http://schemas.openxmlformats.org/drawingml/2006/main" noChangeAspect="1"/>
           </p:cNvPicPr>
           <p:nvPr/>
         </p:nvPicPr>
         <p:blipFill>
-          <a:blip xmlns:r="http://schemas.openxmlformats.org/officeDocument/2006/relationships" xmlns:a="http://schemas.openxmlformats.org/drawingml/2006/main" r:embed="R722707f729004e7d"/>
+          <a:blip xmlns:r="http://schemas.openxmlformats.org/officeDocument/2006/relationships" xmlns:a="http://schemas.openxmlformats.org/drawingml/2006/main" r:embed="R36c7ff626a41483e"/>
           <a:stretch xmlns:a="http://schemas.openxmlformats.org/drawingml/2006/main">
             <a:fillRect l="0" t="0" r="0" b="0"/>
           </a:stretch>
@@ -10630,7 +10803,7 @@
             <a:r>
               <a:rPr sz="1450" b="1">
                 <a:solidFill>
-                  <a:srgbClr val="1A2138"/>
+                  <a:srgbClr val="171717"/>
                 </a:solidFill>
                 <a:latin typeface="Arial"/>
                 <a:ea typeface="Arial"/>
@@ -10679,7 +10852,7 @@
             <a:r>
               <a:rPr sz="1130">
                 <a:solidFill>
-                  <a:srgbClr val="6B7280"/>
+                  <a:srgbClr val="626262"/>
                 </a:solidFill>
                 <a:latin typeface="Arial"/>
                 <a:ea typeface="Arial"/>
@@ -10693,14 +10866,14 @@
       </p:sp>
       <p:pic>
         <p:nvPicPr>
-          <p:cNvPr id="65" name="Image 3"/>
+          <p:cNvPr id="66" name="Image 3"/>
           <p:cNvPicPr>
             <a:picLocks xmlns:a="http://schemas.openxmlformats.org/drawingml/2006/main" noChangeAspect="1"/>
           </p:cNvPicPr>
           <p:nvPr/>
         </p:nvPicPr>
         <p:blipFill>
-          <a:blip xmlns:r="http://schemas.openxmlformats.org/officeDocument/2006/relationships" xmlns:a="http://schemas.openxmlformats.org/drawingml/2006/main" r:embed="Rf99235d61c154a16"/>
+          <a:blip xmlns:r="http://schemas.openxmlformats.org/officeDocument/2006/relationships" xmlns:a="http://schemas.openxmlformats.org/drawingml/2006/main" r:embed="Rce66528f7cd14f49"/>
           <a:stretch xmlns:a="http://schemas.openxmlformats.org/drawingml/2006/main">
             <a:fillRect l="0" t="0" r="0" b="0"/>
           </a:stretch>
@@ -10785,11 +10958,11 @@
             <a:r>
               <a:rPr sz="2600" b="1">
                 <a:solidFill>
-                  <a:srgbClr val="FF8494"/>
-                </a:solidFill>
-                <a:latin typeface="Cambria"/>
-                <a:ea typeface="Cambria"/>
-                <a:cs typeface="Cambria"/>
+                  <a:srgbClr val="356B15"/>
+                </a:solidFill>
+                <a:latin typeface="Arial"/>
+                <a:ea typeface="Arial"/>
+                <a:cs typeface="Arial"/>
               </a:rPr>
               <a:t>3</a:t>
             </a:r>
@@ -10820,20 +10993,20 @@
             <a:avLst/>
           </a:prstGeom>
           <a:solidFill xmlns:a="http://schemas.openxmlformats.org/drawingml/2006/main">
-            <a:srgbClr val="FF5A6E"/>
+            <a:srgbClr val="B8FF58"/>
           </a:solidFill>
         </p:spPr>
       </p:sp>
       <p:pic>
         <p:nvPicPr>
-          <p:cNvPr id="69" name="Image 4"/>
+          <p:cNvPr id="70" name="Image 4"/>
           <p:cNvPicPr>
             <a:picLocks xmlns:a="http://schemas.openxmlformats.org/drawingml/2006/main" noChangeAspect="1"/>
           </p:cNvPicPr>
           <p:nvPr/>
         </p:nvPicPr>
         <p:blipFill>
-          <a:blip xmlns:r="http://schemas.openxmlformats.org/officeDocument/2006/relationships" xmlns:a="http://schemas.openxmlformats.org/drawingml/2006/main" r:embed="R5d4d2ca6d0254db9"/>
+          <a:blip xmlns:r="http://schemas.openxmlformats.org/officeDocument/2006/relationships" xmlns:a="http://schemas.openxmlformats.org/drawingml/2006/main" r:embed="R76f26c3357ef4fdf"/>
           <a:stretch xmlns:a="http://schemas.openxmlformats.org/drawingml/2006/main">
             <a:fillRect l="0" t="0" r="0" b="0"/>
           </a:stretch>
@@ -10882,7 +11055,7 @@
             <a:r>
               <a:rPr sz="1450" b="1">
                 <a:solidFill>
-                  <a:srgbClr val="1A2138"/>
+                  <a:srgbClr val="171717"/>
                 </a:solidFill>
                 <a:latin typeface="Arial"/>
                 <a:ea typeface="Arial"/>
@@ -10931,7 +11104,7 @@
             <a:r>
               <a:rPr sz="1130">
                 <a:solidFill>
-                  <a:srgbClr val="6B7280"/>
+                  <a:srgbClr val="626262"/>
                 </a:solidFill>
                 <a:latin typeface="Arial"/>
                 <a:ea typeface="Arial"/>
@@ -10945,14 +11118,14 @@
       </p:sp>
       <p:pic>
         <p:nvPicPr>
-          <p:cNvPr id="72" name="Image 5"/>
+          <p:cNvPr id="73" name="Image 5"/>
           <p:cNvPicPr>
             <a:picLocks xmlns:a="http://schemas.openxmlformats.org/drawingml/2006/main" noChangeAspect="1"/>
           </p:cNvPicPr>
           <p:nvPr/>
         </p:nvPicPr>
         <p:blipFill>
-          <a:blip xmlns:r="http://schemas.openxmlformats.org/officeDocument/2006/relationships" xmlns:a="http://schemas.openxmlformats.org/drawingml/2006/main" r:embed="Rd0305757152a41b0"/>
+          <a:blip xmlns:r="http://schemas.openxmlformats.org/officeDocument/2006/relationships" xmlns:a="http://schemas.openxmlformats.org/drawingml/2006/main" r:embed="R656e4936a1314bb7"/>
           <a:stretch xmlns:a="http://schemas.openxmlformats.org/drawingml/2006/main">
             <a:fillRect l="0" t="0" r="0" b="0"/>
           </a:stretch>
@@ -11037,11 +11210,11 @@
             <a:r>
               <a:rPr sz="2600" b="1">
                 <a:solidFill>
-                  <a:srgbClr val="FF8494"/>
-                </a:solidFill>
-                <a:latin typeface="Cambria"/>
-                <a:ea typeface="Cambria"/>
-                <a:cs typeface="Cambria"/>
+                  <a:srgbClr val="356B15"/>
+                </a:solidFill>
+                <a:latin typeface="Arial"/>
+                <a:ea typeface="Arial"/>
+                <a:cs typeface="Arial"/>
               </a:rPr>
               <a:t>4</a:t>
             </a:r>
@@ -11072,20 +11245,20 @@
             <a:avLst/>
           </a:prstGeom>
           <a:solidFill xmlns:a="http://schemas.openxmlformats.org/drawingml/2006/main">
-            <a:srgbClr val="FF5A6E"/>
+            <a:srgbClr val="B8FF58"/>
           </a:solidFill>
         </p:spPr>
       </p:sp>
       <p:pic>
         <p:nvPicPr>
-          <p:cNvPr id="76" name="Image 6"/>
+          <p:cNvPr id="77" name="Image 6"/>
           <p:cNvPicPr>
             <a:picLocks xmlns:a="http://schemas.openxmlformats.org/drawingml/2006/main" noChangeAspect="1"/>
           </p:cNvPicPr>
           <p:nvPr/>
         </p:nvPicPr>
         <p:blipFill>
-          <a:blip xmlns:r="http://schemas.openxmlformats.org/officeDocument/2006/relationships" xmlns:a="http://schemas.openxmlformats.org/drawingml/2006/main" r:embed="R8baaee77ad71415c"/>
+          <a:blip xmlns:r="http://schemas.openxmlformats.org/officeDocument/2006/relationships" xmlns:a="http://schemas.openxmlformats.org/drawingml/2006/main" r:embed="R431e9ecf72dc405c"/>
           <a:stretch xmlns:a="http://schemas.openxmlformats.org/drawingml/2006/main">
             <a:fillRect l="0" t="0" r="0" b="0"/>
           </a:stretch>
@@ -11134,7 +11307,7 @@
             <a:r>
               <a:rPr sz="1450" b="1">
                 <a:solidFill>
-                  <a:srgbClr val="1A2138"/>
+                  <a:srgbClr val="171717"/>
                 </a:solidFill>
                 <a:latin typeface="Arial"/>
                 <a:ea typeface="Arial"/>
@@ -11183,7 +11356,7 @@
             <a:r>
               <a:rPr sz="1130">
                 <a:solidFill>
-                  <a:srgbClr val="6B7280"/>
+                  <a:srgbClr val="626262"/>
                 </a:solidFill>
                 <a:latin typeface="Arial"/>
                 <a:ea typeface="Arial"/>
@@ -11197,14 +11370,14 @@
       </p:sp>
       <p:pic>
         <p:nvPicPr>
-          <p:cNvPr id="79" name="Image 7"/>
+          <p:cNvPr id="80" name="Image 7"/>
           <p:cNvPicPr>
             <a:picLocks xmlns:a="http://schemas.openxmlformats.org/drawingml/2006/main" noChangeAspect="1"/>
           </p:cNvPicPr>
           <p:nvPr/>
         </p:nvPicPr>
         <p:blipFill>
-          <a:blip xmlns:r="http://schemas.openxmlformats.org/officeDocument/2006/relationships" xmlns:a="http://schemas.openxmlformats.org/drawingml/2006/main" r:embed="Rad0ba97d28bf4328"/>
+          <a:blip xmlns:r="http://schemas.openxmlformats.org/officeDocument/2006/relationships" xmlns:a="http://schemas.openxmlformats.org/drawingml/2006/main" r:embed="Rb8585783db704b77"/>
           <a:stretch xmlns:a="http://schemas.openxmlformats.org/drawingml/2006/main">
             <a:fillRect l="0" t="0" r="0" b="0"/>
           </a:stretch>
@@ -11289,11 +11462,11 @@
             <a:r>
               <a:rPr sz="2600" b="1">
                 <a:solidFill>
-                  <a:srgbClr val="FF8494"/>
-                </a:solidFill>
-                <a:latin typeface="Cambria"/>
-                <a:ea typeface="Cambria"/>
-                <a:cs typeface="Cambria"/>
+                  <a:srgbClr val="356B15"/>
+                </a:solidFill>
+                <a:latin typeface="Arial"/>
+                <a:ea typeface="Arial"/>
+                <a:cs typeface="Arial"/>
               </a:rPr>
               <a:t>5</a:t>
             </a:r>
@@ -11324,20 +11497,20 @@
             <a:avLst/>
           </a:prstGeom>
           <a:solidFill xmlns:a="http://schemas.openxmlformats.org/drawingml/2006/main">
-            <a:srgbClr val="FF5A6E"/>
+            <a:srgbClr val="B8FF58"/>
           </a:solidFill>
         </p:spPr>
       </p:sp>
       <p:pic>
         <p:nvPicPr>
-          <p:cNvPr id="83" name="Image 8"/>
+          <p:cNvPr id="84" name="Image 8"/>
           <p:cNvPicPr>
             <a:picLocks xmlns:a="http://schemas.openxmlformats.org/drawingml/2006/main" noChangeAspect="1"/>
           </p:cNvPicPr>
           <p:nvPr/>
         </p:nvPicPr>
         <p:blipFill>
-          <a:blip xmlns:r="http://schemas.openxmlformats.org/officeDocument/2006/relationships" xmlns:a="http://schemas.openxmlformats.org/drawingml/2006/main" r:embed="Rfa443ebb27ef4e28"/>
+          <a:blip xmlns:r="http://schemas.openxmlformats.org/officeDocument/2006/relationships" xmlns:a="http://schemas.openxmlformats.org/drawingml/2006/main" r:embed="Ra0d44aba6a7644f2"/>
           <a:stretch xmlns:a="http://schemas.openxmlformats.org/drawingml/2006/main">
             <a:fillRect l="0" t="0" r="0" b="0"/>
           </a:stretch>
@@ -11386,7 +11559,7 @@
             <a:r>
               <a:rPr sz="1450" b="1">
                 <a:solidFill>
-                  <a:srgbClr val="1A2138"/>
+                  <a:srgbClr val="171717"/>
                 </a:solidFill>
                 <a:latin typeface="Arial"/>
                 <a:ea typeface="Arial"/>
@@ -11435,7 +11608,7 @@
             <a:r>
               <a:rPr sz="1130">
                 <a:solidFill>
-                  <a:srgbClr val="6B7280"/>
+                  <a:srgbClr val="626262"/>
                 </a:solidFill>
                 <a:latin typeface="Arial"/>
                 <a:ea typeface="Arial"/>
@@ -11481,7 +11654,7 @@
             <a:r>
               <a:rPr sz="1350" i="1">
                 <a:solidFill>
-                  <a:srgbClr val="1A2138"/>
+                  <a:srgbClr val="171717"/>
                 </a:solidFill>
                 <a:latin typeface="Arial"/>
                 <a:ea typeface="Arial"/>
@@ -11527,7 +11700,7 @@
             <a:r>
               <a:rPr sz="900">
                 <a:solidFill>
-                  <a:srgbClr val="6B7280"/>
+                  <a:srgbClr val="626262"/>
                 </a:solidFill>
                 <a:latin typeface="Arial"/>
                 <a:ea typeface="Arial"/>
@@ -11573,7 +11746,7 @@
             <a:r>
               <a:rPr sz="900">
                 <a:solidFill>
-                  <a:srgbClr val="6B7280"/>
+                  <a:srgbClr val="626262"/>
                 </a:solidFill>
                 <a:latin typeface="Arial"/>
                 <a:ea typeface="Arial"/>
@@ -11585,6 +11758,34 @@
           </a:p>
         </p:txBody>
       </p:sp>
+      <p:pic>
+        <p:nvPicPr>
+          <p:cNvPr id="90" name=""/>
+          <p:cNvPicPr>
+            <a:picLocks xmlns:a="http://schemas.openxmlformats.org/drawingml/2006/main" noChangeAspect="1"/>
+          </p:cNvPicPr>
+          <p:nvPr/>
+        </p:nvPicPr>
+        <p:blipFill>
+          <a:blip xmlns:r="http://schemas.openxmlformats.org/officeDocument/2006/relationships" xmlns:a="http://schemas.openxmlformats.org/drawingml/2006/main" r:embed="Rb0409d0c98a946d9">
+            <a:extLst>
+              <a:ext uri="{96DAC541-7B7A-43D3-8B79-37D633B846F1}">
+                <asvg:svgBlip xmlns:asvg="http://schemas.microsoft.com/office/drawing/2016/SVG/main" r:embed="Rad761889898f478f"/>
+              </a:ext>
+            </a:extLst>
+          </a:blip>
+          <a:stretch xmlns:a="http://schemas.openxmlformats.org/drawingml/2006/main"/>
+        </p:blipFill>
+        <p:spPr>
+          <a:xfrm xmlns:a="http://schemas.openxmlformats.org/drawingml/2006/main">
+            <a:off x="228600" y="228600"/>
+            <a:ext cx="266700" cy="266700"/>
+          </a:xfrm>
+          <a:prstGeom xmlns:a="http://schemas.openxmlformats.org/drawingml/2006/main" prst="rect">
+            <a:avLst/>
+          </a:prstGeom>
+        </p:spPr>
+      </p:pic>
     </p:spTree>
     <p:extLst>
       <p:ext uri="{BB962C8B-B14F-4D97-AF65-F5344CB8AC3E}">
@@ -11601,7 +11802,7 @@
     <p:bg>
       <p:bgPr>
         <a:solidFill xmlns:a="http://schemas.openxmlformats.org/drawingml/2006/main">
-          <a:srgbClr val="141B34"/>
+          <a:srgbClr val="FFFFFF"/>
         </a:solidFill>
       </p:bgPr>
     </p:bg>
@@ -11648,7 +11849,7 @@
             <a:r>
               <a:rPr sz="1200" b="1" spc="300">
                 <a:solidFill>
-                  <a:srgbClr val="FF5A6E"/>
+                  <a:srgbClr val="356B15"/>
                 </a:solidFill>
                 <a:latin typeface="Arial"/>
                 <a:ea typeface="Arial"/>
@@ -11697,11 +11898,11 @@
             <a:r>
               <a:rPr sz="3200" b="1">
                 <a:solidFill>
-                  <a:srgbClr val="FFFFFF"/>
-                </a:solidFill>
-                <a:latin typeface="Cambria"/>
-                <a:ea typeface="Cambria"/>
-                <a:cs typeface="Cambria"/>
+                  <a:srgbClr val="171717"/>
+                </a:solidFill>
+                <a:latin typeface="Arial"/>
+                <a:ea typeface="Arial"/>
+                <a:cs typeface="Arial"/>
               </a:rPr>
               <a:t>A small team can now build a trust-first marketplace</a:t>
             </a:r>
@@ -11734,7 +11935,7 @@
             </a:avLst>
           </a:prstGeom>
           <a:solidFill xmlns:a="http://schemas.openxmlformats.org/drawingml/2006/main">
-            <a:srgbClr val="1E2747"/>
+            <a:srgbClr val="EDFFD4"/>
           </a:solidFill>
           <a:ln xmlns:a="http://schemas.openxmlformats.org/drawingml/2006/main" w="12700">
             <a:solidFill>
@@ -11778,7 +11979,7 @@
             <a:r>
               <a:rPr sz="1200" b="1" spc="200">
                 <a:solidFill>
-                  <a:srgbClr val="9AA3B2"/>
+                  <a:srgbClr val="626262"/>
                 </a:solidFill>
                 <a:latin typeface="Arial"/>
                 <a:ea typeface="Arial"/>
@@ -11827,7 +12028,7 @@
             <a:r>
               <a:rPr sz="1500">
                 <a:solidFill>
-                  <a:srgbClr val="CBD5F0"/>
+                  <a:srgbClr val="626262"/>
                 </a:solidFill>
                 <a:latin typeface="Arial"/>
                 <a:ea typeface="Arial"/>
@@ -11841,14 +12042,14 @@
       </p:sp>
       <p:pic>
         <p:nvPicPr>
-          <p:cNvPr id="24" name="Image 0"/>
+          <p:cNvPr id="25" name="Image 0"/>
           <p:cNvPicPr>
             <a:picLocks xmlns:a="http://schemas.openxmlformats.org/drawingml/2006/main" noChangeAspect="1"/>
           </p:cNvPicPr>
           <p:nvPr/>
         </p:nvPicPr>
         <p:blipFill>
-          <a:blip xmlns:r="http://schemas.openxmlformats.org/officeDocument/2006/relationships" xmlns:a="http://schemas.openxmlformats.org/drawingml/2006/main" r:embed="R5ec6661c0c894382"/>
+          <a:blip xmlns:r="http://schemas.openxmlformats.org/officeDocument/2006/relationships" xmlns:a="http://schemas.openxmlformats.org/drawingml/2006/main" r:embed="Ra79716b8e20344be"/>
           <a:stretch xmlns:a="http://schemas.openxmlformats.org/drawingml/2006/main">
             <a:fillRect l="0" t="0" r="0" b="0"/>
           </a:stretch>
@@ -11888,7 +12089,7 @@
             </a:avLst>
           </a:prstGeom>
           <a:solidFill xmlns:a="http://schemas.openxmlformats.org/drawingml/2006/main">
-            <a:srgbClr val="FF5A6E"/>
+            <a:srgbClr val="B8FF58"/>
           </a:solidFill>
         </p:spPr>
       </p:sp>
@@ -11926,7 +12127,7 @@
             <a:r>
               <a:rPr sz="1200" b="1" spc="200">
                 <a:solidFill>
-                  <a:srgbClr val="FFFFFF"/>
+                  <a:srgbClr val="171717"/>
                 </a:solidFill>
                 <a:latin typeface="Arial"/>
                 <a:ea typeface="Arial"/>
@@ -11975,7 +12176,7 @@
             <a:r>
               <a:rPr sz="1500" b="1">
                 <a:solidFill>
-                  <a:srgbClr val="FFFFFF"/>
+                  <a:srgbClr val="171717"/>
                 </a:solidFill>
                 <a:latin typeface="Arial"/>
                 <a:ea typeface="Arial"/>
@@ -12012,7 +12213,7 @@
             </a:avLst>
           </a:prstGeom>
           <a:solidFill xmlns:a="http://schemas.openxmlformats.org/drawingml/2006/main">
-            <a:srgbClr val="1E2747"/>
+            <a:srgbClr val="EDFFD4"/>
           </a:solidFill>
           <a:ln xmlns:a="http://schemas.openxmlformats.org/drawingml/2006/main" w="12700">
             <a:solidFill>
@@ -12045,20 +12246,20 @@
             <a:avLst/>
           </a:prstGeom>
           <a:solidFill xmlns:a="http://schemas.openxmlformats.org/drawingml/2006/main">
-            <a:srgbClr val="FF5A6E"/>
+            <a:srgbClr val="B8FF58"/>
           </a:solidFill>
         </p:spPr>
       </p:sp>
       <p:pic>
         <p:nvPicPr>
-          <p:cNvPr id="30" name="Image 1"/>
+          <p:cNvPr id="31" name="Image 1"/>
           <p:cNvPicPr>
             <a:picLocks xmlns:a="http://schemas.openxmlformats.org/drawingml/2006/main" noChangeAspect="1"/>
           </p:cNvPicPr>
           <p:nvPr/>
         </p:nvPicPr>
         <p:blipFill>
-          <a:blip xmlns:r="http://schemas.openxmlformats.org/officeDocument/2006/relationships" xmlns:a="http://schemas.openxmlformats.org/drawingml/2006/main" r:embed="R9cf10b45fb9d43f5"/>
+          <a:blip xmlns:r="http://schemas.openxmlformats.org/officeDocument/2006/relationships" xmlns:a="http://schemas.openxmlformats.org/drawingml/2006/main" r:embed="R67861b5465054593"/>
           <a:stretch xmlns:a="http://schemas.openxmlformats.org/drawingml/2006/main">
             <a:fillRect l="0" t="0" r="0" b="0"/>
           </a:stretch>
@@ -12110,7 +12311,7 @@
             <a:r>
               <a:rPr sz="1250" b="1">
                 <a:solidFill>
-                  <a:srgbClr val="FFFFFF"/>
+                  <a:srgbClr val="171717"/>
                 </a:solidFill>
                 <a:latin typeface="Arial"/>
                 <a:ea typeface="Arial"/>
@@ -12121,7 +12322,7 @@
             <a:r>
               <a:rPr sz="1250">
                 <a:solidFill>
-                  <a:srgbClr val="CBD5F0"/>
+                  <a:srgbClr val="171717"/>
                 </a:solidFill>
                 <a:latin typeface="Arial"/>
                 <a:ea typeface="Arial"/>
@@ -12167,7 +12368,7 @@
             <a:r>
               <a:rPr sz="900">
                 <a:solidFill>
-                  <a:srgbClr val="9AA3B2"/>
+                  <a:srgbClr val="626262"/>
                 </a:solidFill>
                 <a:latin typeface="Arial"/>
                 <a:ea typeface="Arial"/>
@@ -12213,7 +12414,7 @@
             <a:r>
               <a:rPr sz="900">
                 <a:solidFill>
-                  <a:srgbClr val="9AA3B2"/>
+                  <a:srgbClr val="626262"/>
                 </a:solidFill>
                 <a:latin typeface="Arial"/>
                 <a:ea typeface="Arial"/>
@@ -12225,6 +12426,34 @@
           </a:p>
         </p:txBody>
       </p:sp>
+      <p:pic>
+        <p:nvPicPr>
+          <p:cNvPr id="35" name=""/>
+          <p:cNvPicPr>
+            <a:picLocks xmlns:a="http://schemas.openxmlformats.org/drawingml/2006/main" noChangeAspect="1"/>
+          </p:cNvPicPr>
+          <p:nvPr/>
+        </p:nvPicPr>
+        <p:blipFill>
+          <a:blip xmlns:r="http://schemas.openxmlformats.org/officeDocument/2006/relationships" xmlns:a="http://schemas.openxmlformats.org/drawingml/2006/main" r:embed="Rea87adb2105b4c0a">
+            <a:extLst>
+              <a:ext uri="{96DAC541-7B7A-43D3-8B79-37D633B846F1}">
+                <asvg:svgBlip xmlns:asvg="http://schemas.microsoft.com/office/drawing/2016/SVG/main" r:embed="R14fc18f28b254cb7"/>
+              </a:ext>
+            </a:extLst>
+          </a:blip>
+          <a:stretch xmlns:a="http://schemas.openxmlformats.org/drawingml/2006/main"/>
+        </p:blipFill>
+        <p:spPr>
+          <a:xfrm xmlns:a="http://schemas.openxmlformats.org/drawingml/2006/main">
+            <a:off x="228600" y="228600"/>
+            <a:ext cx="266700" cy="266700"/>
+          </a:xfrm>
+          <a:prstGeom xmlns:a="http://schemas.openxmlformats.org/drawingml/2006/main" prst="rect">
+            <a:avLst/>
+          </a:prstGeom>
+        </p:spPr>
+      </p:pic>
     </p:spTree>
     <p:extLst>
       <p:ext uri="{BB962C8B-B14F-4D97-AF65-F5344CB8AC3E}">
@@ -12241,7 +12470,7 @@
     <p:bg>
       <p:bgPr>
         <a:solidFill xmlns:a="http://schemas.openxmlformats.org/drawingml/2006/main">
-          <a:srgbClr val="F7F5F2"/>
+          <a:srgbClr val="FFFFFF"/>
         </a:solidFill>
       </p:bgPr>
     </p:bg>
@@ -12288,7 +12517,7 @@
             <a:r>
               <a:rPr sz="1200" b="1" spc="300">
                 <a:solidFill>
-                  <a:srgbClr val="FF5A6E"/>
+                  <a:srgbClr val="356B15"/>
                 </a:solidFill>
                 <a:latin typeface="Arial"/>
                 <a:ea typeface="Arial"/>
@@ -12337,11 +12566,11 @@
             <a:r>
               <a:rPr sz="3200" b="1">
                 <a:solidFill>
-                  <a:srgbClr val="1A2138"/>
-                </a:solidFill>
-                <a:latin typeface="Cambria"/>
-                <a:ea typeface="Cambria"/>
-                <a:cs typeface="Cambria"/>
+                  <a:srgbClr val="171717"/>
+                </a:solidFill>
+                <a:latin typeface="Arial"/>
+                <a:ea typeface="Arial"/>
+                <a:cs typeface="Arial"/>
               </a:rPr>
               <a:t>The model was already validated with real money</a:t>
             </a:r>
@@ -12374,7 +12603,7 @@
             </a:avLst>
           </a:prstGeom>
           <a:solidFill xmlns:a="http://schemas.openxmlformats.org/drawingml/2006/main">
-            <a:srgbClr val="E7FBF3"/>
+            <a:srgbClr val="EDFFD4"/>
           </a:solidFill>
           <a:ln xmlns:a="http://schemas.openxmlformats.org/drawingml/2006/main" w="12700">
             <a:solidFill>
@@ -12386,14 +12615,14 @@
       </p:sp>
       <p:pic>
         <p:nvPicPr>
-          <p:cNvPr id="38" name="Image 0"/>
+          <p:cNvPr id="39" name="Image 0"/>
           <p:cNvPicPr>
             <a:picLocks xmlns:a="http://schemas.openxmlformats.org/drawingml/2006/main" noChangeAspect="1"/>
           </p:cNvPicPr>
           <p:nvPr/>
         </p:nvPicPr>
         <p:blipFill>
-          <a:blip xmlns:r="http://schemas.openxmlformats.org/officeDocument/2006/relationships" xmlns:a="http://schemas.openxmlformats.org/drawingml/2006/main" r:embed="R9a4f0ef8436044bd"/>
+          <a:blip xmlns:r="http://schemas.openxmlformats.org/officeDocument/2006/relationships" xmlns:a="http://schemas.openxmlformats.org/drawingml/2006/main" r:embed="R459c10cc92a6439b"/>
           <a:stretch xmlns:a="http://schemas.openxmlformats.org/drawingml/2006/main">
             <a:fillRect l="0" t="0" r="0" b="0"/>
           </a:stretch>
@@ -12442,7 +12671,7 @@
             <a:r>
               <a:rPr sz="1150" b="1">
                 <a:solidFill>
-                  <a:srgbClr val="0F8A66"/>
+                  <a:srgbClr val="356B15"/>
                 </a:solidFill>
                 <a:latin typeface="Arial"/>
                 <a:ea typeface="Arial"/>
@@ -12524,11 +12753,11 @@
             <a:r>
               <a:rPr sz="3300" b="1">
                 <a:solidFill>
-                  <a:srgbClr val="1A2138"/>
-                </a:solidFill>
-                <a:latin typeface="Cambria"/>
-                <a:ea typeface="Cambria"/>
-                <a:cs typeface="Cambria"/>
+                  <a:srgbClr val="171717"/>
+                </a:solidFill>
+                <a:latin typeface="Arial"/>
+                <a:ea typeface="Arial"/>
+                <a:cs typeface="Arial"/>
               </a:rPr>
               <a:t>$489K</a:t>
             </a:r>
@@ -12570,7 +12799,7 @@
             <a:r>
               <a:rPr sz="1200">
                 <a:solidFill>
-                  <a:srgbClr val="6B7280"/>
+                  <a:srgbClr val="626262"/>
                 </a:solidFill>
                 <a:latin typeface="Arial"/>
                 <a:ea typeface="Arial"/>
@@ -12652,11 +12881,11 @@
             <a:r>
               <a:rPr sz="3300" b="1">
                 <a:solidFill>
-                  <a:srgbClr val="1A2138"/>
-                </a:solidFill>
-                <a:latin typeface="Cambria"/>
-                <a:ea typeface="Cambria"/>
-                <a:cs typeface="Cambria"/>
+                  <a:srgbClr val="171717"/>
+                </a:solidFill>
+                <a:latin typeface="Arial"/>
+                <a:ea typeface="Arial"/>
+                <a:cs typeface="Arial"/>
               </a:rPr>
               <a:t>14.3K</a:t>
             </a:r>
@@ -12698,7 +12927,7 @@
             <a:r>
               <a:rPr sz="1200">
                 <a:solidFill>
-                  <a:srgbClr val="6B7280"/>
+                  <a:srgbClr val="626262"/>
                 </a:solidFill>
                 <a:latin typeface="Arial"/>
                 <a:ea typeface="Arial"/>
@@ -12780,11 +13009,11 @@
             <a:r>
               <a:rPr sz="3300" b="1">
                 <a:solidFill>
-                  <a:srgbClr val="1A2138"/>
-                </a:solidFill>
-                <a:latin typeface="Cambria"/>
-                <a:ea typeface="Cambria"/>
-                <a:cs typeface="Cambria"/>
+                  <a:srgbClr val="171717"/>
+                </a:solidFill>
+                <a:latin typeface="Arial"/>
+                <a:ea typeface="Arial"/>
+                <a:cs typeface="Arial"/>
               </a:rPr>
               <a:t>7.6K</a:t>
             </a:r>
@@ -12826,7 +13055,7 @@
             <a:r>
               <a:rPr sz="1200">
                 <a:solidFill>
-                  <a:srgbClr val="6B7280"/>
+                  <a:srgbClr val="626262"/>
                 </a:solidFill>
                 <a:latin typeface="Arial"/>
                 <a:ea typeface="Arial"/>
@@ -12908,11 +13137,11 @@
             <a:r>
               <a:rPr sz="3300" b="1">
                 <a:solidFill>
-                  <a:srgbClr val="1A2138"/>
-                </a:solidFill>
-                <a:latin typeface="Cambria"/>
-                <a:ea typeface="Cambria"/>
-                <a:cs typeface="Cambria"/>
+                  <a:srgbClr val="171717"/>
+                </a:solidFill>
+                <a:latin typeface="Arial"/>
+                <a:ea typeface="Arial"/>
+                <a:cs typeface="Arial"/>
               </a:rPr>
               <a:t>$1.3M</a:t>
             </a:r>
@@ -12954,7 +13183,7 @@
             <a:r>
               <a:rPr sz="1200">
                 <a:solidFill>
-                  <a:srgbClr val="6B7280"/>
+                  <a:srgbClr val="626262"/>
                 </a:solidFill>
                 <a:latin typeface="Arial"/>
                 <a:ea typeface="Arial"/>
@@ -13036,11 +13265,11 @@
             <a:r>
               <a:rPr sz="3300" b="1">
                 <a:solidFill>
-                  <a:srgbClr val="1A2138"/>
-                </a:solidFill>
-                <a:latin typeface="Cambria"/>
-                <a:ea typeface="Cambria"/>
-                <a:cs typeface="Cambria"/>
+                  <a:srgbClr val="171717"/>
+                </a:solidFill>
+                <a:latin typeface="Arial"/>
+                <a:ea typeface="Arial"/>
+                <a:cs typeface="Arial"/>
               </a:rPr>
               <a:t>~$8</a:t>
             </a:r>
@@ -13082,7 +13311,7 @@
             <a:r>
               <a:rPr sz="1200">
                 <a:solidFill>
-                  <a:srgbClr val="6B7280"/>
+                  <a:srgbClr val="626262"/>
                 </a:solidFill>
                 <a:latin typeface="Arial"/>
                 <a:ea typeface="Arial"/>
@@ -13164,11 +13393,11 @@
             <a:r>
               <a:rPr sz="3300" b="1">
                 <a:solidFill>
-                  <a:srgbClr val="1A2138"/>
-                </a:solidFill>
-                <a:latin typeface="Cambria"/>
-                <a:ea typeface="Cambria"/>
-                <a:cs typeface="Cambria"/>
+                  <a:srgbClr val="171717"/>
+                </a:solidFill>
+                <a:latin typeface="Arial"/>
+                <a:ea typeface="Arial"/>
+                <a:cs typeface="Arial"/>
               </a:rPr>
               <a:t>~$0.09</a:t>
             </a:r>
@@ -13210,7 +13439,7 @@
             <a:r>
               <a:rPr sz="1200">
                 <a:solidFill>
-                  <a:srgbClr val="6B7280"/>
+                  <a:srgbClr val="626262"/>
                 </a:solidFill>
                 <a:latin typeface="Arial"/>
                 <a:ea typeface="Arial"/>
@@ -13292,11 +13521,11 @@
             <a:r>
               <a:rPr sz="3300" b="1">
                 <a:solidFill>
-                  <a:srgbClr val="1A2138"/>
-                </a:solidFill>
-                <a:latin typeface="Cambria"/>
-                <a:ea typeface="Cambria"/>
-                <a:cs typeface="Cambria"/>
+                  <a:srgbClr val="171717"/>
+                </a:solidFill>
+                <a:latin typeface="Arial"/>
+                <a:ea typeface="Arial"/>
+                <a:cs typeface="Arial"/>
               </a:rPr>
               <a:t>$34</a:t>
             </a:r>
@@ -13338,7 +13567,7 @@
             <a:r>
               <a:rPr sz="1200">
                 <a:solidFill>
-                  <a:srgbClr val="6B7280"/>
+                  <a:srgbClr val="626262"/>
                 </a:solidFill>
                 <a:latin typeface="Arial"/>
                 <a:ea typeface="Arial"/>
@@ -13420,11 +13649,11 @@
             <a:r>
               <a:rPr sz="3300" b="1">
                 <a:solidFill>
-                  <a:srgbClr val="1A2138"/>
-                </a:solidFill>
-                <a:latin typeface="Cambria"/>
-                <a:ea typeface="Cambria"/>
-                <a:cs typeface="Cambria"/>
+                  <a:srgbClr val="171717"/>
+                </a:solidFill>
+                <a:latin typeface="Arial"/>
+                <a:ea typeface="Arial"/>
+                <a:cs typeface="Arial"/>
               </a:rPr>
               <a:t>11-13.5%</a:t>
             </a:r>
@@ -13466,7 +13695,7 @@
             <a:r>
               <a:rPr sz="1200">
                 <a:solidFill>
-                  <a:srgbClr val="6B7280"/>
+                  <a:srgbClr val="626262"/>
                 </a:solidFill>
                 <a:latin typeface="Arial"/>
                 <a:ea typeface="Arial"/>
@@ -13515,7 +13744,7 @@
             <a:r>
               <a:rPr sz="1250" b="1">
                 <a:solidFill>
-                  <a:srgbClr val="1A2138"/>
+                  <a:srgbClr val="171717"/>
                 </a:solidFill>
                 <a:latin typeface="Arial"/>
                 <a:ea typeface="Arial"/>
@@ -13526,7 +13755,7 @@
             <a:r>
               <a:rPr sz="1250">
                 <a:solidFill>
-                  <a:srgbClr val="6B7280"/>
+                  <a:srgbClr val="171717"/>
                 </a:solidFill>
                 <a:latin typeface="Arial"/>
                 <a:ea typeface="Arial"/>
@@ -13572,7 +13801,7 @@
             <a:r>
               <a:rPr sz="900">
                 <a:solidFill>
-                  <a:srgbClr val="6B7280"/>
+                  <a:srgbClr val="626262"/>
                 </a:solidFill>
                 <a:latin typeface="Arial"/>
                 <a:ea typeface="Arial"/>
@@ -13618,7 +13847,7 @@
             <a:r>
               <a:rPr sz="900">
                 <a:solidFill>
-                  <a:srgbClr val="6B7280"/>
+                  <a:srgbClr val="626262"/>
                 </a:solidFill>
                 <a:latin typeface="Arial"/>
                 <a:ea typeface="Arial"/>
@@ -13630,6 +13859,34 @@
           </a:p>
         </p:txBody>
       </p:sp>
+      <p:pic>
+        <p:nvPicPr>
+          <p:cNvPr id="68" name=""/>
+          <p:cNvPicPr>
+            <a:picLocks xmlns:a="http://schemas.openxmlformats.org/drawingml/2006/main" noChangeAspect="1"/>
+          </p:cNvPicPr>
+          <p:nvPr/>
+        </p:nvPicPr>
+        <p:blipFill>
+          <a:blip xmlns:r="http://schemas.openxmlformats.org/officeDocument/2006/relationships" xmlns:a="http://schemas.openxmlformats.org/drawingml/2006/main" r:embed="Ra2cd6554af7c49c0">
+            <a:extLst>
+              <a:ext uri="{96DAC541-7B7A-43D3-8B79-37D633B846F1}">
+                <asvg:svgBlip xmlns:asvg="http://schemas.microsoft.com/office/drawing/2016/SVG/main" r:embed="Re2dbabcd81504355"/>
+              </a:ext>
+            </a:extLst>
+          </a:blip>
+          <a:stretch xmlns:a="http://schemas.openxmlformats.org/drawingml/2006/main"/>
+        </p:blipFill>
+        <p:spPr>
+          <a:xfrm xmlns:a="http://schemas.openxmlformats.org/drawingml/2006/main">
+            <a:off x="228600" y="228600"/>
+            <a:ext cx="266700" cy="266700"/>
+          </a:xfrm>
+          <a:prstGeom xmlns:a="http://schemas.openxmlformats.org/drawingml/2006/main" prst="rect">
+            <a:avLst/>
+          </a:prstGeom>
+        </p:spPr>
+      </p:pic>
     </p:spTree>
     <p:extLst>
       <p:ext uri="{BB962C8B-B14F-4D97-AF65-F5344CB8AC3E}">
@@ -13646,7 +13903,7 @@
     <p:bg>
       <p:bgPr>
         <a:solidFill xmlns:a="http://schemas.openxmlformats.org/drawingml/2006/main">
-          <a:srgbClr val="F7F5F2"/>
+          <a:srgbClr val="FFFFFF"/>
         </a:solidFill>
       </p:bgPr>
     </p:bg>
@@ -13693,7 +13950,7 @@
             <a:r>
               <a:rPr sz="1200" b="1" spc="300">
                 <a:solidFill>
-                  <a:srgbClr val="FF5A6E"/>
+                  <a:srgbClr val="356B15"/>
                 </a:solidFill>
                 <a:latin typeface="Arial"/>
                 <a:ea typeface="Arial"/>
@@ -13742,11 +13999,11 @@
             <a:r>
               <a:rPr sz="3200" b="1">
                 <a:solidFill>
-                  <a:srgbClr val="1A2138"/>
-                </a:solidFill>
-                <a:latin typeface="Cambria"/>
-                <a:ea typeface="Cambria"/>
-                <a:cs typeface="Cambria"/>
+                  <a:srgbClr val="171717"/>
+                </a:solidFill>
+                <a:latin typeface="Arial"/>
+                <a:ea typeface="Arial"/>
+                <a:cs typeface="Arial"/>
               </a:rPr>
               <a:t>A large market where we don't fight incumbents head-on</a:t>
             </a:r>
@@ -13779,7 +14036,7 @@
             </a:avLst>
           </a:prstGeom>
           <a:solidFill xmlns:a="http://schemas.openxmlformats.org/drawingml/2006/main">
-            <a:srgbClr val="141B34"/>
+            <a:srgbClr val="171717"/>
           </a:solidFill>
         </p:spPr>
       </p:sp>
@@ -13817,7 +14074,7 @@
             <a:r>
               <a:rPr sz="1300" b="1" spc="200">
                 <a:solidFill>
-                  <a:srgbClr val="CBD5F0"/>
+                  <a:srgbClr val="FFFFFF"/>
                 </a:solidFill>
                 <a:latin typeface="Arial"/>
                 <a:ea typeface="Arial"/>
@@ -13865,9 +14122,9 @@
                 <a:solidFill>
                   <a:srgbClr val="FFFFFF"/>
                 </a:solidFill>
-                <a:latin typeface="Cambria"/>
-                <a:ea typeface="Cambria"/>
-                <a:cs typeface="Cambria"/>
+                <a:latin typeface="Arial"/>
+                <a:ea typeface="Arial"/>
+                <a:cs typeface="Arial"/>
               </a:rPr>
               <a:t>$1.0T+</a:t>
             </a:r>
@@ -13912,7 +14169,7 @@
             <a:r>
               <a:rPr sz="1100">
                 <a:solidFill>
-                  <a:srgbClr val="CBD5F0"/>
+                  <a:srgbClr val="FFFFFF"/>
                 </a:solidFill>
                 <a:latin typeface="Arial"/>
                 <a:ea typeface="Arial"/>
@@ -13949,7 +14206,7 @@
             </a:avLst>
           </a:prstGeom>
           <a:solidFill xmlns:a="http://schemas.openxmlformats.org/drawingml/2006/main">
-            <a:srgbClr val="2A3557"/>
+            <a:srgbClr val="14210A"/>
           </a:solidFill>
         </p:spPr>
       </p:sp>
@@ -13987,7 +14244,7 @@
             <a:r>
               <a:rPr sz="1300" b="1" spc="200">
                 <a:solidFill>
-                  <a:srgbClr val="CBD5F0"/>
+                  <a:srgbClr val="FFFFFF"/>
                 </a:solidFill>
                 <a:latin typeface="Arial"/>
                 <a:ea typeface="Arial"/>
@@ -14035,9 +14292,9 @@
                 <a:solidFill>
                   <a:srgbClr val="FFFFFF"/>
                 </a:solidFill>
-                <a:latin typeface="Cambria"/>
-                <a:ea typeface="Cambria"/>
-                <a:cs typeface="Cambria"/>
+                <a:latin typeface="Arial"/>
+                <a:ea typeface="Arial"/>
+                <a:cs typeface="Arial"/>
               </a:rPr>
               <a:t>$150-200B</a:t>
             </a:r>
@@ -14082,7 +14339,7 @@
             <a:r>
               <a:rPr sz="1100">
                 <a:solidFill>
-                  <a:srgbClr val="CBD5F0"/>
+                  <a:srgbClr val="FFFFFF"/>
                 </a:solidFill>
                 <a:latin typeface="Arial"/>
                 <a:ea typeface="Arial"/>
@@ -14119,7 +14376,7 @@
             </a:avLst>
           </a:prstGeom>
           <a:solidFill xmlns:a="http://schemas.openxmlformats.org/drawingml/2006/main">
-            <a:srgbClr val="FF5A6E"/>
+            <a:srgbClr val="B8FF58"/>
           </a:solidFill>
         </p:spPr>
       </p:sp>
@@ -14157,7 +14414,7 @@
             <a:r>
               <a:rPr sz="1300" b="1" spc="200">
                 <a:solidFill>
-                  <a:srgbClr val="FFECEF"/>
+                  <a:srgbClr val="356B15"/>
                 </a:solidFill>
                 <a:latin typeface="Arial"/>
                 <a:ea typeface="Arial"/>
@@ -14203,11 +14460,11 @@
             <a:r>
               <a:rPr sz="2700" b="1">
                 <a:solidFill>
-                  <a:srgbClr val="FFFFFF"/>
-                </a:solidFill>
-                <a:latin typeface="Cambria"/>
-                <a:ea typeface="Cambria"/>
-                <a:cs typeface="Cambria"/>
+                  <a:srgbClr val="171717"/>
+                </a:solidFill>
+                <a:latin typeface="Arial"/>
+                <a:ea typeface="Arial"/>
+                <a:cs typeface="Arial"/>
               </a:rPr>
               <a:t>$10-20B</a:t>
             </a:r>
@@ -14252,7 +14509,7 @@
             <a:r>
               <a:rPr sz="1100">
                 <a:solidFill>
-                  <a:srgbClr val="FFECEF"/>
+                  <a:srgbClr val="356B15"/>
                 </a:solidFill>
                 <a:latin typeface="Arial"/>
                 <a:ea typeface="Arial"/>
@@ -14334,7 +14591,7 @@
             <a:r>
               <a:rPr sz="1400" b="1">
                 <a:solidFill>
-                  <a:srgbClr val="1A2138"/>
+                  <a:srgbClr val="171717"/>
                 </a:solidFill>
                 <a:latin typeface="Arial"/>
                 <a:ea typeface="Arial"/>
@@ -14369,7 +14626,7 @@
             <a:avLst/>
           </a:prstGeom>
           <a:solidFill xmlns:a="http://schemas.openxmlformats.org/drawingml/2006/main">
-            <a:srgbClr val="FF5A6E"/>
+            <a:srgbClr val="B8FF58"/>
           </a:solidFill>
         </p:spPr>
       </p:sp>
@@ -14407,7 +14664,7 @@
             <a:r>
               <a:rPr sz="1350" b="1">
                 <a:solidFill>
-                  <a:srgbClr val="1A2138"/>
+                  <a:srgbClr val="171717"/>
                 </a:solidFill>
                 <a:latin typeface="Arial"/>
                 <a:ea typeface="Arial"/>
@@ -14456,7 +14713,7 @@
             <a:r>
               <a:rPr sz="1100">
                 <a:solidFill>
-                  <a:srgbClr val="6B7280"/>
+                  <a:srgbClr val="626262"/>
                 </a:solidFill>
                 <a:latin typeface="Arial"/>
                 <a:ea typeface="Arial"/>
@@ -14491,7 +14748,7 @@
             <a:avLst/>
           </a:prstGeom>
           <a:solidFill xmlns:a="http://schemas.openxmlformats.org/drawingml/2006/main">
-            <a:srgbClr val="FF5A6E"/>
+            <a:srgbClr val="B8FF58"/>
           </a:solidFill>
         </p:spPr>
       </p:sp>
@@ -14529,7 +14786,7 @@
             <a:r>
               <a:rPr sz="1350" b="1">
                 <a:solidFill>
-                  <a:srgbClr val="1A2138"/>
+                  <a:srgbClr val="171717"/>
                 </a:solidFill>
                 <a:latin typeface="Arial"/>
                 <a:ea typeface="Arial"/>
@@ -14578,7 +14835,7 @@
             <a:r>
               <a:rPr sz="1100">
                 <a:solidFill>
-                  <a:srgbClr val="6B7280"/>
+                  <a:srgbClr val="626262"/>
                 </a:solidFill>
                 <a:latin typeface="Arial"/>
                 <a:ea typeface="Arial"/>
@@ -14613,7 +14870,7 @@
             <a:avLst/>
           </a:prstGeom>
           <a:solidFill xmlns:a="http://schemas.openxmlformats.org/drawingml/2006/main">
-            <a:srgbClr val="FF5A6E"/>
+            <a:srgbClr val="B8FF58"/>
           </a:solidFill>
         </p:spPr>
       </p:sp>
@@ -14651,7 +14908,7 @@
             <a:r>
               <a:rPr sz="1350" b="1">
                 <a:solidFill>
-                  <a:srgbClr val="1A2138"/>
+                  <a:srgbClr val="171717"/>
                 </a:solidFill>
                 <a:latin typeface="Arial"/>
                 <a:ea typeface="Arial"/>
@@ -14700,7 +14957,7 @@
             <a:r>
               <a:rPr sz="1100">
                 <a:solidFill>
-                  <a:srgbClr val="6B7280"/>
+                  <a:srgbClr val="626262"/>
                 </a:solidFill>
                 <a:latin typeface="Arial"/>
                 <a:ea typeface="Arial"/>
@@ -14746,7 +15003,7 @@
             <a:r>
               <a:rPr sz="900">
                 <a:solidFill>
-                  <a:srgbClr val="6B7280"/>
+                  <a:srgbClr val="626262"/>
                 </a:solidFill>
                 <a:latin typeface="Arial"/>
                 <a:ea typeface="Arial"/>
@@ -14792,7 +15049,7 @@
             <a:r>
               <a:rPr sz="900">
                 <a:solidFill>
-                  <a:srgbClr val="6B7280"/>
+                  <a:srgbClr val="626262"/>
                 </a:solidFill>
                 <a:latin typeface="Arial"/>
                 <a:ea typeface="Arial"/>
@@ -14838,7 +15095,7 @@
             <a:r>
               <a:rPr sz="900">
                 <a:solidFill>
-                  <a:srgbClr val="6B7280"/>
+                  <a:srgbClr val="626262"/>
                 </a:solidFill>
                 <a:latin typeface="Arial"/>
                 <a:ea typeface="Arial"/>
@@ -14850,6 +15107,34 @@
           </a:p>
         </p:txBody>
       </p:sp>
+      <p:pic>
+        <p:nvPicPr>
+          <p:cNvPr id="59" name=""/>
+          <p:cNvPicPr>
+            <a:picLocks xmlns:a="http://schemas.openxmlformats.org/drawingml/2006/main" noChangeAspect="1"/>
+          </p:cNvPicPr>
+          <p:nvPr/>
+        </p:nvPicPr>
+        <p:blipFill>
+          <a:blip xmlns:r="http://schemas.openxmlformats.org/officeDocument/2006/relationships" xmlns:a="http://schemas.openxmlformats.org/drawingml/2006/main" r:embed="Rd24272a0c12646e5">
+            <a:extLst>
+              <a:ext uri="{96DAC541-7B7A-43D3-8B79-37D633B846F1}">
+                <asvg:svgBlip xmlns:asvg="http://schemas.microsoft.com/office/drawing/2016/SVG/main" r:embed="R102cb29bb06f41a8"/>
+              </a:ext>
+            </a:extLst>
+          </a:blip>
+          <a:stretch xmlns:a="http://schemas.openxmlformats.org/drawingml/2006/main"/>
+        </p:blipFill>
+        <p:spPr>
+          <a:xfrm xmlns:a="http://schemas.openxmlformats.org/drawingml/2006/main">
+            <a:off x="228600" y="228600"/>
+            <a:ext cx="266700" cy="266700"/>
+          </a:xfrm>
+          <a:prstGeom xmlns:a="http://schemas.openxmlformats.org/drawingml/2006/main" prst="rect">
+            <a:avLst/>
+          </a:prstGeom>
+        </p:spPr>
+      </p:pic>
     </p:spTree>
     <p:extLst>
       <p:ext uri="{BB962C8B-B14F-4D97-AF65-F5344CB8AC3E}">

</xml_diff>

<commit_message>
Use raster SuperCheap icon and remove working name
</commit_message>
<xml_diff>
--- a/pitch/supercheap.market.pptx
+++ b/pitch/supercheap.market.pptx
@@ -2,24 +2,24 @@
 <file path=ppt/presentation.xml><?xml version="1.0" encoding="utf-8"?>
 <p:presentation xmlns:p="http://schemas.openxmlformats.org/presentationml/2006/main">
   <p:sldMasterIdLst>
-    <p:sldMasterId xmlns:r="http://schemas.openxmlformats.org/officeDocument/2006/relationships" id="2147483648" r:id="Re52a6f5b920a49f8"/>
+    <p:sldMasterId xmlns:r="http://schemas.openxmlformats.org/officeDocument/2006/relationships" id="2147483648" r:id="R6ae01d8915a94290"/>
   </p:sldMasterIdLst>
   <p:notesMasterIdLst>
-    <p:notesMasterId xmlns:r="http://schemas.openxmlformats.org/officeDocument/2006/relationships" r:id="R0422dae34d5d41fd"/>
+    <p:notesMasterId xmlns:r="http://schemas.openxmlformats.org/officeDocument/2006/relationships" r:id="R7c7a5d9ac6ed45b3"/>
   </p:notesMasterIdLst>
   <p:sldIdLst>
-    <p:sldId xmlns:r="http://schemas.openxmlformats.org/officeDocument/2006/relationships" id="256" r:id="Rd206ee0c2935424f"/>
-    <p:sldId xmlns:r="http://schemas.openxmlformats.org/officeDocument/2006/relationships" id="257" r:id="R1e09785dce364ef3"/>
-    <p:sldId xmlns:r="http://schemas.openxmlformats.org/officeDocument/2006/relationships" id="258" r:id="Rc43b97442d994e0b"/>
-    <p:sldId xmlns:r="http://schemas.openxmlformats.org/officeDocument/2006/relationships" id="259" r:id="R5035a46671c74a2f"/>
-    <p:sldId xmlns:r="http://schemas.openxmlformats.org/officeDocument/2006/relationships" id="260" r:id="Re31b17a5117a4b70"/>
-    <p:sldId xmlns:r="http://schemas.openxmlformats.org/officeDocument/2006/relationships" id="261" r:id="Re737e4dfa5a946f8"/>
-    <p:sldId xmlns:r="http://schemas.openxmlformats.org/officeDocument/2006/relationships" id="262" r:id="Ra5695431bcda4aef"/>
-    <p:sldId xmlns:r="http://schemas.openxmlformats.org/officeDocument/2006/relationships" id="263" r:id="R62f31a6504f24367"/>
-    <p:sldId xmlns:r="http://schemas.openxmlformats.org/officeDocument/2006/relationships" id="264" r:id="Rc2586edb37664b22"/>
-    <p:sldId xmlns:r="http://schemas.openxmlformats.org/officeDocument/2006/relationships" id="265" r:id="R1fd5cd6d3a0b4510"/>
-    <p:sldId xmlns:r="http://schemas.openxmlformats.org/officeDocument/2006/relationships" id="266" r:id="R828e66dff9284bef"/>
-    <p:sldId xmlns:r="http://schemas.openxmlformats.org/officeDocument/2006/relationships" id="267" r:id="Rf04dd785c1284633"/>
+    <p:sldId xmlns:r="http://schemas.openxmlformats.org/officeDocument/2006/relationships" id="256" r:id="R614a79c7eecb4c11"/>
+    <p:sldId xmlns:r="http://schemas.openxmlformats.org/officeDocument/2006/relationships" id="257" r:id="R55f7e49261154a62"/>
+    <p:sldId xmlns:r="http://schemas.openxmlformats.org/officeDocument/2006/relationships" id="258" r:id="Ra8977cd29f174e90"/>
+    <p:sldId xmlns:r="http://schemas.openxmlformats.org/officeDocument/2006/relationships" id="259" r:id="R59797605872641d5"/>
+    <p:sldId xmlns:r="http://schemas.openxmlformats.org/officeDocument/2006/relationships" id="260" r:id="R9598f20dc65c4eca"/>
+    <p:sldId xmlns:r="http://schemas.openxmlformats.org/officeDocument/2006/relationships" id="261" r:id="Rbbb00edf93584306"/>
+    <p:sldId xmlns:r="http://schemas.openxmlformats.org/officeDocument/2006/relationships" id="262" r:id="Rf1ddfe94315b41df"/>
+    <p:sldId xmlns:r="http://schemas.openxmlformats.org/officeDocument/2006/relationships" id="263" r:id="Re1b29b93e31f4610"/>
+    <p:sldId xmlns:r="http://schemas.openxmlformats.org/officeDocument/2006/relationships" id="264" r:id="R6887a6ff56054ba8"/>
+    <p:sldId xmlns:r="http://schemas.openxmlformats.org/officeDocument/2006/relationships" id="265" r:id="Re328241f14cd4929"/>
+    <p:sldId xmlns:r="http://schemas.openxmlformats.org/officeDocument/2006/relationships" id="266" r:id="R6a4813ccf9a7409f"/>
+    <p:sldId xmlns:r="http://schemas.openxmlformats.org/officeDocument/2006/relationships" id="267" r:id="Rd5c6a8be1e4c4b97"/>
   </p:sldIdLst>
   <p:sldSz cx="12192000" cy="6858000"/>
   <p:notesSz cx="6858000" cy="9144000"/>
@@ -1343,7 +1343,7 @@
   </p:cSld>
   <p:clrMap bg1="lt1" tx1="dk1" bg2="lt2" tx2="dk2" accent1="accent1" accent2="accent2" accent3="accent3" accent4="accent4" accent5="accent5" accent6="accent6" hlink="hlink" folHlink="folHlink"/>
   <p:sldLayoutIdLst>
-    <p:sldLayoutId xmlns:r="http://schemas.openxmlformats.org/officeDocument/2006/relationships" id="2147483649" r:id="R872b9e6e6e6d43c6"/>
+    <p:sldLayoutId xmlns:r="http://schemas.openxmlformats.org/officeDocument/2006/relationships" id="2147483649" r:id="Rc46e104ef8c340bf"/>
   </p:sldLayoutIdLst>
   <p:hf sldNum="0" hdr="0" ftr="0" dt="0"/>
   <p:txStyles>
@@ -2003,7 +2003,7 @@
                 <a:ea typeface="Arial"/>
                 <a:cs typeface="Arial"/>
               </a:rPr>
-              <a:t>supercheap.market · working name</a:t>
+              <a:t>supercheap.market</a:t>
             </a:r>
             <a:endParaRPr sz="1300"/>
           </a:p>
@@ -2367,7 +2367,7 @@
           <p:nvPr/>
         </p:nvPicPr>
         <p:blipFill>
-          <a:blip xmlns:r="http://schemas.openxmlformats.org/officeDocument/2006/relationships" xmlns:a="http://schemas.openxmlformats.org/drawingml/2006/main" r:embed="Rcdc4df2fa0c849c0"/>
+          <a:blip xmlns:r="http://schemas.openxmlformats.org/officeDocument/2006/relationships" xmlns:a="http://schemas.openxmlformats.org/drawingml/2006/main" r:embed="Rc627796f687341f2"/>
           <a:stretch xmlns:a="http://schemas.openxmlformats.org/drawingml/2006/main"/>
         </p:blipFill>
         <p:spPr>
@@ -2389,14 +2389,11 @@
           <p:nvPr/>
         </p:nvPicPr>
         <p:blipFill>
-          <a:blip xmlns:r="http://schemas.openxmlformats.org/officeDocument/2006/relationships" xmlns:a="http://schemas.openxmlformats.org/drawingml/2006/main" r:embed="R0c24cbda5e77485d">
-            <a:extLst>
-              <a:ext uri="{96DAC541-7B7A-43D3-8B79-37D633B846F1}">
-                <asvg:svgBlip xmlns:asvg="http://schemas.microsoft.com/office/drawing/2016/SVG/main" r:embed="R48b3d6fa390545fe"/>
-              </a:ext>
-            </a:extLst>
-          </a:blip>
-          <a:stretch xmlns:a="http://schemas.openxmlformats.org/drawingml/2006/main"/>
+          <a:blip xmlns:r="http://schemas.openxmlformats.org/officeDocument/2006/relationships" xmlns:a="http://schemas.openxmlformats.org/drawingml/2006/main" r:embed="R9d0bd879699043cb"/>
+          <a:srcRect xmlns:a="http://schemas.openxmlformats.org/drawingml/2006/main" l="0" t="0" r="0" b="0"/>
+          <a:stretch xmlns:a="http://schemas.openxmlformats.org/drawingml/2006/main">
+            <a:fillRect l="0" t="0" r="0" b="0"/>
+          </a:stretch>
         </p:blipFill>
         <p:spPr>
           <a:xfrm xmlns:a="http://schemas.openxmlformats.org/drawingml/2006/main">
@@ -2895,7 +2892,7 @@
           <p:nvPr/>
         </p:nvPicPr>
         <p:blipFill>
-          <a:blip xmlns:r="http://schemas.openxmlformats.org/officeDocument/2006/relationships" xmlns:a="http://schemas.openxmlformats.org/drawingml/2006/main" r:embed="R06b0f9d15cb14717"/>
+          <a:blip xmlns:r="http://schemas.openxmlformats.org/officeDocument/2006/relationships" xmlns:a="http://schemas.openxmlformats.org/drawingml/2006/main" r:embed="R28cd7656d1c1436a"/>
           <a:stretch xmlns:a="http://schemas.openxmlformats.org/drawingml/2006/main">
             <a:fillRect l="0" t="0" r="0" b="0"/>
           </a:stretch>
@@ -3074,7 +3071,7 @@
           <p:nvPr/>
         </p:nvPicPr>
         <p:blipFill>
-          <a:blip xmlns:r="http://schemas.openxmlformats.org/officeDocument/2006/relationships" xmlns:a="http://schemas.openxmlformats.org/drawingml/2006/main" r:embed="Rdd0a3c4a4d214ca2"/>
+          <a:blip xmlns:r="http://schemas.openxmlformats.org/officeDocument/2006/relationships" xmlns:a="http://schemas.openxmlformats.org/drawingml/2006/main" r:embed="Rcd83367b93884597"/>
           <a:stretch xmlns:a="http://schemas.openxmlformats.org/drawingml/2006/main">
             <a:fillRect l="0" t="0" r="0" b="0"/>
           </a:stretch>
@@ -3253,7 +3250,7 @@
           <p:nvPr/>
         </p:nvPicPr>
         <p:blipFill>
-          <a:blip xmlns:r="http://schemas.openxmlformats.org/officeDocument/2006/relationships" xmlns:a="http://schemas.openxmlformats.org/drawingml/2006/main" r:embed="R6a367b88ade14907"/>
+          <a:blip xmlns:r="http://schemas.openxmlformats.org/officeDocument/2006/relationships" xmlns:a="http://schemas.openxmlformats.org/drawingml/2006/main" r:embed="Rfc9317f99dbe496e"/>
           <a:stretch xmlns:a="http://schemas.openxmlformats.org/drawingml/2006/main">
             <a:fillRect l="0" t="0" r="0" b="0"/>
           </a:stretch>
@@ -3432,7 +3429,7 @@
           <p:nvPr/>
         </p:nvPicPr>
         <p:blipFill>
-          <a:blip xmlns:r="http://schemas.openxmlformats.org/officeDocument/2006/relationships" xmlns:a="http://schemas.openxmlformats.org/drawingml/2006/main" r:embed="R44c4d5a93f8641aa"/>
+          <a:blip xmlns:r="http://schemas.openxmlformats.org/officeDocument/2006/relationships" xmlns:a="http://schemas.openxmlformats.org/drawingml/2006/main" r:embed="Reb07c87136104c6a"/>
           <a:stretch xmlns:a="http://schemas.openxmlformats.org/drawingml/2006/main">
             <a:fillRect l="0" t="0" r="0" b="0"/>
           </a:stretch>
@@ -3579,7 +3576,7 @@
                 <a:ea typeface="Arial"/>
                 <a:cs typeface="Arial"/>
               </a:rPr>
-              <a:t>SuperCheap.market  ·  working name</a:t>
+              <a:t>SuperCheap.market</a:t>
             </a:r>
             <a:endParaRPr sz="900"/>
           </a:p>
@@ -3640,14 +3637,11 @@
           <p:nvPr/>
         </p:nvPicPr>
         <p:blipFill>
-          <a:blip xmlns:r="http://schemas.openxmlformats.org/officeDocument/2006/relationships" xmlns:a="http://schemas.openxmlformats.org/drawingml/2006/main" r:embed="R1d47d27fb7ac4ec4">
-            <a:extLst>
-              <a:ext uri="{96DAC541-7B7A-43D3-8B79-37D633B846F1}">
-                <asvg:svgBlip xmlns:asvg="http://schemas.microsoft.com/office/drawing/2016/SVG/main" r:embed="Rab55b48b441b490d"/>
-              </a:ext>
-            </a:extLst>
-          </a:blip>
-          <a:stretch xmlns:a="http://schemas.openxmlformats.org/drawingml/2006/main"/>
+          <a:blip xmlns:r="http://schemas.openxmlformats.org/officeDocument/2006/relationships" xmlns:a="http://schemas.openxmlformats.org/drawingml/2006/main" r:embed="R72aaf147d1a14c4e"/>
+          <a:srcRect xmlns:a="http://schemas.openxmlformats.org/drawingml/2006/main" l="0" t="0" r="0" b="0"/>
+          <a:stretch xmlns:a="http://schemas.openxmlformats.org/drawingml/2006/main">
+            <a:fillRect l="0" t="0" r="0" b="0"/>
+          </a:stretch>
         </p:blipFill>
         <p:spPr>
           <a:xfrm xmlns:a="http://schemas.openxmlformats.org/drawingml/2006/main">
@@ -3819,7 +3813,7 @@
           <p:nvPr/>
         </p:nvPicPr>
         <p:blipFill>
-          <a:blip xmlns:r="http://schemas.openxmlformats.org/officeDocument/2006/relationships" xmlns:a="http://schemas.openxmlformats.org/drawingml/2006/main" r:embed="R0727b8f23ac14098"/>
+          <a:blip xmlns:r="http://schemas.openxmlformats.org/officeDocument/2006/relationships" xmlns:a="http://schemas.openxmlformats.org/drawingml/2006/main" r:embed="R6c8ec2a270824689"/>
           <a:stretch xmlns:a="http://schemas.openxmlformats.org/drawingml/2006/main">
             <a:fillRect l="0" t="0" r="0" b="0"/>
           </a:stretch>
@@ -4046,7 +4040,7 @@
           <p:nvPr/>
         </p:nvPicPr>
         <p:blipFill>
-          <a:blip xmlns:r="http://schemas.openxmlformats.org/officeDocument/2006/relationships" xmlns:a="http://schemas.openxmlformats.org/drawingml/2006/main" r:embed="R782b520997654d15"/>
+          <a:blip xmlns:r="http://schemas.openxmlformats.org/officeDocument/2006/relationships" xmlns:a="http://schemas.openxmlformats.org/drawingml/2006/main" r:embed="R97112a43a18b484a"/>
           <a:stretch xmlns:a="http://schemas.openxmlformats.org/drawingml/2006/main">
             <a:fillRect l="0" t="0" r="0" b="0"/>
           </a:stretch>
@@ -4227,7 +4221,7 @@
           <p:nvPr/>
         </p:nvPicPr>
         <p:blipFill>
-          <a:blip xmlns:r="http://schemas.openxmlformats.org/officeDocument/2006/relationships" xmlns:a="http://schemas.openxmlformats.org/drawingml/2006/main" r:embed="R9c3c5621af0a43db"/>
+          <a:blip xmlns:r="http://schemas.openxmlformats.org/officeDocument/2006/relationships" xmlns:a="http://schemas.openxmlformats.org/drawingml/2006/main" r:embed="Re091ccaff45340b7"/>
           <a:stretch xmlns:a="http://schemas.openxmlformats.org/drawingml/2006/main">
             <a:fillRect l="0" t="0" r="0" b="0"/>
           </a:stretch>
@@ -4408,7 +4402,7 @@
           <p:nvPr/>
         </p:nvPicPr>
         <p:blipFill>
-          <a:blip xmlns:r="http://schemas.openxmlformats.org/officeDocument/2006/relationships" xmlns:a="http://schemas.openxmlformats.org/drawingml/2006/main" r:embed="Ra8489c1b2f014737"/>
+          <a:blip xmlns:r="http://schemas.openxmlformats.org/officeDocument/2006/relationships" xmlns:a="http://schemas.openxmlformats.org/drawingml/2006/main" r:embed="Rb65893441ee24064"/>
           <a:stretch xmlns:a="http://schemas.openxmlformats.org/drawingml/2006/main">
             <a:fillRect l="0" t="0" r="0" b="0"/>
           </a:stretch>
@@ -4589,7 +4583,7 @@
           <p:nvPr/>
         </p:nvPicPr>
         <p:blipFill>
-          <a:blip xmlns:r="http://schemas.openxmlformats.org/officeDocument/2006/relationships" xmlns:a="http://schemas.openxmlformats.org/drawingml/2006/main" r:embed="R79d7372ae4b4411e"/>
+          <a:blip xmlns:r="http://schemas.openxmlformats.org/officeDocument/2006/relationships" xmlns:a="http://schemas.openxmlformats.org/drawingml/2006/main" r:embed="R5b9dcd6e30244d1d"/>
           <a:stretch xmlns:a="http://schemas.openxmlformats.org/drawingml/2006/main">
             <a:fillRect l="0" t="0" r="0" b="0"/>
           </a:stretch>
@@ -4739,7 +4733,7 @@
                 <a:ea typeface="Arial"/>
                 <a:cs typeface="Arial"/>
               </a:rPr>
-              <a:t>SuperCheap.market  ·  working name</a:t>
+              <a:t>SuperCheap.market</a:t>
             </a:r>
             <a:endParaRPr sz="900"/>
           </a:p>
@@ -4800,14 +4794,11 @@
           <p:nvPr/>
         </p:nvPicPr>
         <p:blipFill>
-          <a:blip xmlns:r="http://schemas.openxmlformats.org/officeDocument/2006/relationships" xmlns:a="http://schemas.openxmlformats.org/drawingml/2006/main" r:embed="Rd107b91a326842b0">
-            <a:extLst>
-              <a:ext uri="{96DAC541-7B7A-43D3-8B79-37D633B846F1}">
-                <asvg:svgBlip xmlns:asvg="http://schemas.microsoft.com/office/drawing/2016/SVG/main" r:embed="R89edc59f12394a79"/>
-              </a:ext>
-            </a:extLst>
-          </a:blip>
-          <a:stretch xmlns:a="http://schemas.openxmlformats.org/drawingml/2006/main"/>
+          <a:blip xmlns:r="http://schemas.openxmlformats.org/officeDocument/2006/relationships" xmlns:a="http://schemas.openxmlformats.org/drawingml/2006/main" r:embed="Rd9b14779b7e84e9a"/>
+          <a:srcRect xmlns:a="http://schemas.openxmlformats.org/drawingml/2006/main" l="0" t="0" r="0" b="0"/>
+          <a:stretch xmlns:a="http://schemas.openxmlformats.org/drawingml/2006/main">
+            <a:fillRect l="0" t="0" r="0" b="0"/>
+          </a:stretch>
         </p:blipFill>
         <p:spPr>
           <a:xfrm xmlns:a="http://schemas.openxmlformats.org/drawingml/2006/main">
@@ -5109,7 +5100,7 @@
           <p:nvPr/>
         </p:nvPicPr>
         <p:blipFill>
-          <a:blip xmlns:r="http://schemas.openxmlformats.org/officeDocument/2006/relationships" xmlns:a="http://schemas.openxmlformats.org/drawingml/2006/main" r:embed="Re2a81b733a554240"/>
+          <a:blip xmlns:r="http://schemas.openxmlformats.org/officeDocument/2006/relationships" xmlns:a="http://schemas.openxmlformats.org/drawingml/2006/main" r:embed="Rd1077fb065104d8b"/>
           <a:stretch xmlns:a="http://schemas.openxmlformats.org/drawingml/2006/main">
             <a:fillRect l="0" t="0" r="0" b="0"/>
           </a:stretch>
@@ -5206,7 +5197,7 @@
           <p:nvPr/>
         </p:nvPicPr>
         <p:blipFill>
-          <a:blip xmlns:r="http://schemas.openxmlformats.org/officeDocument/2006/relationships" xmlns:a="http://schemas.openxmlformats.org/drawingml/2006/main" r:embed="Rb6ab1a05228046db"/>
+          <a:blip xmlns:r="http://schemas.openxmlformats.org/officeDocument/2006/relationships" xmlns:a="http://schemas.openxmlformats.org/drawingml/2006/main" r:embed="R473a42326e0b402c"/>
           <a:stretch xmlns:a="http://schemas.openxmlformats.org/drawingml/2006/main">
             <a:fillRect l="0" t="0" r="0" b="0"/>
           </a:stretch>
@@ -5303,7 +5294,7 @@
           <p:nvPr/>
         </p:nvPicPr>
         <p:blipFill>
-          <a:blip xmlns:r="http://schemas.openxmlformats.org/officeDocument/2006/relationships" xmlns:a="http://schemas.openxmlformats.org/drawingml/2006/main" r:embed="R719f0a7bbca04495"/>
+          <a:blip xmlns:r="http://schemas.openxmlformats.org/officeDocument/2006/relationships" xmlns:a="http://schemas.openxmlformats.org/drawingml/2006/main" r:embed="Rd1fd1061d4d9443f"/>
           <a:stretch xmlns:a="http://schemas.openxmlformats.org/drawingml/2006/main">
             <a:fillRect l="0" t="0" r="0" b="0"/>
           </a:stretch>
@@ -5400,7 +5391,7 @@
           <p:nvPr/>
         </p:nvPicPr>
         <p:blipFill>
-          <a:blip xmlns:r="http://schemas.openxmlformats.org/officeDocument/2006/relationships" xmlns:a="http://schemas.openxmlformats.org/drawingml/2006/main" r:embed="Rc7357d5525d34b9a"/>
+          <a:blip xmlns:r="http://schemas.openxmlformats.org/officeDocument/2006/relationships" xmlns:a="http://schemas.openxmlformats.org/drawingml/2006/main" r:embed="R861da4f874cf4a27"/>
           <a:stretch xmlns:a="http://schemas.openxmlformats.org/drawingml/2006/main">
             <a:fillRect l="0" t="0" r="0" b="0"/>
           </a:stretch>
@@ -5718,14 +5709,11 @@
           <p:nvPr/>
         </p:nvPicPr>
         <p:blipFill>
-          <a:blip xmlns:r="http://schemas.openxmlformats.org/officeDocument/2006/relationships" xmlns:a="http://schemas.openxmlformats.org/drawingml/2006/main" r:embed="R731ab5d22a7e487a">
-            <a:extLst>
-              <a:ext uri="{96DAC541-7B7A-43D3-8B79-37D633B846F1}">
-                <asvg:svgBlip xmlns:asvg="http://schemas.microsoft.com/office/drawing/2016/SVG/main" r:embed="R8b195ebb5a8a4b64"/>
-              </a:ext>
-            </a:extLst>
-          </a:blip>
-          <a:stretch xmlns:a="http://schemas.openxmlformats.org/drawingml/2006/main"/>
+          <a:blip xmlns:r="http://schemas.openxmlformats.org/officeDocument/2006/relationships" xmlns:a="http://schemas.openxmlformats.org/drawingml/2006/main" r:embed="Rb0aa7e38db994838"/>
+          <a:srcRect xmlns:a="http://schemas.openxmlformats.org/drawingml/2006/main" l="0" t="0" r="0" b="0"/>
+          <a:stretch xmlns:a="http://schemas.openxmlformats.org/drawingml/2006/main">
+            <a:fillRect l="0" t="0" r="0" b="0"/>
+          </a:stretch>
         </p:blipFill>
         <p:spPr>
           <a:xfrm xmlns:a="http://schemas.openxmlformats.org/drawingml/2006/main">
@@ -5982,7 +5970,7 @@
           <p:nvPr/>
         </p:nvPicPr>
         <p:blipFill>
-          <a:blip xmlns:r="http://schemas.openxmlformats.org/officeDocument/2006/relationships" xmlns:a="http://schemas.openxmlformats.org/drawingml/2006/main" r:embed="Ra76d5b2dd15a41cc"/>
+          <a:blip xmlns:r="http://schemas.openxmlformats.org/officeDocument/2006/relationships" xmlns:a="http://schemas.openxmlformats.org/drawingml/2006/main" r:embed="R98ded7a1693347db"/>
           <a:stretch xmlns:a="http://schemas.openxmlformats.org/drawingml/2006/main">
             <a:fillRect l="0" t="0" r="0" b="0"/>
           </a:stretch>
@@ -6164,7 +6152,7 @@
           <p:nvPr/>
         </p:nvPicPr>
         <p:blipFill>
-          <a:blip xmlns:r="http://schemas.openxmlformats.org/officeDocument/2006/relationships" xmlns:a="http://schemas.openxmlformats.org/drawingml/2006/main" r:embed="R85ef5ca6c79b4ba0"/>
+          <a:blip xmlns:r="http://schemas.openxmlformats.org/officeDocument/2006/relationships" xmlns:a="http://schemas.openxmlformats.org/drawingml/2006/main" r:embed="R628761ef604d4e6e"/>
           <a:stretch xmlns:a="http://schemas.openxmlformats.org/drawingml/2006/main">
             <a:fillRect l="0" t="0" r="0" b="0"/>
           </a:stretch>
@@ -6346,7 +6334,7 @@
           <p:nvPr/>
         </p:nvPicPr>
         <p:blipFill>
-          <a:blip xmlns:r="http://schemas.openxmlformats.org/officeDocument/2006/relationships" xmlns:a="http://schemas.openxmlformats.org/drawingml/2006/main" r:embed="Rd995a7f7b17a4d9f"/>
+          <a:blip xmlns:r="http://schemas.openxmlformats.org/officeDocument/2006/relationships" xmlns:a="http://schemas.openxmlformats.org/drawingml/2006/main" r:embed="R9d7871fb872b4911"/>
           <a:stretch xmlns:a="http://schemas.openxmlformats.org/drawingml/2006/main">
             <a:fillRect l="0" t="0" r="0" b="0"/>
           </a:stretch>
@@ -6528,7 +6516,7 @@
           <p:nvPr/>
         </p:nvPicPr>
         <p:blipFill>
-          <a:blip xmlns:r="http://schemas.openxmlformats.org/officeDocument/2006/relationships" xmlns:a="http://schemas.openxmlformats.org/drawingml/2006/main" r:embed="R1e8d9c94c7c04520"/>
+          <a:blip xmlns:r="http://schemas.openxmlformats.org/officeDocument/2006/relationships" xmlns:a="http://schemas.openxmlformats.org/drawingml/2006/main" r:embed="R8e667033792d4b43"/>
           <a:stretch xmlns:a="http://schemas.openxmlformats.org/drawingml/2006/main">
             <a:fillRect l="0" t="0" r="0" b="0"/>
           </a:stretch>
@@ -6678,7 +6666,7 @@
                 <a:ea typeface="Arial"/>
                 <a:cs typeface="Arial"/>
               </a:rPr>
-              <a:t>SuperCheap.market  ·  working name</a:t>
+              <a:t>SuperCheap.market</a:t>
             </a:r>
             <a:endParaRPr sz="900"/>
           </a:p>
@@ -6739,14 +6727,11 @@
           <p:nvPr/>
         </p:nvPicPr>
         <p:blipFill>
-          <a:blip xmlns:r="http://schemas.openxmlformats.org/officeDocument/2006/relationships" xmlns:a="http://schemas.openxmlformats.org/drawingml/2006/main" r:embed="Rb453a7ec93544071">
-            <a:extLst>
-              <a:ext uri="{96DAC541-7B7A-43D3-8B79-37D633B846F1}">
-                <asvg:svgBlip xmlns:asvg="http://schemas.microsoft.com/office/drawing/2016/SVG/main" r:embed="Rf8f06cd2b7de43a1"/>
-              </a:ext>
-            </a:extLst>
-          </a:blip>
-          <a:stretch xmlns:a="http://schemas.openxmlformats.org/drawingml/2006/main"/>
+          <a:blip xmlns:r="http://schemas.openxmlformats.org/officeDocument/2006/relationships" xmlns:a="http://schemas.openxmlformats.org/drawingml/2006/main" r:embed="R52d094ea0f344dd1"/>
+          <a:srcRect xmlns:a="http://schemas.openxmlformats.org/drawingml/2006/main" l="0" t="0" r="0" b="0"/>
+          <a:stretch xmlns:a="http://schemas.openxmlformats.org/drawingml/2006/main">
+            <a:fillRect l="0" t="0" r="0" b="0"/>
+          </a:stretch>
         </p:blipFill>
         <p:spPr>
           <a:xfrm xmlns:a="http://schemas.openxmlformats.org/drawingml/2006/main">
@@ -6954,7 +6939,7 @@
           <p:nvPr/>
         </p:nvPicPr>
         <p:blipFill>
-          <a:blip xmlns:r="http://schemas.openxmlformats.org/officeDocument/2006/relationships" xmlns:a="http://schemas.openxmlformats.org/drawingml/2006/main" r:embed="R1dbb4d713c304b15"/>
+          <a:blip xmlns:r="http://schemas.openxmlformats.org/officeDocument/2006/relationships" xmlns:a="http://schemas.openxmlformats.org/drawingml/2006/main" r:embed="R99399c3987024bf1"/>
           <a:stretch xmlns:a="http://schemas.openxmlformats.org/drawingml/2006/main">
             <a:fillRect l="0" t="0" r="0" b="0"/>
           </a:stretch>
@@ -7185,7 +7170,7 @@
           <p:nvPr/>
         </p:nvPicPr>
         <p:blipFill>
-          <a:blip xmlns:r="http://schemas.openxmlformats.org/officeDocument/2006/relationships" xmlns:a="http://schemas.openxmlformats.org/drawingml/2006/main" r:embed="Rf3b1a041613e47c4"/>
+          <a:blip xmlns:r="http://schemas.openxmlformats.org/officeDocument/2006/relationships" xmlns:a="http://schemas.openxmlformats.org/drawingml/2006/main" r:embed="R1fb7b1c70cd64b94"/>
           <a:stretch xmlns:a="http://schemas.openxmlformats.org/drawingml/2006/main">
             <a:fillRect l="0" t="0" r="0" b="0"/>
           </a:stretch>
@@ -7416,7 +7401,7 @@
           <p:nvPr/>
         </p:nvPicPr>
         <p:blipFill>
-          <a:blip xmlns:r="http://schemas.openxmlformats.org/officeDocument/2006/relationships" xmlns:a="http://schemas.openxmlformats.org/drawingml/2006/main" r:embed="Rb5d00ecd63d2407d"/>
+          <a:blip xmlns:r="http://schemas.openxmlformats.org/officeDocument/2006/relationships" xmlns:a="http://schemas.openxmlformats.org/drawingml/2006/main" r:embed="Ra8bf4f1d319a4928"/>
           <a:stretch xmlns:a="http://schemas.openxmlformats.org/drawingml/2006/main">
             <a:fillRect l="0" t="0" r="0" b="0"/>
           </a:stretch>
@@ -7647,7 +7632,7 @@
           <p:nvPr/>
         </p:nvPicPr>
         <p:blipFill>
-          <a:blip xmlns:r="http://schemas.openxmlformats.org/officeDocument/2006/relationships" xmlns:a="http://schemas.openxmlformats.org/drawingml/2006/main" r:embed="Rfac7c55b600b4685"/>
+          <a:blip xmlns:r="http://schemas.openxmlformats.org/officeDocument/2006/relationships" xmlns:a="http://schemas.openxmlformats.org/drawingml/2006/main" r:embed="R0bcb227240b1448a"/>
           <a:stretch xmlns:a="http://schemas.openxmlformats.org/drawingml/2006/main">
             <a:fillRect l="0" t="0" r="0" b="0"/>
           </a:stretch>
@@ -7892,7 +7877,7 @@
                 <a:ea typeface="Arial"/>
                 <a:cs typeface="Arial"/>
               </a:rPr>
-              <a:t>SuperCheap.market  ·  working name</a:t>
+              <a:t>SuperCheap.market</a:t>
             </a:r>
             <a:endParaRPr sz="900"/>
           </a:p>
@@ -7953,14 +7938,11 @@
           <p:nvPr/>
         </p:nvPicPr>
         <p:blipFill>
-          <a:blip xmlns:r="http://schemas.openxmlformats.org/officeDocument/2006/relationships" xmlns:a="http://schemas.openxmlformats.org/drawingml/2006/main" r:embed="R6757c1a950954242">
-            <a:extLst>
-              <a:ext uri="{96DAC541-7B7A-43D3-8B79-37D633B846F1}">
-                <asvg:svgBlip xmlns:asvg="http://schemas.microsoft.com/office/drawing/2016/SVG/main" r:embed="R579c97feefc7486b"/>
-              </a:ext>
-            </a:extLst>
-          </a:blip>
-          <a:stretch xmlns:a="http://schemas.openxmlformats.org/drawingml/2006/main"/>
+          <a:blip xmlns:r="http://schemas.openxmlformats.org/officeDocument/2006/relationships" xmlns:a="http://schemas.openxmlformats.org/drawingml/2006/main" r:embed="R7f7da08436324992"/>
+          <a:srcRect xmlns:a="http://schemas.openxmlformats.org/drawingml/2006/main" l="0" t="0" r="0" b="0"/>
+          <a:stretch xmlns:a="http://schemas.openxmlformats.org/drawingml/2006/main">
+            <a:fillRect l="0" t="0" r="0" b="0"/>
+          </a:stretch>
         </p:blipFill>
         <p:spPr>
           <a:xfrm xmlns:a="http://schemas.openxmlformats.org/drawingml/2006/main">
@@ -8213,7 +8195,7 @@
           <p:nvPr/>
         </p:nvPicPr>
         <p:blipFill>
-          <a:blip xmlns:r="http://schemas.openxmlformats.org/officeDocument/2006/relationships" xmlns:a="http://schemas.openxmlformats.org/drawingml/2006/main" r:embed="R178bfee0a21243c1"/>
+          <a:blip xmlns:r="http://schemas.openxmlformats.org/officeDocument/2006/relationships" xmlns:a="http://schemas.openxmlformats.org/drawingml/2006/main" r:embed="Rdf57adc076294592"/>
           <a:stretch xmlns:a="http://schemas.openxmlformats.org/drawingml/2006/main">
             <a:fillRect l="0" t="0" r="0" b="0"/>
           </a:stretch>
@@ -8397,7 +8379,7 @@
           <p:nvPr/>
         </p:nvPicPr>
         <p:blipFill>
-          <a:blip xmlns:r="http://schemas.openxmlformats.org/officeDocument/2006/relationships" xmlns:a="http://schemas.openxmlformats.org/drawingml/2006/main" r:embed="R0ccb6df5884e4afe"/>
+          <a:blip xmlns:r="http://schemas.openxmlformats.org/officeDocument/2006/relationships" xmlns:a="http://schemas.openxmlformats.org/drawingml/2006/main" r:embed="R5bae27577d9b48b4"/>
           <a:stretch xmlns:a="http://schemas.openxmlformats.org/drawingml/2006/main">
             <a:fillRect l="0" t="0" r="0" b="0"/>
           </a:stretch>
@@ -8581,7 +8563,7 @@
           <p:nvPr/>
         </p:nvPicPr>
         <p:blipFill>
-          <a:blip xmlns:r="http://schemas.openxmlformats.org/officeDocument/2006/relationships" xmlns:a="http://schemas.openxmlformats.org/drawingml/2006/main" r:embed="Rdf66342b608c4caf"/>
+          <a:blip xmlns:r="http://schemas.openxmlformats.org/officeDocument/2006/relationships" xmlns:a="http://schemas.openxmlformats.org/drawingml/2006/main" r:embed="Rec064e5243694319"/>
           <a:stretch xmlns:a="http://schemas.openxmlformats.org/drawingml/2006/main">
             <a:fillRect l="0" t="0" r="0" b="0"/>
           </a:stretch>
@@ -8780,7 +8762,7 @@
                 <a:ea typeface="Arial"/>
                 <a:cs typeface="Arial"/>
               </a:rPr>
-              <a:t>SuperCheap.market  ·  working name</a:t>
+              <a:t>SuperCheap.market</a:t>
             </a:r>
             <a:endParaRPr sz="900"/>
           </a:p>
@@ -8841,14 +8823,11 @@
           <p:nvPr/>
         </p:nvPicPr>
         <p:blipFill>
-          <a:blip xmlns:r="http://schemas.openxmlformats.org/officeDocument/2006/relationships" xmlns:a="http://schemas.openxmlformats.org/drawingml/2006/main" r:embed="R41c3534e92154568">
-            <a:extLst>
-              <a:ext uri="{96DAC541-7B7A-43D3-8B79-37D633B846F1}">
-                <asvg:svgBlip xmlns:asvg="http://schemas.microsoft.com/office/drawing/2016/SVG/main" r:embed="R04c809798c1a410a"/>
-              </a:ext>
-            </a:extLst>
-          </a:blip>
-          <a:stretch xmlns:a="http://schemas.openxmlformats.org/drawingml/2006/main"/>
+          <a:blip xmlns:r="http://schemas.openxmlformats.org/officeDocument/2006/relationships" xmlns:a="http://schemas.openxmlformats.org/drawingml/2006/main" r:embed="R0196ccb91afa4911"/>
+          <a:srcRect xmlns:a="http://schemas.openxmlformats.org/drawingml/2006/main" l="0" t="0" r="0" b="0"/>
+          <a:stretch xmlns:a="http://schemas.openxmlformats.org/drawingml/2006/main">
+            <a:fillRect l="0" t="0" r="0" b="0"/>
+          </a:stretch>
         </p:blipFill>
         <p:spPr>
           <a:xfrm xmlns:a="http://schemas.openxmlformats.org/drawingml/2006/main">
@@ -9056,7 +9035,7 @@
           <p:nvPr/>
         </p:nvPicPr>
         <p:blipFill>
-          <a:blip xmlns:r="http://schemas.openxmlformats.org/officeDocument/2006/relationships" xmlns:a="http://schemas.openxmlformats.org/drawingml/2006/main" r:embed="Rf2e2b980559346f0"/>
+          <a:blip xmlns:r="http://schemas.openxmlformats.org/officeDocument/2006/relationships" xmlns:a="http://schemas.openxmlformats.org/drawingml/2006/main" r:embed="R729dd056940148e4"/>
           <a:stretch xmlns:a="http://schemas.openxmlformats.org/drawingml/2006/main">
             <a:fillRect l="0" t="0" r="0" b="0"/>
           </a:stretch>
@@ -9241,7 +9220,7 @@
           <p:nvPr/>
         </p:nvPicPr>
         <p:blipFill>
-          <a:blip xmlns:r="http://schemas.openxmlformats.org/officeDocument/2006/relationships" xmlns:a="http://schemas.openxmlformats.org/drawingml/2006/main" r:embed="Rf8d17968eaca4850"/>
+          <a:blip xmlns:r="http://schemas.openxmlformats.org/officeDocument/2006/relationships" xmlns:a="http://schemas.openxmlformats.org/drawingml/2006/main" r:embed="R5cf9697f03904a2c"/>
           <a:stretch xmlns:a="http://schemas.openxmlformats.org/drawingml/2006/main">
             <a:fillRect l="0" t="0" r="0" b="0"/>
           </a:stretch>
@@ -9426,7 +9405,7 @@
           <p:nvPr/>
         </p:nvPicPr>
         <p:blipFill>
-          <a:blip xmlns:r="http://schemas.openxmlformats.org/officeDocument/2006/relationships" xmlns:a="http://schemas.openxmlformats.org/drawingml/2006/main" r:embed="R1a6c51682fba46d0"/>
+          <a:blip xmlns:r="http://schemas.openxmlformats.org/officeDocument/2006/relationships" xmlns:a="http://schemas.openxmlformats.org/drawingml/2006/main" r:embed="R81fa9fa31ef94ebd"/>
           <a:stretch xmlns:a="http://schemas.openxmlformats.org/drawingml/2006/main">
             <a:fillRect l="0" t="0" r="0" b="0"/>
           </a:stretch>
@@ -9611,7 +9590,7 @@
           <p:nvPr/>
         </p:nvPicPr>
         <p:blipFill>
-          <a:blip xmlns:r="http://schemas.openxmlformats.org/officeDocument/2006/relationships" xmlns:a="http://schemas.openxmlformats.org/drawingml/2006/main" r:embed="R6c170fc49fb4429b"/>
+          <a:blip xmlns:r="http://schemas.openxmlformats.org/officeDocument/2006/relationships" xmlns:a="http://schemas.openxmlformats.org/drawingml/2006/main" r:embed="Rcdd01ed458314f49"/>
           <a:stretch xmlns:a="http://schemas.openxmlformats.org/drawingml/2006/main">
             <a:fillRect l="0" t="0" r="0" b="0"/>
           </a:stretch>
@@ -9796,7 +9775,7 @@
           <p:nvPr/>
         </p:nvPicPr>
         <p:blipFill>
-          <a:blip xmlns:r="http://schemas.openxmlformats.org/officeDocument/2006/relationships" xmlns:a="http://schemas.openxmlformats.org/drawingml/2006/main" r:embed="R897e7cc7adc14e4a"/>
+          <a:blip xmlns:r="http://schemas.openxmlformats.org/officeDocument/2006/relationships" xmlns:a="http://schemas.openxmlformats.org/drawingml/2006/main" r:embed="R08ee47dba8c04eca"/>
           <a:stretch xmlns:a="http://schemas.openxmlformats.org/drawingml/2006/main">
             <a:fillRect l="0" t="0" r="0" b="0"/>
           </a:stretch>
@@ -9981,7 +9960,7 @@
           <p:nvPr/>
         </p:nvPicPr>
         <p:blipFill>
-          <a:blip xmlns:r="http://schemas.openxmlformats.org/officeDocument/2006/relationships" xmlns:a="http://schemas.openxmlformats.org/drawingml/2006/main" r:embed="R965d50074af24c4d"/>
+          <a:blip xmlns:r="http://schemas.openxmlformats.org/officeDocument/2006/relationships" xmlns:a="http://schemas.openxmlformats.org/drawingml/2006/main" r:embed="R7b1e7726f80a41b5"/>
           <a:stretch xmlns:a="http://schemas.openxmlformats.org/drawingml/2006/main">
             <a:fillRect l="0" t="0" r="0" b="0"/>
           </a:stretch>
@@ -10180,7 +10159,7 @@
                 <a:ea typeface="Arial"/>
                 <a:cs typeface="Arial"/>
               </a:rPr>
-              <a:t>SuperCheap.market  ·  working name</a:t>
+              <a:t>SuperCheap.market</a:t>
             </a:r>
             <a:endParaRPr sz="900"/>
           </a:p>
@@ -10241,14 +10220,11 @@
           <p:nvPr/>
         </p:nvPicPr>
         <p:blipFill>
-          <a:blip xmlns:r="http://schemas.openxmlformats.org/officeDocument/2006/relationships" xmlns:a="http://schemas.openxmlformats.org/drawingml/2006/main" r:embed="R3a8e7dc966e74492">
-            <a:extLst>
-              <a:ext uri="{96DAC541-7B7A-43D3-8B79-37D633B846F1}">
-                <asvg:svgBlip xmlns:asvg="http://schemas.microsoft.com/office/drawing/2016/SVG/main" r:embed="R98578ce354e34941"/>
-              </a:ext>
-            </a:extLst>
-          </a:blip>
-          <a:stretch xmlns:a="http://schemas.openxmlformats.org/drawingml/2006/main"/>
+          <a:blip xmlns:r="http://schemas.openxmlformats.org/officeDocument/2006/relationships" xmlns:a="http://schemas.openxmlformats.org/drawingml/2006/main" r:embed="Rea01bda046b6457c"/>
+          <a:srcRect xmlns:a="http://schemas.openxmlformats.org/drawingml/2006/main" l="0" t="0" r="0" b="0"/>
+          <a:stretch xmlns:a="http://schemas.openxmlformats.org/drawingml/2006/main">
+            <a:fillRect l="0" t="0" r="0" b="0"/>
+          </a:stretch>
         </p:blipFill>
         <p:spPr>
           <a:xfrm xmlns:a="http://schemas.openxmlformats.org/drawingml/2006/main">
@@ -10502,7 +10478,7 @@
           <p:nvPr/>
         </p:nvPicPr>
         <p:blipFill>
-          <a:blip xmlns:r="http://schemas.openxmlformats.org/officeDocument/2006/relationships" xmlns:a="http://schemas.openxmlformats.org/drawingml/2006/main" r:embed="R1728260ba9b147f6"/>
+          <a:blip xmlns:r="http://schemas.openxmlformats.org/officeDocument/2006/relationships" xmlns:a="http://schemas.openxmlformats.org/drawingml/2006/main" r:embed="R24d8c5bfcc45434b"/>
           <a:stretch xmlns:a="http://schemas.openxmlformats.org/drawingml/2006/main">
             <a:fillRect l="0" t="0" r="0" b="0"/>
           </a:stretch>
@@ -10621,7 +10597,7 @@
           <p:nvPr/>
         </p:nvPicPr>
         <p:blipFill>
-          <a:blip xmlns:r="http://schemas.openxmlformats.org/officeDocument/2006/relationships" xmlns:a="http://schemas.openxmlformats.org/drawingml/2006/main" r:embed="R7b446f7b64fc4251"/>
+          <a:blip xmlns:r="http://schemas.openxmlformats.org/officeDocument/2006/relationships" xmlns:a="http://schemas.openxmlformats.org/drawingml/2006/main" r:embed="Rc02fb1cbf5ba4df0"/>
           <a:stretch xmlns:a="http://schemas.openxmlformats.org/drawingml/2006/main">
             <a:fillRect l="0" t="0" r="0" b="0"/>
           </a:stretch>
@@ -10754,7 +10730,7 @@
           <p:nvPr/>
         </p:nvPicPr>
         <p:blipFill>
-          <a:blip xmlns:r="http://schemas.openxmlformats.org/officeDocument/2006/relationships" xmlns:a="http://schemas.openxmlformats.org/drawingml/2006/main" r:embed="R36c7ff626a41483e"/>
+          <a:blip xmlns:r="http://schemas.openxmlformats.org/officeDocument/2006/relationships" xmlns:a="http://schemas.openxmlformats.org/drawingml/2006/main" r:embed="Rb41d1a77bc1746a3"/>
           <a:stretch xmlns:a="http://schemas.openxmlformats.org/drawingml/2006/main">
             <a:fillRect l="0" t="0" r="0" b="0"/>
           </a:stretch>
@@ -10873,7 +10849,7 @@
           <p:nvPr/>
         </p:nvPicPr>
         <p:blipFill>
-          <a:blip xmlns:r="http://schemas.openxmlformats.org/officeDocument/2006/relationships" xmlns:a="http://schemas.openxmlformats.org/drawingml/2006/main" r:embed="Rce66528f7cd14f49"/>
+          <a:blip xmlns:r="http://schemas.openxmlformats.org/officeDocument/2006/relationships" xmlns:a="http://schemas.openxmlformats.org/drawingml/2006/main" r:embed="Rbe6d6ec917e44aaa"/>
           <a:stretch xmlns:a="http://schemas.openxmlformats.org/drawingml/2006/main">
             <a:fillRect l="0" t="0" r="0" b="0"/>
           </a:stretch>
@@ -11006,7 +10982,7 @@
           <p:nvPr/>
         </p:nvPicPr>
         <p:blipFill>
-          <a:blip xmlns:r="http://schemas.openxmlformats.org/officeDocument/2006/relationships" xmlns:a="http://schemas.openxmlformats.org/drawingml/2006/main" r:embed="R76f26c3357ef4fdf"/>
+          <a:blip xmlns:r="http://schemas.openxmlformats.org/officeDocument/2006/relationships" xmlns:a="http://schemas.openxmlformats.org/drawingml/2006/main" r:embed="R059f1013099e4d82"/>
           <a:stretch xmlns:a="http://schemas.openxmlformats.org/drawingml/2006/main">
             <a:fillRect l="0" t="0" r="0" b="0"/>
           </a:stretch>
@@ -11125,7 +11101,7 @@
           <p:nvPr/>
         </p:nvPicPr>
         <p:blipFill>
-          <a:blip xmlns:r="http://schemas.openxmlformats.org/officeDocument/2006/relationships" xmlns:a="http://schemas.openxmlformats.org/drawingml/2006/main" r:embed="R656e4936a1314bb7"/>
+          <a:blip xmlns:r="http://schemas.openxmlformats.org/officeDocument/2006/relationships" xmlns:a="http://schemas.openxmlformats.org/drawingml/2006/main" r:embed="R037844a40ad348d4"/>
           <a:stretch xmlns:a="http://schemas.openxmlformats.org/drawingml/2006/main">
             <a:fillRect l="0" t="0" r="0" b="0"/>
           </a:stretch>
@@ -11258,7 +11234,7 @@
           <p:nvPr/>
         </p:nvPicPr>
         <p:blipFill>
-          <a:blip xmlns:r="http://schemas.openxmlformats.org/officeDocument/2006/relationships" xmlns:a="http://schemas.openxmlformats.org/drawingml/2006/main" r:embed="R431e9ecf72dc405c"/>
+          <a:blip xmlns:r="http://schemas.openxmlformats.org/officeDocument/2006/relationships" xmlns:a="http://schemas.openxmlformats.org/drawingml/2006/main" r:embed="Re55ed6681e784613"/>
           <a:stretch xmlns:a="http://schemas.openxmlformats.org/drawingml/2006/main">
             <a:fillRect l="0" t="0" r="0" b="0"/>
           </a:stretch>
@@ -11377,7 +11353,7 @@
           <p:nvPr/>
         </p:nvPicPr>
         <p:blipFill>
-          <a:blip xmlns:r="http://schemas.openxmlformats.org/officeDocument/2006/relationships" xmlns:a="http://schemas.openxmlformats.org/drawingml/2006/main" r:embed="Rb8585783db704b77"/>
+          <a:blip xmlns:r="http://schemas.openxmlformats.org/officeDocument/2006/relationships" xmlns:a="http://schemas.openxmlformats.org/drawingml/2006/main" r:embed="R1fcca46f17994b39"/>
           <a:stretch xmlns:a="http://schemas.openxmlformats.org/drawingml/2006/main">
             <a:fillRect l="0" t="0" r="0" b="0"/>
           </a:stretch>
@@ -11510,7 +11486,7 @@
           <p:nvPr/>
         </p:nvPicPr>
         <p:blipFill>
-          <a:blip xmlns:r="http://schemas.openxmlformats.org/officeDocument/2006/relationships" xmlns:a="http://schemas.openxmlformats.org/drawingml/2006/main" r:embed="Ra0d44aba6a7644f2"/>
+          <a:blip xmlns:r="http://schemas.openxmlformats.org/officeDocument/2006/relationships" xmlns:a="http://schemas.openxmlformats.org/drawingml/2006/main" r:embed="Rfe7ebe1e42224154"/>
           <a:stretch xmlns:a="http://schemas.openxmlformats.org/drawingml/2006/main">
             <a:fillRect l="0" t="0" r="0" b="0"/>
           </a:stretch>
@@ -11706,7 +11682,7 @@
                 <a:ea typeface="Arial"/>
                 <a:cs typeface="Arial"/>
               </a:rPr>
-              <a:t>SuperCheap.market  ·  working name</a:t>
+              <a:t>SuperCheap.market</a:t>
             </a:r>
             <a:endParaRPr sz="900"/>
           </a:p>
@@ -11767,14 +11743,11 @@
           <p:nvPr/>
         </p:nvPicPr>
         <p:blipFill>
-          <a:blip xmlns:r="http://schemas.openxmlformats.org/officeDocument/2006/relationships" xmlns:a="http://schemas.openxmlformats.org/drawingml/2006/main" r:embed="Rb0409d0c98a946d9">
-            <a:extLst>
-              <a:ext uri="{96DAC541-7B7A-43D3-8B79-37D633B846F1}">
-                <asvg:svgBlip xmlns:asvg="http://schemas.microsoft.com/office/drawing/2016/SVG/main" r:embed="Rad761889898f478f"/>
-              </a:ext>
-            </a:extLst>
-          </a:blip>
-          <a:stretch xmlns:a="http://schemas.openxmlformats.org/drawingml/2006/main"/>
+          <a:blip xmlns:r="http://schemas.openxmlformats.org/officeDocument/2006/relationships" xmlns:a="http://schemas.openxmlformats.org/drawingml/2006/main" r:embed="R4d978160def348c7"/>
+          <a:srcRect xmlns:a="http://schemas.openxmlformats.org/drawingml/2006/main" l="0" t="0" r="0" b="0"/>
+          <a:stretch xmlns:a="http://schemas.openxmlformats.org/drawingml/2006/main">
+            <a:fillRect l="0" t="0" r="0" b="0"/>
+          </a:stretch>
         </p:blipFill>
         <p:spPr>
           <a:xfrm xmlns:a="http://schemas.openxmlformats.org/drawingml/2006/main">
@@ -12049,7 +12022,7 @@
           <p:nvPr/>
         </p:nvPicPr>
         <p:blipFill>
-          <a:blip xmlns:r="http://schemas.openxmlformats.org/officeDocument/2006/relationships" xmlns:a="http://schemas.openxmlformats.org/drawingml/2006/main" r:embed="Ra79716b8e20344be"/>
+          <a:blip xmlns:r="http://schemas.openxmlformats.org/officeDocument/2006/relationships" xmlns:a="http://schemas.openxmlformats.org/drawingml/2006/main" r:embed="R6f74f3d91b6f4535"/>
           <a:stretch xmlns:a="http://schemas.openxmlformats.org/drawingml/2006/main">
             <a:fillRect l="0" t="0" r="0" b="0"/>
           </a:stretch>
@@ -12259,7 +12232,7 @@
           <p:nvPr/>
         </p:nvPicPr>
         <p:blipFill>
-          <a:blip xmlns:r="http://schemas.openxmlformats.org/officeDocument/2006/relationships" xmlns:a="http://schemas.openxmlformats.org/drawingml/2006/main" r:embed="R67861b5465054593"/>
+          <a:blip xmlns:r="http://schemas.openxmlformats.org/officeDocument/2006/relationships" xmlns:a="http://schemas.openxmlformats.org/drawingml/2006/main" r:embed="Rfcad8127cdad4569"/>
           <a:stretch xmlns:a="http://schemas.openxmlformats.org/drawingml/2006/main">
             <a:fillRect l="0" t="0" r="0" b="0"/>
           </a:stretch>
@@ -12374,7 +12347,7 @@
                 <a:ea typeface="Arial"/>
                 <a:cs typeface="Arial"/>
               </a:rPr>
-              <a:t>SuperCheap.market  ·  working name</a:t>
+              <a:t>SuperCheap.market</a:t>
             </a:r>
             <a:endParaRPr sz="900"/>
           </a:p>
@@ -12435,14 +12408,11 @@
           <p:nvPr/>
         </p:nvPicPr>
         <p:blipFill>
-          <a:blip xmlns:r="http://schemas.openxmlformats.org/officeDocument/2006/relationships" xmlns:a="http://schemas.openxmlformats.org/drawingml/2006/main" r:embed="Rea87adb2105b4c0a">
-            <a:extLst>
-              <a:ext uri="{96DAC541-7B7A-43D3-8B79-37D633B846F1}">
-                <asvg:svgBlip xmlns:asvg="http://schemas.microsoft.com/office/drawing/2016/SVG/main" r:embed="R14fc18f28b254cb7"/>
-              </a:ext>
-            </a:extLst>
-          </a:blip>
-          <a:stretch xmlns:a="http://schemas.openxmlformats.org/drawingml/2006/main"/>
+          <a:blip xmlns:r="http://schemas.openxmlformats.org/officeDocument/2006/relationships" xmlns:a="http://schemas.openxmlformats.org/drawingml/2006/main" r:embed="R2e5d3fe0bb624509"/>
+          <a:srcRect xmlns:a="http://schemas.openxmlformats.org/drawingml/2006/main" l="0" t="0" r="0" b="0"/>
+          <a:stretch xmlns:a="http://schemas.openxmlformats.org/drawingml/2006/main">
+            <a:fillRect l="0" t="0" r="0" b="0"/>
+          </a:stretch>
         </p:blipFill>
         <p:spPr>
           <a:xfrm xmlns:a="http://schemas.openxmlformats.org/drawingml/2006/main">
@@ -12622,7 +12592,7 @@
           <p:nvPr/>
         </p:nvPicPr>
         <p:blipFill>
-          <a:blip xmlns:r="http://schemas.openxmlformats.org/officeDocument/2006/relationships" xmlns:a="http://schemas.openxmlformats.org/drawingml/2006/main" r:embed="R459c10cc92a6439b"/>
+          <a:blip xmlns:r="http://schemas.openxmlformats.org/officeDocument/2006/relationships" xmlns:a="http://schemas.openxmlformats.org/drawingml/2006/main" r:embed="Ra0bd9e8004b04273"/>
           <a:stretch xmlns:a="http://schemas.openxmlformats.org/drawingml/2006/main">
             <a:fillRect l="0" t="0" r="0" b="0"/>
           </a:stretch>
@@ -13807,7 +13777,7 @@
                 <a:ea typeface="Arial"/>
                 <a:cs typeface="Arial"/>
               </a:rPr>
-              <a:t>SuperCheap.market  ·  working name</a:t>
+              <a:t>SuperCheap.market</a:t>
             </a:r>
             <a:endParaRPr sz="900"/>
           </a:p>
@@ -13868,14 +13838,11 @@
           <p:nvPr/>
         </p:nvPicPr>
         <p:blipFill>
-          <a:blip xmlns:r="http://schemas.openxmlformats.org/officeDocument/2006/relationships" xmlns:a="http://schemas.openxmlformats.org/drawingml/2006/main" r:embed="Ra2cd6554af7c49c0">
-            <a:extLst>
-              <a:ext uri="{96DAC541-7B7A-43D3-8B79-37D633B846F1}">
-                <asvg:svgBlip xmlns:asvg="http://schemas.microsoft.com/office/drawing/2016/SVG/main" r:embed="Re2dbabcd81504355"/>
-              </a:ext>
-            </a:extLst>
-          </a:blip>
-          <a:stretch xmlns:a="http://schemas.openxmlformats.org/drawingml/2006/main"/>
+          <a:blip xmlns:r="http://schemas.openxmlformats.org/officeDocument/2006/relationships" xmlns:a="http://schemas.openxmlformats.org/drawingml/2006/main" r:embed="R169b70f9c53341b0"/>
+          <a:srcRect xmlns:a="http://schemas.openxmlformats.org/drawingml/2006/main" l="0" t="0" r="0" b="0"/>
+          <a:stretch xmlns:a="http://schemas.openxmlformats.org/drawingml/2006/main">
+            <a:fillRect l="0" t="0" r="0" b="0"/>
+          </a:stretch>
         </p:blipFill>
         <p:spPr>
           <a:xfrm xmlns:a="http://schemas.openxmlformats.org/drawingml/2006/main">
@@ -15055,7 +15022,7 @@
                 <a:ea typeface="Arial"/>
                 <a:cs typeface="Arial"/>
               </a:rPr>
-              <a:t>SuperCheap.market  ·  working name</a:t>
+              <a:t>SuperCheap.market</a:t>
             </a:r>
             <a:endParaRPr sz="900"/>
           </a:p>
@@ -15116,14 +15083,11 @@
           <p:nvPr/>
         </p:nvPicPr>
         <p:blipFill>
-          <a:blip xmlns:r="http://schemas.openxmlformats.org/officeDocument/2006/relationships" xmlns:a="http://schemas.openxmlformats.org/drawingml/2006/main" r:embed="Rd24272a0c12646e5">
-            <a:extLst>
-              <a:ext uri="{96DAC541-7B7A-43D3-8B79-37D633B846F1}">
-                <asvg:svgBlip xmlns:asvg="http://schemas.microsoft.com/office/drawing/2016/SVG/main" r:embed="R102cb29bb06f41a8"/>
-              </a:ext>
-            </a:extLst>
-          </a:blip>
-          <a:stretch xmlns:a="http://schemas.openxmlformats.org/drawingml/2006/main"/>
+          <a:blip xmlns:r="http://schemas.openxmlformats.org/officeDocument/2006/relationships" xmlns:a="http://schemas.openxmlformats.org/drawingml/2006/main" r:embed="R836f981b141e487b"/>
+          <a:srcRect xmlns:a="http://schemas.openxmlformats.org/drawingml/2006/main" l="0" t="0" r="0" b="0"/>
+          <a:stretch xmlns:a="http://schemas.openxmlformats.org/drawingml/2006/main">
+            <a:fillRect l="0" t="0" r="0" b="0"/>
+          </a:stretch>
         </p:blipFill>
         <p:spPr>
           <a:xfrm xmlns:a="http://schemas.openxmlformats.org/drawingml/2006/main">

</xml_diff>